<commit_message>
CMA scatter: comps-first legend and a takeaway box for the size-only line
- Legend: Comparable Sales (matched to the comp cards by street address), Other
  Sales, For Sale Now, trend and the subject. Replaces the renovated / other pool /
  no pool split and drops scatter.renovated. Empty series are left out of the legend
  in the PDF and the listing presentation.
- Exclusions: one muted line with the count, no per-home list.
- Takeaway box under the chart: a headline with where the home sits against the
  size-only line and by how much, what the line means, and an icon that draws the
  same thing. The deck's trend note gives the same gap.
- New print-light exception (CLAUDE.md, docs/architecture.md): one tinted takeaway
  box per chart; outlined boxes with no fill are allowed.
- Examples, sample inputs and references updated; samples regenerated.

Co-Authored-By: Claude Opus 5.5 <noreply@anthropic.com>
</commit_message>
<xml_diff>
--- a/samples/seller-cma/517-Larkwood-Ave-Listing-Presentation.pptx
+++ b/samples/seller-cma/517-Larkwood-Ave-Listing-Presentation.pptx
@@ -141,7 +141,7 @@
               <c:strCache>
                 <c:ptCount val="1"/>
                 <c:pt idx="0">
-                  <c:v>Renovated Pool Home (Sold)</c:v>
+                  <c:v>Comparable Sales</c:v>
                 </c:pt>
               </c:strCache>
             </c:strRef>
@@ -182,97 +182,97 @@
                   <c:v>1865</c:v>
                 </c:pt>
                 <c:pt idx="2">
+                  <c:v>1871</c:v>
+                </c:pt>
+                <c:pt idx="3">
+                  <c:v>1849</c:v>
+                </c:pt>
+                <c:pt idx="4">
                   <c:v>1865</c:v>
                 </c:pt>
-                <c:pt idx="3">
+                <c:pt idx="5">
+                  <c:v>1790</c:v>
+                </c:pt>
+                <c:pt idx="6">
+                  <c:v>1810</c:v>
+                </c:pt>
+                <c:pt idx="7">
                   <c:v>1702</c:v>
                 </c:pt>
-                <c:pt idx="4">
-                  <c:v>1871</c:v>
-                </c:pt>
-                <c:pt idx="5">
-                  <c:v>1849</c:v>
-                </c:pt>
-                <c:pt idx="6">
-                  <c:v>1790</c:v>
-                </c:pt>
-                <c:pt idx="7">
+                <c:pt idx="8">
+                  <c:v>1880</c:v>
+                </c:pt>
+                <c:pt idx="9">
                   <c:v>2260</c:v>
-                </c:pt>
-                <c:pt idx="8">
-                  <c:v>2150</c:v>
-                </c:pt>
-                <c:pt idx="9">
-                  <c:v>1880</c:v>
                 </c:pt>
                 <c:pt idx="10">
                   <c:v>1950</c:v>
                 </c:pt>
                 <c:pt idx="11">
-                  <c:v>1450</c:v>
+                  <c:v>2380</c:v>
                 </c:pt>
                 <c:pt idx="12">
                   <c:v>2150</c:v>
                 </c:pt>
                 <c:pt idx="13">
-                  <c:v>2260</c:v>
+                  <c:v>2380</c:v>
                 </c:pt>
                 <c:pt idx="14">
-                  <c:v>2380</c:v>
+                  <c:v>1740</c:v>
                 </c:pt>
                 <c:pt idx="15">
+                  <c:v>1880</c:v>
+                </c:pt>
+                <c:pt idx="16">
+                  <c:v>1950</c:v>
+                </c:pt>
+                <c:pt idx="17">
                   <c:v>1740</c:v>
                 </c:pt>
-                <c:pt idx="16">
+                <c:pt idx="18">
                   <c:v>1450</c:v>
                 </c:pt>
-                <c:pt idx="17">
-                  <c:v>1610</c:v>
-                </c:pt>
-                <c:pt idx="18">
-                  <c:v>1820</c:v>
-                </c:pt>
                 <c:pt idx="19">
-                  <c:v>1880</c:v>
+                  <c:v>2150</c:v>
                 </c:pt>
                 <c:pt idx="20">
                   <c:v>2380</c:v>
                 </c:pt>
                 <c:pt idx="21">
-                  <c:v>1810</c:v>
+                  <c:v>2260</c:v>
                 </c:pt>
                 <c:pt idx="22">
+                  <c:v>2380</c:v>
+                </c:pt>
+                <c:pt idx="23">
+                  <c:v>1740</c:v>
+                </c:pt>
+                <c:pt idx="24">
+                  <c:v>1450</c:v>
+                </c:pt>
+                <c:pt idx="25">
+                  <c:v>1610</c:v>
+                </c:pt>
+                <c:pt idx="26">
+                  <c:v>2380</c:v>
+                </c:pt>
+                <c:pt idx="27">
+                  <c:v>1820</c:v>
+                </c:pt>
+                <c:pt idx="28">
                   <c:v>1880</c:v>
                 </c:pt>
-                <c:pt idx="23">
-                  <c:v>1950</c:v>
-                </c:pt>
-                <c:pt idx="24">
+                <c:pt idx="29">
+                  <c:v>2040</c:v>
+                </c:pt>
+                <c:pt idx="30">
                   <c:v>2380</c:v>
                 </c:pt>
-                <c:pt idx="25">
+                <c:pt idx="31">
+                  <c:v>1610</c:v>
+                </c:pt>
+                <c:pt idx="32">
                   <c:v>2380</c:v>
-                </c:pt>
-                <c:pt idx="26">
-                  <c:v>1740</c:v>
-                </c:pt>
-                <c:pt idx="27">
-                  <c:v>1740</c:v>
-                </c:pt>
-                <c:pt idx="28">
-                  <c:v>2380</c:v>
-                </c:pt>
-                <c:pt idx="29">
-                  <c:v>2380</c:v>
-                </c:pt>
-                <c:pt idx="30">
-                  <c:v>2040</c:v>
-                </c:pt>
-                <c:pt idx="31">
-                  <c:v>2380</c:v>
-                </c:pt>
-                <c:pt idx="32">
-                  <c:v>1610</c:v>
                 </c:pt>
                 <c:pt idx="33">
                   <c:v>1849</c:v>
@@ -416,13 +416,13 @@
                   <c:v>495000</c:v>
                 </c:pt>
                 <c:pt idx="2">
+                  <c:v>427000</c:v>
+                </c:pt>
+                <c:pt idx="3">
+                  <c:v>429000</c:v>
+                </c:pt>
+                <c:pt idx="4">
                   <c:v>465000</c:v>
-                </c:pt>
-                <c:pt idx="3">
-                  <c:v>470000</c:v>
-                </c:pt>
-                <c:pt idx="4">
-                  <c:v/>
                 </c:pt>
                 <c:pt idx="5">
                   <c:v/>
@@ -648,514 +648,7 @@
               <c:strCache>
                 <c:ptCount val="1"/>
                 <c:pt idx="0">
-                  <c:v>Other Pool Home (Sold)</c:v>
-                </c:pt>
-              </c:strCache>
-            </c:strRef>
-          </c:tx>
-          <c:spPr>
-            <a:solidFill>
-              <a:srgbClr val="DD9577"/>
-            </a:solidFill>
-            <a:ln>
-              <a:noFill/>
-            </a:ln>
-            <a:effectLst/>
-          </c:spPr>
-          <c:marker>
-            <c:symbol val="triangle"/>
-            <c:size val="8"/>
-            <c:spPr>
-              <a:solidFill>
-                <a:srgbClr val="DD9577"/>
-              </a:solidFill>
-              <a:ln w="9525">
-                <a:solidFill>
-                  <a:srgbClr val="DD9577"/>
-                </a:solidFill>
-              </a:ln>
-            </c:spPr>
-          </c:marker>
-          <c:xVal>
-            <c:numRef>
-              <c:f>Sheet1!$A$2:$A$76</c:f>
-              <c:numCache>
-                <c:formatCode>General</c:formatCode>
-                <c:ptCount val="75"/>
-                <c:pt idx="0">
-                  <c:v>1824</c:v>
-                </c:pt>
-                <c:pt idx="1">
-                  <c:v>1865</c:v>
-                </c:pt>
-                <c:pt idx="2">
-                  <c:v>1865</c:v>
-                </c:pt>
-                <c:pt idx="3">
-                  <c:v>1702</c:v>
-                </c:pt>
-                <c:pt idx="4">
-                  <c:v>1871</c:v>
-                </c:pt>
-                <c:pt idx="5">
-                  <c:v>1849</c:v>
-                </c:pt>
-                <c:pt idx="6">
-                  <c:v>1790</c:v>
-                </c:pt>
-                <c:pt idx="7">
-                  <c:v>2260</c:v>
-                </c:pt>
-                <c:pt idx="8">
-                  <c:v>2150</c:v>
-                </c:pt>
-                <c:pt idx="9">
-                  <c:v>1880</c:v>
-                </c:pt>
-                <c:pt idx="10">
-                  <c:v>1950</c:v>
-                </c:pt>
-                <c:pt idx="11">
-                  <c:v>1450</c:v>
-                </c:pt>
-                <c:pt idx="12">
-                  <c:v>2150</c:v>
-                </c:pt>
-                <c:pt idx="13">
-                  <c:v>2260</c:v>
-                </c:pt>
-                <c:pt idx="14">
-                  <c:v>2380</c:v>
-                </c:pt>
-                <c:pt idx="15">
-                  <c:v>1740</c:v>
-                </c:pt>
-                <c:pt idx="16">
-                  <c:v>1450</c:v>
-                </c:pt>
-                <c:pt idx="17">
-                  <c:v>1610</c:v>
-                </c:pt>
-                <c:pt idx="18">
-                  <c:v>1820</c:v>
-                </c:pt>
-                <c:pt idx="19">
-                  <c:v>1880</c:v>
-                </c:pt>
-                <c:pt idx="20">
-                  <c:v>2380</c:v>
-                </c:pt>
-                <c:pt idx="21">
-                  <c:v>1810</c:v>
-                </c:pt>
-                <c:pt idx="22">
-                  <c:v>1880</c:v>
-                </c:pt>
-                <c:pt idx="23">
-                  <c:v>1950</c:v>
-                </c:pt>
-                <c:pt idx="24">
-                  <c:v>2380</c:v>
-                </c:pt>
-                <c:pt idx="25">
-                  <c:v>2380</c:v>
-                </c:pt>
-                <c:pt idx="26">
-                  <c:v>1740</c:v>
-                </c:pt>
-                <c:pt idx="27">
-                  <c:v>1740</c:v>
-                </c:pt>
-                <c:pt idx="28">
-                  <c:v>2380</c:v>
-                </c:pt>
-                <c:pt idx="29">
-                  <c:v>2380</c:v>
-                </c:pt>
-                <c:pt idx="30">
-                  <c:v>2040</c:v>
-                </c:pt>
-                <c:pt idx="31">
-                  <c:v>2380</c:v>
-                </c:pt>
-                <c:pt idx="32">
-                  <c:v>1610</c:v>
-                </c:pt>
-                <c:pt idx="33">
-                  <c:v>1849</c:v>
-                </c:pt>
-                <c:pt idx="34">
-                  <c:v>1943</c:v>
-                </c:pt>
-                <c:pt idx="35">
-                  <c:v>2400</c:v>
-                </c:pt>
-                <c:pt idx="36">
-                  <c:v>2400</c:v>
-                </c:pt>
-                <c:pt idx="37">
-                  <c:v>2400</c:v>
-                </c:pt>
-                <c:pt idx="38">
-                  <c:v>1650</c:v>
-                </c:pt>
-                <c:pt idx="39">
-                  <c:v>1500</c:v>
-                </c:pt>
-                <c:pt idx="40">
-                  <c:v>1650</c:v>
-                </c:pt>
-                <c:pt idx="41">
-                  <c:v>1900</c:v>
-                </c:pt>
-                <c:pt idx="42">
-                  <c:v>1650</c:v>
-                </c:pt>
-                <c:pt idx="43">
-                  <c:v>1900</c:v>
-                </c:pt>
-                <c:pt idx="44">
-                  <c:v>1650</c:v>
-                </c:pt>
-                <c:pt idx="45">
-                  <c:v>2100</c:v>
-                </c:pt>
-                <c:pt idx="46">
-                  <c:v>1450</c:v>
-                </c:pt>
-                <c:pt idx="47">
-                  <c:v>1485.1851851851852</c:v>
-                </c:pt>
-                <c:pt idx="48">
-                  <c:v>1520.3703703703704</c:v>
-                </c:pt>
-                <c:pt idx="49">
-                  <c:v>1555.5555555555557</c:v>
-                </c:pt>
-                <c:pt idx="50">
-                  <c:v>1590.7407407407406</c:v>
-                </c:pt>
-                <c:pt idx="51">
-                  <c:v>1625.9259259259259</c:v>
-                </c:pt>
-                <c:pt idx="52">
-                  <c:v>1661.111111111111</c:v>
-                </c:pt>
-                <c:pt idx="53">
-                  <c:v>1696.2962962962963</c:v>
-                </c:pt>
-                <c:pt idx="54">
-                  <c:v>1731.4814814814815</c:v>
-                </c:pt>
-                <c:pt idx="55">
-                  <c:v>1766.6666666666667</c:v>
-                </c:pt>
-                <c:pt idx="56">
-                  <c:v>1801.8518518518517</c:v>
-                </c:pt>
-                <c:pt idx="57">
-                  <c:v>1837.037037037037</c:v>
-                </c:pt>
-                <c:pt idx="58">
-                  <c:v>1872.2222222222222</c:v>
-                </c:pt>
-                <c:pt idx="59">
-                  <c:v>1907.4074074074074</c:v>
-                </c:pt>
-                <c:pt idx="60">
-                  <c:v>1942.5925925925926</c:v>
-                </c:pt>
-                <c:pt idx="61">
-                  <c:v>1977.7777777777778</c:v>
-                </c:pt>
-                <c:pt idx="62">
-                  <c:v>2012.962962962963</c:v>
-                </c:pt>
-                <c:pt idx="63">
-                  <c:v>2048.1481481481483</c:v>
-                </c:pt>
-                <c:pt idx="64">
-                  <c:v>2083.3333333333335</c:v>
-                </c:pt>
-                <c:pt idx="65">
-                  <c:v>2118.5185185185182</c:v>
-                </c:pt>
-                <c:pt idx="66">
-                  <c:v>2153.7037037037035</c:v>
-                </c:pt>
-                <c:pt idx="67">
-                  <c:v>2188.8888888888887</c:v>
-                </c:pt>
-                <c:pt idx="68">
-                  <c:v>2224.074074074074</c:v>
-                </c:pt>
-                <c:pt idx="69">
-                  <c:v>2259.259259259259</c:v>
-                </c:pt>
-                <c:pt idx="70">
-                  <c:v>2294.4444444444443</c:v>
-                </c:pt>
-                <c:pt idx="71">
-                  <c:v>2329.6296296296296</c:v>
-                </c:pt>
-                <c:pt idx="72">
-                  <c:v>2364.814814814815</c:v>
-                </c:pt>
-                <c:pt idx="73">
-                  <c:v>2400</c:v>
-                </c:pt>
-                <c:pt idx="74">
-                  <c:v>1849</c:v>
-                </c:pt>
-              </c:numCache>
-            </c:numRef>
-          </c:xVal>
-          <c:yVal>
-            <c:numRef>
-              <c:f>Sheet1!$C$2:$C$76</c:f>
-              <c:numCache>
-                <c:formatCode>General</c:formatCode>
-                <c:ptCount val="75"/>
-                <c:pt idx="0">
-                  <c:v/>
-                </c:pt>
-                <c:pt idx="1">
-                  <c:v/>
-                </c:pt>
-                <c:pt idx="2">
-                  <c:v/>
-                </c:pt>
-                <c:pt idx="3">
-                  <c:v/>
-                </c:pt>
-                <c:pt idx="4">
-                  <c:v>427000</c:v>
-                </c:pt>
-                <c:pt idx="5">
-                  <c:v>429000</c:v>
-                </c:pt>
-                <c:pt idx="6">
-                  <c:v>427000</c:v>
-                </c:pt>
-                <c:pt idx="7">
-                  <c:v>559500</c:v>
-                </c:pt>
-                <c:pt idx="8">
-                  <c:v>529500</c:v>
-                </c:pt>
-                <c:pt idx="9">
-                  <c:v>429500</c:v>
-                </c:pt>
-                <c:pt idx="10">
-                  <c:v>473000</c:v>
-                </c:pt>
-                <c:pt idx="11">
-                  <c:v>325500</c:v>
-                </c:pt>
-                <c:pt idx="12">
-                  <c:v>493000</c:v>
-                </c:pt>
-                <c:pt idx="13">
-                  <c:v>549500</c:v>
-                </c:pt>
-                <c:pt idx="14">
-                  <c:v>596500</c:v>
-                </c:pt>
-                <c:pt idx="15">
-                  <c:v>444500</c:v>
-                </c:pt>
-                <c:pt idx="16">
-                  <c:v>361500</c:v>
-                </c:pt>
-                <c:pt idx="17">
-                  <c:v>398000</c:v>
-                </c:pt>
-                <c:pt idx="18">
-                  <c:v>396500</c:v>
-                </c:pt>
-                <c:pt idx="19">
-                  <c:v>461000</c:v>
-                </c:pt>
-                <c:pt idx="20">
-                  <c:v>570000</c:v>
-                </c:pt>
-                <c:pt idx="21">
-                  <c:v/>
-                </c:pt>
-                <c:pt idx="22">
-                  <c:v/>
-                </c:pt>
-                <c:pt idx="23">
-                  <c:v/>
-                </c:pt>
-                <c:pt idx="24">
-                  <c:v/>
-                </c:pt>
-                <c:pt idx="25">
-                  <c:v/>
-                </c:pt>
-                <c:pt idx="26">
-                  <c:v/>
-                </c:pt>
-                <c:pt idx="27">
-                  <c:v/>
-                </c:pt>
-                <c:pt idx="28">
-                  <c:v/>
-                </c:pt>
-                <c:pt idx="29">
-                  <c:v/>
-                </c:pt>
-                <c:pt idx="30">
-                  <c:v/>
-                </c:pt>
-                <c:pt idx="31">
-                  <c:v/>
-                </c:pt>
-                <c:pt idx="32">
-                  <c:v/>
-                </c:pt>
-                <c:pt idx="33">
-                  <c:v/>
-                </c:pt>
-                <c:pt idx="34">
-                  <c:v/>
-                </c:pt>
-                <c:pt idx="35">
-                  <c:v/>
-                </c:pt>
-                <c:pt idx="36">
-                  <c:v/>
-                </c:pt>
-                <c:pt idx="37">
-                  <c:v/>
-                </c:pt>
-                <c:pt idx="38">
-                  <c:v/>
-                </c:pt>
-                <c:pt idx="39">
-                  <c:v/>
-                </c:pt>
-                <c:pt idx="40">
-                  <c:v/>
-                </c:pt>
-                <c:pt idx="41">
-                  <c:v/>
-                </c:pt>
-                <c:pt idx="42">
-                  <c:v/>
-                </c:pt>
-                <c:pt idx="43">
-                  <c:v/>
-                </c:pt>
-                <c:pt idx="44">
-                  <c:v/>
-                </c:pt>
-                <c:pt idx="45">
-                  <c:v/>
-                </c:pt>
-                <c:pt idx="46">
-                  <c:v/>
-                </c:pt>
-                <c:pt idx="47">
-                  <c:v/>
-                </c:pt>
-                <c:pt idx="48">
-                  <c:v/>
-                </c:pt>
-                <c:pt idx="49">
-                  <c:v/>
-                </c:pt>
-                <c:pt idx="50">
-                  <c:v/>
-                </c:pt>
-                <c:pt idx="51">
-                  <c:v/>
-                </c:pt>
-                <c:pt idx="52">
-                  <c:v/>
-                </c:pt>
-                <c:pt idx="53">
-                  <c:v/>
-                </c:pt>
-                <c:pt idx="54">
-                  <c:v/>
-                </c:pt>
-                <c:pt idx="55">
-                  <c:v/>
-                </c:pt>
-                <c:pt idx="56">
-                  <c:v/>
-                </c:pt>
-                <c:pt idx="57">
-                  <c:v/>
-                </c:pt>
-                <c:pt idx="58">
-                  <c:v/>
-                </c:pt>
-                <c:pt idx="59">
-                  <c:v/>
-                </c:pt>
-                <c:pt idx="60">
-                  <c:v/>
-                </c:pt>
-                <c:pt idx="61">
-                  <c:v/>
-                </c:pt>
-                <c:pt idx="62">
-                  <c:v/>
-                </c:pt>
-                <c:pt idx="63">
-                  <c:v/>
-                </c:pt>
-                <c:pt idx="64">
-                  <c:v/>
-                </c:pt>
-                <c:pt idx="65">
-                  <c:v/>
-                </c:pt>
-                <c:pt idx="66">
-                  <c:v/>
-                </c:pt>
-                <c:pt idx="67">
-                  <c:v/>
-                </c:pt>
-                <c:pt idx="68">
-                  <c:v/>
-                </c:pt>
-                <c:pt idx="69">
-                  <c:v/>
-                </c:pt>
-                <c:pt idx="70">
-                  <c:v/>
-                </c:pt>
-                <c:pt idx="71">
-                  <c:v/>
-                </c:pt>
-                <c:pt idx="72">
-                  <c:v/>
-                </c:pt>
-                <c:pt idx="73">
-                  <c:v/>
-                </c:pt>
-                <c:pt idx="74">
-                  <c:v/>
-                </c:pt>
-              </c:numCache>
-            </c:numRef>
-          </c:yVal>
-          <c:smooth val="0"/>
-        </c:ser>
-        <c:ser>
-          <c:idx val="2"/>
-          <c:order val="2"/>
-          <c:tx>
-            <c:strRef>
-              <c:f>Sheet1!$D$1</c:f>
-              <c:strCache>
-                <c:ptCount val="1"/>
-                <c:pt idx="0">
-                  <c:v>No Pool (Sold)</c:v>
+                  <c:v>Other Sales</c:v>
                 </c:pt>
               </c:strCache>
             </c:strRef>
@@ -1196,97 +689,97 @@
                   <c:v>1865</c:v>
                 </c:pt>
                 <c:pt idx="2">
+                  <c:v>1871</c:v>
+                </c:pt>
+                <c:pt idx="3">
+                  <c:v>1849</c:v>
+                </c:pt>
+                <c:pt idx="4">
                   <c:v>1865</c:v>
                 </c:pt>
-                <c:pt idx="3">
+                <c:pt idx="5">
+                  <c:v>1790</c:v>
+                </c:pt>
+                <c:pt idx="6">
+                  <c:v>1810</c:v>
+                </c:pt>
+                <c:pt idx="7">
                   <c:v>1702</c:v>
                 </c:pt>
-                <c:pt idx="4">
-                  <c:v>1871</c:v>
-                </c:pt>
-                <c:pt idx="5">
-                  <c:v>1849</c:v>
-                </c:pt>
-                <c:pt idx="6">
-                  <c:v>1790</c:v>
-                </c:pt>
-                <c:pt idx="7">
+                <c:pt idx="8">
+                  <c:v>1880</c:v>
+                </c:pt>
+                <c:pt idx="9">
                   <c:v>2260</c:v>
-                </c:pt>
-                <c:pt idx="8">
-                  <c:v>2150</c:v>
-                </c:pt>
-                <c:pt idx="9">
-                  <c:v>1880</c:v>
                 </c:pt>
                 <c:pt idx="10">
                   <c:v>1950</c:v>
                 </c:pt>
                 <c:pt idx="11">
-                  <c:v>1450</c:v>
+                  <c:v>2380</c:v>
                 </c:pt>
                 <c:pt idx="12">
                   <c:v>2150</c:v>
                 </c:pt>
                 <c:pt idx="13">
-                  <c:v>2260</c:v>
+                  <c:v>2380</c:v>
                 </c:pt>
                 <c:pt idx="14">
-                  <c:v>2380</c:v>
+                  <c:v>1740</c:v>
                 </c:pt>
                 <c:pt idx="15">
+                  <c:v>1880</c:v>
+                </c:pt>
+                <c:pt idx="16">
+                  <c:v>1950</c:v>
+                </c:pt>
+                <c:pt idx="17">
                   <c:v>1740</c:v>
                 </c:pt>
-                <c:pt idx="16">
+                <c:pt idx="18">
                   <c:v>1450</c:v>
                 </c:pt>
-                <c:pt idx="17">
-                  <c:v>1610</c:v>
-                </c:pt>
-                <c:pt idx="18">
-                  <c:v>1820</c:v>
-                </c:pt>
                 <c:pt idx="19">
-                  <c:v>1880</c:v>
+                  <c:v>2150</c:v>
                 </c:pt>
                 <c:pt idx="20">
                   <c:v>2380</c:v>
                 </c:pt>
                 <c:pt idx="21">
-                  <c:v>1810</c:v>
+                  <c:v>2260</c:v>
                 </c:pt>
                 <c:pt idx="22">
+                  <c:v>2380</c:v>
+                </c:pt>
+                <c:pt idx="23">
+                  <c:v>1740</c:v>
+                </c:pt>
+                <c:pt idx="24">
+                  <c:v>1450</c:v>
+                </c:pt>
+                <c:pt idx="25">
+                  <c:v>1610</c:v>
+                </c:pt>
+                <c:pt idx="26">
+                  <c:v>2380</c:v>
+                </c:pt>
+                <c:pt idx="27">
+                  <c:v>1820</c:v>
+                </c:pt>
+                <c:pt idx="28">
                   <c:v>1880</c:v>
                 </c:pt>
-                <c:pt idx="23">
-                  <c:v>1950</c:v>
-                </c:pt>
-                <c:pt idx="24">
+                <c:pt idx="29">
+                  <c:v>2040</c:v>
+                </c:pt>
+                <c:pt idx="30">
                   <c:v>2380</c:v>
                 </c:pt>
-                <c:pt idx="25">
+                <c:pt idx="31">
+                  <c:v>1610</c:v>
+                </c:pt>
+                <c:pt idx="32">
                   <c:v>2380</c:v>
-                </c:pt>
-                <c:pt idx="26">
-                  <c:v>1740</c:v>
-                </c:pt>
-                <c:pt idx="27">
-                  <c:v>1740</c:v>
-                </c:pt>
-                <c:pt idx="28">
-                  <c:v>2380</c:v>
-                </c:pt>
-                <c:pt idx="29">
-                  <c:v>2380</c:v>
-                </c:pt>
-                <c:pt idx="30">
-                  <c:v>2040</c:v>
-                </c:pt>
-                <c:pt idx="31">
-                  <c:v>2380</c:v>
-                </c:pt>
-                <c:pt idx="32">
-                  <c:v>1610</c:v>
                 </c:pt>
                 <c:pt idx="33">
                   <c:v>1849</c:v>
@@ -1419,7 +912,7 @@
           </c:xVal>
           <c:yVal>
             <c:numRef>
-              <c:f>Sheet1!$D$2:$D$76</c:f>
+              <c:f>Sheet1!$C$2:$C$76</c:f>
               <c:numCache>
                 <c:formatCode>General</c:formatCode>
                 <c:ptCount val="75"/>
@@ -1439,88 +932,88 @@
                   <c:v/>
                 </c:pt>
                 <c:pt idx="5">
-                  <c:v/>
+                  <c:v>427000</c:v>
                 </c:pt>
                 <c:pt idx="6">
-                  <c:v/>
+                  <c:v>435000</c:v>
                 </c:pt>
                 <c:pt idx="7">
-                  <c:v/>
+                  <c:v>470000</c:v>
                 </c:pt>
                 <c:pt idx="8">
-                  <c:v/>
+                  <c:v>454500</c:v>
                 </c:pt>
                 <c:pt idx="9">
-                  <c:v/>
+                  <c:v>559500</c:v>
                 </c:pt>
                 <c:pt idx="10">
-                  <c:v/>
+                  <c:v>446000</c:v>
                 </c:pt>
                 <c:pt idx="11">
-                  <c:v/>
+                  <c:v>575000</c:v>
                 </c:pt>
                 <c:pt idx="12">
-                  <c:v/>
+                  <c:v>529500</c:v>
                 </c:pt>
                 <c:pt idx="13">
-                  <c:v/>
+                  <c:v>516000</c:v>
                 </c:pt>
                 <c:pt idx="14">
-                  <c:v/>
+                  <c:v>364000</c:v>
                 </c:pt>
                 <c:pt idx="15">
-                  <c:v/>
+                  <c:v>429500</c:v>
                 </c:pt>
                 <c:pt idx="16">
-                  <c:v/>
+                  <c:v>473000</c:v>
                 </c:pt>
                 <c:pt idx="17">
-                  <c:v/>
+                  <c:v>391000</c:v>
                 </c:pt>
                 <c:pt idx="18">
-                  <c:v/>
+                  <c:v>325500</c:v>
                 </c:pt>
                 <c:pt idx="19">
-                  <c:v/>
+                  <c:v>493000</c:v>
                 </c:pt>
                 <c:pt idx="20">
-                  <c:v/>
+                  <c:v>578000</c:v>
                 </c:pt>
                 <c:pt idx="21">
-                  <c:v>435000</c:v>
+                  <c:v>549500</c:v>
                 </c:pt>
                 <c:pt idx="22">
-                  <c:v>454500</c:v>
+                  <c:v>596500</c:v>
                 </c:pt>
                 <c:pt idx="23">
-                  <c:v>446000</c:v>
+                  <c:v>444500</c:v>
                 </c:pt>
                 <c:pt idx="24">
-                  <c:v>575000</c:v>
+                  <c:v>361500</c:v>
                 </c:pt>
                 <c:pt idx="25">
-                  <c:v>516000</c:v>
+                  <c:v>398000</c:v>
                 </c:pt>
                 <c:pt idx="26">
-                  <c:v>364000</c:v>
+                  <c:v>526000</c:v>
                 </c:pt>
                 <c:pt idx="27">
-                  <c:v>391000</c:v>
+                  <c:v>396500</c:v>
                 </c:pt>
                 <c:pt idx="28">
-                  <c:v>578000</c:v>
+                  <c:v>461000</c:v>
                 </c:pt>
                 <c:pt idx="29">
-                  <c:v>526000</c:v>
+                  <c:v>477000</c:v>
                 </c:pt>
                 <c:pt idx="30">
-                  <c:v>477000</c:v>
+                  <c:v>535000</c:v>
                 </c:pt>
                 <c:pt idx="31">
-                  <c:v>535000</c:v>
+                  <c:v>367000</c:v>
                 </c:pt>
                 <c:pt idx="32">
-                  <c:v>367000</c:v>
+                  <c:v>570000</c:v>
                 </c:pt>
                 <c:pt idx="33">
                   <c:v/>
@@ -1654,11 +1147,11 @@
           <c:smooth val="0"/>
         </c:ser>
         <c:ser>
-          <c:idx val="3"/>
-          <c:order val="3"/>
+          <c:idx val="2"/>
+          <c:order val="2"/>
           <c:tx>
             <c:strRef>
-              <c:f>Sheet1!$E$1</c:f>
+              <c:f>Sheet1!$D$1</c:f>
               <c:strCache>
                 <c:ptCount val="1"/>
                 <c:pt idx="0">
@@ -1703,97 +1196,97 @@
                   <c:v>1865</c:v>
                 </c:pt>
                 <c:pt idx="2">
+                  <c:v>1871</c:v>
+                </c:pt>
+                <c:pt idx="3">
+                  <c:v>1849</c:v>
+                </c:pt>
+                <c:pt idx="4">
                   <c:v>1865</c:v>
                 </c:pt>
-                <c:pt idx="3">
+                <c:pt idx="5">
+                  <c:v>1790</c:v>
+                </c:pt>
+                <c:pt idx="6">
+                  <c:v>1810</c:v>
+                </c:pt>
+                <c:pt idx="7">
                   <c:v>1702</c:v>
                 </c:pt>
-                <c:pt idx="4">
-                  <c:v>1871</c:v>
-                </c:pt>
-                <c:pt idx="5">
-                  <c:v>1849</c:v>
-                </c:pt>
-                <c:pt idx="6">
-                  <c:v>1790</c:v>
-                </c:pt>
-                <c:pt idx="7">
+                <c:pt idx="8">
+                  <c:v>1880</c:v>
+                </c:pt>
+                <c:pt idx="9">
                   <c:v>2260</c:v>
-                </c:pt>
-                <c:pt idx="8">
-                  <c:v>2150</c:v>
-                </c:pt>
-                <c:pt idx="9">
-                  <c:v>1880</c:v>
                 </c:pt>
                 <c:pt idx="10">
                   <c:v>1950</c:v>
                 </c:pt>
                 <c:pt idx="11">
-                  <c:v>1450</c:v>
+                  <c:v>2380</c:v>
                 </c:pt>
                 <c:pt idx="12">
                   <c:v>2150</c:v>
                 </c:pt>
                 <c:pt idx="13">
-                  <c:v>2260</c:v>
+                  <c:v>2380</c:v>
                 </c:pt>
                 <c:pt idx="14">
-                  <c:v>2380</c:v>
+                  <c:v>1740</c:v>
                 </c:pt>
                 <c:pt idx="15">
+                  <c:v>1880</c:v>
+                </c:pt>
+                <c:pt idx="16">
+                  <c:v>1950</c:v>
+                </c:pt>
+                <c:pt idx="17">
                   <c:v>1740</c:v>
                 </c:pt>
-                <c:pt idx="16">
+                <c:pt idx="18">
                   <c:v>1450</c:v>
                 </c:pt>
-                <c:pt idx="17">
-                  <c:v>1610</c:v>
-                </c:pt>
-                <c:pt idx="18">
-                  <c:v>1820</c:v>
-                </c:pt>
                 <c:pt idx="19">
-                  <c:v>1880</c:v>
+                  <c:v>2150</c:v>
                 </c:pt>
                 <c:pt idx="20">
                   <c:v>2380</c:v>
                 </c:pt>
                 <c:pt idx="21">
-                  <c:v>1810</c:v>
+                  <c:v>2260</c:v>
                 </c:pt>
                 <c:pt idx="22">
+                  <c:v>2380</c:v>
+                </c:pt>
+                <c:pt idx="23">
+                  <c:v>1740</c:v>
+                </c:pt>
+                <c:pt idx="24">
+                  <c:v>1450</c:v>
+                </c:pt>
+                <c:pt idx="25">
+                  <c:v>1610</c:v>
+                </c:pt>
+                <c:pt idx="26">
+                  <c:v>2380</c:v>
+                </c:pt>
+                <c:pt idx="27">
+                  <c:v>1820</c:v>
+                </c:pt>
+                <c:pt idx="28">
                   <c:v>1880</c:v>
                 </c:pt>
-                <c:pt idx="23">
-                  <c:v>1950</c:v>
-                </c:pt>
-                <c:pt idx="24">
+                <c:pt idx="29">
+                  <c:v>2040</c:v>
+                </c:pt>
+                <c:pt idx="30">
                   <c:v>2380</c:v>
                 </c:pt>
-                <c:pt idx="25">
+                <c:pt idx="31">
+                  <c:v>1610</c:v>
+                </c:pt>
+                <c:pt idx="32">
                   <c:v>2380</c:v>
-                </c:pt>
-                <c:pt idx="26">
-                  <c:v>1740</c:v>
-                </c:pt>
-                <c:pt idx="27">
-                  <c:v>1740</c:v>
-                </c:pt>
-                <c:pt idx="28">
-                  <c:v>2380</c:v>
-                </c:pt>
-                <c:pt idx="29">
-                  <c:v>2380</c:v>
-                </c:pt>
-                <c:pt idx="30">
-                  <c:v>2040</c:v>
-                </c:pt>
-                <c:pt idx="31">
-                  <c:v>2380</c:v>
-                </c:pt>
-                <c:pt idx="32">
-                  <c:v>1610</c:v>
                 </c:pt>
                 <c:pt idx="33">
                   <c:v>1849</c:v>
@@ -1926,7 +1419,7 @@
           </c:xVal>
           <c:yVal>
             <c:numRef>
-              <c:f>Sheet1!$E$2:$E$76</c:f>
+              <c:f>Sheet1!$D$2:$D$76</c:f>
               <c:numCache>
                 <c:formatCode>General</c:formatCode>
                 <c:ptCount val="75"/>
@@ -2161,11 +1654,11 @@
           <c:smooth val="0"/>
         </c:ser>
         <c:ser>
-          <c:idx val="4"/>
-          <c:order val="4"/>
+          <c:idx val="3"/>
+          <c:order val="3"/>
           <c:tx>
             <c:strRef>
-              <c:f>Sheet1!$F$1</c:f>
+              <c:f>Sheet1!$E$1</c:f>
               <c:strCache>
                 <c:ptCount val="1"/>
                 <c:pt idx="0">
@@ -2202,97 +1695,97 @@
                   <c:v>1865</c:v>
                 </c:pt>
                 <c:pt idx="2">
+                  <c:v>1871</c:v>
+                </c:pt>
+                <c:pt idx="3">
+                  <c:v>1849</c:v>
+                </c:pt>
+                <c:pt idx="4">
                   <c:v>1865</c:v>
                 </c:pt>
-                <c:pt idx="3">
+                <c:pt idx="5">
+                  <c:v>1790</c:v>
+                </c:pt>
+                <c:pt idx="6">
+                  <c:v>1810</c:v>
+                </c:pt>
+                <c:pt idx="7">
                   <c:v>1702</c:v>
                 </c:pt>
-                <c:pt idx="4">
-                  <c:v>1871</c:v>
-                </c:pt>
-                <c:pt idx="5">
-                  <c:v>1849</c:v>
-                </c:pt>
-                <c:pt idx="6">
-                  <c:v>1790</c:v>
-                </c:pt>
-                <c:pt idx="7">
+                <c:pt idx="8">
+                  <c:v>1880</c:v>
+                </c:pt>
+                <c:pt idx="9">
                   <c:v>2260</c:v>
-                </c:pt>
-                <c:pt idx="8">
-                  <c:v>2150</c:v>
-                </c:pt>
-                <c:pt idx="9">
-                  <c:v>1880</c:v>
                 </c:pt>
                 <c:pt idx="10">
                   <c:v>1950</c:v>
                 </c:pt>
                 <c:pt idx="11">
-                  <c:v>1450</c:v>
+                  <c:v>2380</c:v>
                 </c:pt>
                 <c:pt idx="12">
                   <c:v>2150</c:v>
                 </c:pt>
                 <c:pt idx="13">
-                  <c:v>2260</c:v>
+                  <c:v>2380</c:v>
                 </c:pt>
                 <c:pt idx="14">
-                  <c:v>2380</c:v>
+                  <c:v>1740</c:v>
                 </c:pt>
                 <c:pt idx="15">
+                  <c:v>1880</c:v>
+                </c:pt>
+                <c:pt idx="16">
+                  <c:v>1950</c:v>
+                </c:pt>
+                <c:pt idx="17">
                   <c:v>1740</c:v>
                 </c:pt>
-                <c:pt idx="16">
+                <c:pt idx="18">
                   <c:v>1450</c:v>
                 </c:pt>
-                <c:pt idx="17">
-                  <c:v>1610</c:v>
-                </c:pt>
-                <c:pt idx="18">
-                  <c:v>1820</c:v>
-                </c:pt>
                 <c:pt idx="19">
-                  <c:v>1880</c:v>
+                  <c:v>2150</c:v>
                 </c:pt>
                 <c:pt idx="20">
                   <c:v>2380</c:v>
                 </c:pt>
                 <c:pt idx="21">
-                  <c:v>1810</c:v>
+                  <c:v>2260</c:v>
                 </c:pt>
                 <c:pt idx="22">
+                  <c:v>2380</c:v>
+                </c:pt>
+                <c:pt idx="23">
+                  <c:v>1740</c:v>
+                </c:pt>
+                <c:pt idx="24">
+                  <c:v>1450</c:v>
+                </c:pt>
+                <c:pt idx="25">
+                  <c:v>1610</c:v>
+                </c:pt>
+                <c:pt idx="26">
+                  <c:v>2380</c:v>
+                </c:pt>
+                <c:pt idx="27">
+                  <c:v>1820</c:v>
+                </c:pt>
+                <c:pt idx="28">
                   <c:v>1880</c:v>
                 </c:pt>
-                <c:pt idx="23">
-                  <c:v>1950</c:v>
-                </c:pt>
-                <c:pt idx="24">
+                <c:pt idx="29">
+                  <c:v>2040</c:v>
+                </c:pt>
+                <c:pt idx="30">
                   <c:v>2380</c:v>
                 </c:pt>
-                <c:pt idx="25">
+                <c:pt idx="31">
+                  <c:v>1610</c:v>
+                </c:pt>
+                <c:pt idx="32">
                   <c:v>2380</c:v>
-                </c:pt>
-                <c:pt idx="26">
-                  <c:v>1740</c:v>
-                </c:pt>
-                <c:pt idx="27">
-                  <c:v>1740</c:v>
-                </c:pt>
-                <c:pt idx="28">
-                  <c:v>2380</c:v>
-                </c:pt>
-                <c:pt idx="29">
-                  <c:v>2380</c:v>
-                </c:pt>
-                <c:pt idx="30">
-                  <c:v>2040</c:v>
-                </c:pt>
-                <c:pt idx="31">
-                  <c:v>2380</c:v>
-                </c:pt>
-                <c:pt idx="32">
-                  <c:v>1610</c:v>
                 </c:pt>
                 <c:pt idx="33">
                   <c:v>1849</c:v>
@@ -2425,7 +1918,7 @@
           </c:xVal>
           <c:yVal>
             <c:numRef>
-              <c:f>Sheet1!$F$2:$F$76</c:f>
+              <c:f>Sheet1!$E$2:$E$76</c:f>
               <c:numCache>
                 <c:formatCode>General</c:formatCode>
                 <c:ptCount val="75"/>
@@ -2660,11 +2153,11 @@
           <c:smooth val="0"/>
         </c:ser>
         <c:ser>
-          <c:idx val="5"/>
-          <c:order val="5"/>
+          <c:idx val="4"/>
+          <c:order val="4"/>
           <c:tx>
             <c:strRef>
-              <c:f>Sheet1!$G$1</c:f>
+              <c:f>Sheet1!$F$1</c:f>
               <c:strCache>
                 <c:ptCount val="1"/>
                 <c:pt idx="0">
@@ -2709,97 +2202,97 @@
                   <c:v>1865</c:v>
                 </c:pt>
                 <c:pt idx="2">
+                  <c:v>1871</c:v>
+                </c:pt>
+                <c:pt idx="3">
+                  <c:v>1849</c:v>
+                </c:pt>
+                <c:pt idx="4">
                   <c:v>1865</c:v>
                 </c:pt>
-                <c:pt idx="3">
+                <c:pt idx="5">
+                  <c:v>1790</c:v>
+                </c:pt>
+                <c:pt idx="6">
+                  <c:v>1810</c:v>
+                </c:pt>
+                <c:pt idx="7">
                   <c:v>1702</c:v>
                 </c:pt>
-                <c:pt idx="4">
-                  <c:v>1871</c:v>
-                </c:pt>
-                <c:pt idx="5">
-                  <c:v>1849</c:v>
-                </c:pt>
-                <c:pt idx="6">
-                  <c:v>1790</c:v>
-                </c:pt>
-                <c:pt idx="7">
+                <c:pt idx="8">
+                  <c:v>1880</c:v>
+                </c:pt>
+                <c:pt idx="9">
                   <c:v>2260</c:v>
-                </c:pt>
-                <c:pt idx="8">
-                  <c:v>2150</c:v>
-                </c:pt>
-                <c:pt idx="9">
-                  <c:v>1880</c:v>
                 </c:pt>
                 <c:pt idx="10">
                   <c:v>1950</c:v>
                 </c:pt>
                 <c:pt idx="11">
-                  <c:v>1450</c:v>
+                  <c:v>2380</c:v>
                 </c:pt>
                 <c:pt idx="12">
                   <c:v>2150</c:v>
                 </c:pt>
                 <c:pt idx="13">
-                  <c:v>2260</c:v>
+                  <c:v>2380</c:v>
                 </c:pt>
                 <c:pt idx="14">
-                  <c:v>2380</c:v>
+                  <c:v>1740</c:v>
                 </c:pt>
                 <c:pt idx="15">
+                  <c:v>1880</c:v>
+                </c:pt>
+                <c:pt idx="16">
+                  <c:v>1950</c:v>
+                </c:pt>
+                <c:pt idx="17">
                   <c:v>1740</c:v>
                 </c:pt>
-                <c:pt idx="16">
+                <c:pt idx="18">
                   <c:v>1450</c:v>
                 </c:pt>
-                <c:pt idx="17">
-                  <c:v>1610</c:v>
-                </c:pt>
-                <c:pt idx="18">
-                  <c:v>1820</c:v>
-                </c:pt>
                 <c:pt idx="19">
-                  <c:v>1880</c:v>
+                  <c:v>2150</c:v>
                 </c:pt>
                 <c:pt idx="20">
                   <c:v>2380</c:v>
                 </c:pt>
                 <c:pt idx="21">
-                  <c:v>1810</c:v>
+                  <c:v>2260</c:v>
                 </c:pt>
                 <c:pt idx="22">
+                  <c:v>2380</c:v>
+                </c:pt>
+                <c:pt idx="23">
+                  <c:v>1740</c:v>
+                </c:pt>
+                <c:pt idx="24">
+                  <c:v>1450</c:v>
+                </c:pt>
+                <c:pt idx="25">
+                  <c:v>1610</c:v>
+                </c:pt>
+                <c:pt idx="26">
+                  <c:v>2380</c:v>
+                </c:pt>
+                <c:pt idx="27">
+                  <c:v>1820</c:v>
+                </c:pt>
+                <c:pt idx="28">
                   <c:v>1880</c:v>
                 </c:pt>
-                <c:pt idx="23">
-                  <c:v>1950</c:v>
-                </c:pt>
-                <c:pt idx="24">
+                <c:pt idx="29">
+                  <c:v>2040</c:v>
+                </c:pt>
+                <c:pt idx="30">
                   <c:v>2380</c:v>
                 </c:pt>
-                <c:pt idx="25">
+                <c:pt idx="31">
+                  <c:v>1610</c:v>
+                </c:pt>
+                <c:pt idx="32">
                   <c:v>2380</c:v>
-                </c:pt>
-                <c:pt idx="26">
-                  <c:v>1740</c:v>
-                </c:pt>
-                <c:pt idx="27">
-                  <c:v>1740</c:v>
-                </c:pt>
-                <c:pt idx="28">
-                  <c:v>2380</c:v>
-                </c:pt>
-                <c:pt idx="29">
-                  <c:v>2380</c:v>
-                </c:pt>
-                <c:pt idx="30">
-                  <c:v>2040</c:v>
-                </c:pt>
-                <c:pt idx="31">
-                  <c:v>2380</c:v>
-                </c:pt>
-                <c:pt idx="32">
-                  <c:v>1610</c:v>
                 </c:pt>
                 <c:pt idx="33">
                   <c:v>1849</c:v>
@@ -2932,7 +2425,7 @@
           </c:xVal>
           <c:yVal>
             <c:numRef>
-              <c:f>Sheet1!$G$2:$G$76</c:f>
+              <c:f>Sheet1!$F$2:$F$76</c:f>
               <c:numCache>
                 <c:formatCode>General</c:formatCode>
                 <c:ptCount val="75"/>
@@ -18238,7 +17731,7 @@
                 <a:ea typeface="Arial" pitchFamily="34" charset="-122"/>
                 <a:cs typeface="Arial" pitchFamily="34" charset="-120"/>
               </a:rPr>
-              <a:t>Renovated pool homes sell well above the neighborhood trend. At $469,900, yours sits among them without testing the ceiling.</a:t>
+              <a:t>The renovated comparable sales sit well above the neighborhood trend. At $469,900, yours sits among them without testing the ceiling.</a:t>
             </a:r>
             <a:endParaRPr lang="en-US" sz="1300" dirty="0"/>
           </a:p>
@@ -18277,7 +17770,7 @@
                 <a:ea typeface="Arial" pitchFamily="34" charset="-122"/>
                 <a:cs typeface="Arial" pitchFamily="34" charset="-120"/>
               </a:rPr>
-              <a:t>Size alone predicts about $443K at your size.</a:t>
+              <a:t>Size alone predicts about $443K at your size. Your price is about $27K above the line.</a:t>
             </a:r>
             <a:endParaRPr lang="en-US" sz="1100" dirty="0"/>
           </a:p>

</xml_diff>

<commit_message>
Version 0.10.1: quieter scatterplot background
Other sales become small, light dots instead of squares, so stacked sales
read as a denser patch rather than solid bars. Comps and the subject home
draw on top; the trend line is still fit to all sales. In the deck, For
Sale Now is the darker gray so current competition stands out.

Co-Authored-By: Claude Opus 5.5 <noreply@anthropic.com>
</commit_message>
<xml_diff>
--- a/samples/seller-cma/517-Larkwood-Ave-Listing-Presentation.pptx
+++ b/samples/seller-cma/517-Larkwood-Ave-Listing-Presentation.pptx
@@ -141,513 +141,6 @@
               <c:strCache>
                 <c:ptCount val="1"/>
                 <c:pt idx="0">
-                  <c:v>Comparable Sales</c:v>
-                </c:pt>
-              </c:strCache>
-            </c:strRef>
-          </c:tx>
-          <c:spPr>
-            <a:solidFill>
-              <a:srgbClr val="C2410C"/>
-            </a:solidFill>
-            <a:ln>
-              <a:noFill/>
-            </a:ln>
-            <a:effectLst/>
-          </c:spPr>
-          <c:marker>
-            <c:symbol val="circle"/>
-            <c:size val="8"/>
-            <c:spPr>
-              <a:solidFill>
-                <a:srgbClr val="C2410C"/>
-              </a:solidFill>
-              <a:ln w="9525">
-                <a:solidFill>
-                  <a:srgbClr val="C2410C"/>
-                </a:solidFill>
-              </a:ln>
-            </c:spPr>
-          </c:marker>
-          <c:xVal>
-            <c:numRef>
-              <c:f>Sheet1!$A$2:$A$76</c:f>
-              <c:numCache>
-                <c:formatCode>General</c:formatCode>
-                <c:ptCount val="75"/>
-                <c:pt idx="0">
-                  <c:v>1824</c:v>
-                </c:pt>
-                <c:pt idx="1">
-                  <c:v>1865</c:v>
-                </c:pt>
-                <c:pt idx="2">
-                  <c:v>1871</c:v>
-                </c:pt>
-                <c:pt idx="3">
-                  <c:v>1849</c:v>
-                </c:pt>
-                <c:pt idx="4">
-                  <c:v>1865</c:v>
-                </c:pt>
-                <c:pt idx="5">
-                  <c:v>1790</c:v>
-                </c:pt>
-                <c:pt idx="6">
-                  <c:v>1810</c:v>
-                </c:pt>
-                <c:pt idx="7">
-                  <c:v>1702</c:v>
-                </c:pt>
-                <c:pt idx="8">
-                  <c:v>1880</c:v>
-                </c:pt>
-                <c:pt idx="9">
-                  <c:v>2260</c:v>
-                </c:pt>
-                <c:pt idx="10">
-                  <c:v>1950</c:v>
-                </c:pt>
-                <c:pt idx="11">
-                  <c:v>2380</c:v>
-                </c:pt>
-                <c:pt idx="12">
-                  <c:v>2150</c:v>
-                </c:pt>
-                <c:pt idx="13">
-                  <c:v>2380</c:v>
-                </c:pt>
-                <c:pt idx="14">
-                  <c:v>1740</c:v>
-                </c:pt>
-                <c:pt idx="15">
-                  <c:v>1880</c:v>
-                </c:pt>
-                <c:pt idx="16">
-                  <c:v>1950</c:v>
-                </c:pt>
-                <c:pt idx="17">
-                  <c:v>1740</c:v>
-                </c:pt>
-                <c:pt idx="18">
-                  <c:v>1450</c:v>
-                </c:pt>
-                <c:pt idx="19">
-                  <c:v>2150</c:v>
-                </c:pt>
-                <c:pt idx="20">
-                  <c:v>2380</c:v>
-                </c:pt>
-                <c:pt idx="21">
-                  <c:v>2260</c:v>
-                </c:pt>
-                <c:pt idx="22">
-                  <c:v>2380</c:v>
-                </c:pt>
-                <c:pt idx="23">
-                  <c:v>1740</c:v>
-                </c:pt>
-                <c:pt idx="24">
-                  <c:v>1450</c:v>
-                </c:pt>
-                <c:pt idx="25">
-                  <c:v>1610</c:v>
-                </c:pt>
-                <c:pt idx="26">
-                  <c:v>2380</c:v>
-                </c:pt>
-                <c:pt idx="27">
-                  <c:v>1820</c:v>
-                </c:pt>
-                <c:pt idx="28">
-                  <c:v>1880</c:v>
-                </c:pt>
-                <c:pt idx="29">
-                  <c:v>2040</c:v>
-                </c:pt>
-                <c:pt idx="30">
-                  <c:v>2380</c:v>
-                </c:pt>
-                <c:pt idx="31">
-                  <c:v>1610</c:v>
-                </c:pt>
-                <c:pt idx="32">
-                  <c:v>2380</c:v>
-                </c:pt>
-                <c:pt idx="33">
-                  <c:v>1849</c:v>
-                </c:pt>
-                <c:pt idx="34">
-                  <c:v>1943</c:v>
-                </c:pt>
-                <c:pt idx="35">
-                  <c:v>2400</c:v>
-                </c:pt>
-                <c:pt idx="36">
-                  <c:v>2400</c:v>
-                </c:pt>
-                <c:pt idx="37">
-                  <c:v>2400</c:v>
-                </c:pt>
-                <c:pt idx="38">
-                  <c:v>1650</c:v>
-                </c:pt>
-                <c:pt idx="39">
-                  <c:v>1500</c:v>
-                </c:pt>
-                <c:pt idx="40">
-                  <c:v>1650</c:v>
-                </c:pt>
-                <c:pt idx="41">
-                  <c:v>1900</c:v>
-                </c:pt>
-                <c:pt idx="42">
-                  <c:v>1650</c:v>
-                </c:pt>
-                <c:pt idx="43">
-                  <c:v>1900</c:v>
-                </c:pt>
-                <c:pt idx="44">
-                  <c:v>1650</c:v>
-                </c:pt>
-                <c:pt idx="45">
-                  <c:v>2100</c:v>
-                </c:pt>
-                <c:pt idx="46">
-                  <c:v>1450</c:v>
-                </c:pt>
-                <c:pt idx="47">
-                  <c:v>1485.1851851851852</c:v>
-                </c:pt>
-                <c:pt idx="48">
-                  <c:v>1520.3703703703704</c:v>
-                </c:pt>
-                <c:pt idx="49">
-                  <c:v>1555.5555555555557</c:v>
-                </c:pt>
-                <c:pt idx="50">
-                  <c:v>1590.7407407407406</c:v>
-                </c:pt>
-                <c:pt idx="51">
-                  <c:v>1625.9259259259259</c:v>
-                </c:pt>
-                <c:pt idx="52">
-                  <c:v>1661.111111111111</c:v>
-                </c:pt>
-                <c:pt idx="53">
-                  <c:v>1696.2962962962963</c:v>
-                </c:pt>
-                <c:pt idx="54">
-                  <c:v>1731.4814814814815</c:v>
-                </c:pt>
-                <c:pt idx="55">
-                  <c:v>1766.6666666666667</c:v>
-                </c:pt>
-                <c:pt idx="56">
-                  <c:v>1801.8518518518517</c:v>
-                </c:pt>
-                <c:pt idx="57">
-                  <c:v>1837.037037037037</c:v>
-                </c:pt>
-                <c:pt idx="58">
-                  <c:v>1872.2222222222222</c:v>
-                </c:pt>
-                <c:pt idx="59">
-                  <c:v>1907.4074074074074</c:v>
-                </c:pt>
-                <c:pt idx="60">
-                  <c:v>1942.5925925925926</c:v>
-                </c:pt>
-                <c:pt idx="61">
-                  <c:v>1977.7777777777778</c:v>
-                </c:pt>
-                <c:pt idx="62">
-                  <c:v>2012.962962962963</c:v>
-                </c:pt>
-                <c:pt idx="63">
-                  <c:v>2048.1481481481483</c:v>
-                </c:pt>
-                <c:pt idx="64">
-                  <c:v>2083.3333333333335</c:v>
-                </c:pt>
-                <c:pt idx="65">
-                  <c:v>2118.5185185185182</c:v>
-                </c:pt>
-                <c:pt idx="66">
-                  <c:v>2153.7037037037035</c:v>
-                </c:pt>
-                <c:pt idx="67">
-                  <c:v>2188.8888888888887</c:v>
-                </c:pt>
-                <c:pt idx="68">
-                  <c:v>2224.074074074074</c:v>
-                </c:pt>
-                <c:pt idx="69">
-                  <c:v>2259.259259259259</c:v>
-                </c:pt>
-                <c:pt idx="70">
-                  <c:v>2294.4444444444443</c:v>
-                </c:pt>
-                <c:pt idx="71">
-                  <c:v>2329.6296296296296</c:v>
-                </c:pt>
-                <c:pt idx="72">
-                  <c:v>2364.814814814815</c:v>
-                </c:pt>
-                <c:pt idx="73">
-                  <c:v>2400</c:v>
-                </c:pt>
-                <c:pt idx="74">
-                  <c:v>1849</c:v>
-                </c:pt>
-              </c:numCache>
-            </c:numRef>
-          </c:xVal>
-          <c:yVal>
-            <c:numRef>
-              <c:f>Sheet1!$B$2:$B$76</c:f>
-              <c:numCache>
-                <c:formatCode>General</c:formatCode>
-                <c:ptCount val="75"/>
-                <c:pt idx="0">
-                  <c:v>505500</c:v>
-                </c:pt>
-                <c:pt idx="1">
-                  <c:v>495000</c:v>
-                </c:pt>
-                <c:pt idx="2">
-                  <c:v>427000</c:v>
-                </c:pt>
-                <c:pt idx="3">
-                  <c:v>429000</c:v>
-                </c:pt>
-                <c:pt idx="4">
-                  <c:v>465000</c:v>
-                </c:pt>
-                <c:pt idx="5">
-                  <c:v/>
-                </c:pt>
-                <c:pt idx="6">
-                  <c:v/>
-                </c:pt>
-                <c:pt idx="7">
-                  <c:v/>
-                </c:pt>
-                <c:pt idx="8">
-                  <c:v/>
-                </c:pt>
-                <c:pt idx="9">
-                  <c:v/>
-                </c:pt>
-                <c:pt idx="10">
-                  <c:v/>
-                </c:pt>
-                <c:pt idx="11">
-                  <c:v/>
-                </c:pt>
-                <c:pt idx="12">
-                  <c:v/>
-                </c:pt>
-                <c:pt idx="13">
-                  <c:v/>
-                </c:pt>
-                <c:pt idx="14">
-                  <c:v/>
-                </c:pt>
-                <c:pt idx="15">
-                  <c:v/>
-                </c:pt>
-                <c:pt idx="16">
-                  <c:v/>
-                </c:pt>
-                <c:pt idx="17">
-                  <c:v/>
-                </c:pt>
-                <c:pt idx="18">
-                  <c:v/>
-                </c:pt>
-                <c:pt idx="19">
-                  <c:v/>
-                </c:pt>
-                <c:pt idx="20">
-                  <c:v/>
-                </c:pt>
-                <c:pt idx="21">
-                  <c:v/>
-                </c:pt>
-                <c:pt idx="22">
-                  <c:v/>
-                </c:pt>
-                <c:pt idx="23">
-                  <c:v/>
-                </c:pt>
-                <c:pt idx="24">
-                  <c:v/>
-                </c:pt>
-                <c:pt idx="25">
-                  <c:v/>
-                </c:pt>
-                <c:pt idx="26">
-                  <c:v/>
-                </c:pt>
-                <c:pt idx="27">
-                  <c:v/>
-                </c:pt>
-                <c:pt idx="28">
-                  <c:v/>
-                </c:pt>
-                <c:pt idx="29">
-                  <c:v/>
-                </c:pt>
-                <c:pt idx="30">
-                  <c:v/>
-                </c:pt>
-                <c:pt idx="31">
-                  <c:v/>
-                </c:pt>
-                <c:pt idx="32">
-                  <c:v/>
-                </c:pt>
-                <c:pt idx="33">
-                  <c:v/>
-                </c:pt>
-                <c:pt idx="34">
-                  <c:v/>
-                </c:pt>
-                <c:pt idx="35">
-                  <c:v/>
-                </c:pt>
-                <c:pt idx="36">
-                  <c:v/>
-                </c:pt>
-                <c:pt idx="37">
-                  <c:v/>
-                </c:pt>
-                <c:pt idx="38">
-                  <c:v/>
-                </c:pt>
-                <c:pt idx="39">
-                  <c:v/>
-                </c:pt>
-                <c:pt idx="40">
-                  <c:v/>
-                </c:pt>
-                <c:pt idx="41">
-                  <c:v/>
-                </c:pt>
-                <c:pt idx="42">
-                  <c:v/>
-                </c:pt>
-                <c:pt idx="43">
-                  <c:v/>
-                </c:pt>
-                <c:pt idx="44">
-                  <c:v/>
-                </c:pt>
-                <c:pt idx="45">
-                  <c:v/>
-                </c:pt>
-                <c:pt idx="46">
-                  <c:v/>
-                </c:pt>
-                <c:pt idx="47">
-                  <c:v/>
-                </c:pt>
-                <c:pt idx="48">
-                  <c:v/>
-                </c:pt>
-                <c:pt idx="49">
-                  <c:v/>
-                </c:pt>
-                <c:pt idx="50">
-                  <c:v/>
-                </c:pt>
-                <c:pt idx="51">
-                  <c:v/>
-                </c:pt>
-                <c:pt idx="52">
-                  <c:v/>
-                </c:pt>
-                <c:pt idx="53">
-                  <c:v/>
-                </c:pt>
-                <c:pt idx="54">
-                  <c:v/>
-                </c:pt>
-                <c:pt idx="55">
-                  <c:v/>
-                </c:pt>
-                <c:pt idx="56">
-                  <c:v/>
-                </c:pt>
-                <c:pt idx="57">
-                  <c:v/>
-                </c:pt>
-                <c:pt idx="58">
-                  <c:v/>
-                </c:pt>
-                <c:pt idx="59">
-                  <c:v/>
-                </c:pt>
-                <c:pt idx="60">
-                  <c:v/>
-                </c:pt>
-                <c:pt idx="61">
-                  <c:v/>
-                </c:pt>
-                <c:pt idx="62">
-                  <c:v/>
-                </c:pt>
-                <c:pt idx="63">
-                  <c:v/>
-                </c:pt>
-                <c:pt idx="64">
-                  <c:v/>
-                </c:pt>
-                <c:pt idx="65">
-                  <c:v/>
-                </c:pt>
-                <c:pt idx="66">
-                  <c:v/>
-                </c:pt>
-                <c:pt idx="67">
-                  <c:v/>
-                </c:pt>
-                <c:pt idx="68">
-                  <c:v/>
-                </c:pt>
-                <c:pt idx="69">
-                  <c:v/>
-                </c:pt>
-                <c:pt idx="70">
-                  <c:v/>
-                </c:pt>
-                <c:pt idx="71">
-                  <c:v/>
-                </c:pt>
-                <c:pt idx="72">
-                  <c:v/>
-                </c:pt>
-                <c:pt idx="73">
-                  <c:v/>
-                </c:pt>
-                <c:pt idx="74">
-                  <c:v/>
-                </c:pt>
-              </c:numCache>
-            </c:numRef>
-          </c:yVal>
-          <c:smooth val="0"/>
-        </c:ser>
-        <c:ser>
-          <c:idx val="1"/>
-          <c:order val="1"/>
-          <c:tx>
-            <c:strRef>
-              <c:f>Sheet1!$C$1</c:f>
-              <c:strCache>
-                <c:ptCount val="1"/>
-                <c:pt idx="0">
                   <c:v>Other Sales</c:v>
                 </c:pt>
               </c:strCache>
@@ -663,16 +156,14 @@
             <a:effectLst/>
           </c:spPr>
           <c:marker>
-            <c:symbol val="square"/>
-            <c:size val="6"/>
+            <c:symbol val="circle"/>
+            <c:size val="5"/>
             <c:spPr>
               <a:solidFill>
-                <a:srgbClr val="A3ADB6"/>
+                <a:srgbClr val="DADEE2"/>
               </a:solidFill>
-              <a:ln w="9525">
-                <a:solidFill>
-                  <a:srgbClr val="A3ADB6"/>
-                </a:solidFill>
+              <a:ln>
+                <a:noFill/>
               </a:ln>
             </c:spPr>
           </c:marker>
@@ -683,226 +174,226 @@
                 <c:formatCode>General</c:formatCode>
                 <c:ptCount val="75"/>
                 <c:pt idx="0">
+                  <c:v>1790</c:v>
+                </c:pt>
+                <c:pt idx="1">
+                  <c:v>1810</c:v>
+                </c:pt>
+                <c:pt idx="2">
+                  <c:v>1702</c:v>
+                </c:pt>
+                <c:pt idx="3">
+                  <c:v>1880</c:v>
+                </c:pt>
+                <c:pt idx="4">
+                  <c:v>2260</c:v>
+                </c:pt>
+                <c:pt idx="5">
+                  <c:v>1950</c:v>
+                </c:pt>
+                <c:pt idx="6">
+                  <c:v>2380</c:v>
+                </c:pt>
+                <c:pt idx="7">
+                  <c:v>2150</c:v>
+                </c:pt>
+                <c:pt idx="8">
+                  <c:v>2380</c:v>
+                </c:pt>
+                <c:pt idx="9">
+                  <c:v>1740</c:v>
+                </c:pt>
+                <c:pt idx="10">
+                  <c:v>1880</c:v>
+                </c:pt>
+                <c:pt idx="11">
+                  <c:v>1950</c:v>
+                </c:pt>
+                <c:pt idx="12">
+                  <c:v>1740</c:v>
+                </c:pt>
+                <c:pt idx="13">
+                  <c:v>1450</c:v>
+                </c:pt>
+                <c:pt idx="14">
+                  <c:v>2150</c:v>
+                </c:pt>
+                <c:pt idx="15">
+                  <c:v>2380</c:v>
+                </c:pt>
+                <c:pt idx="16">
+                  <c:v>2260</c:v>
+                </c:pt>
+                <c:pt idx="17">
+                  <c:v>2380</c:v>
+                </c:pt>
+                <c:pt idx="18">
+                  <c:v>1740</c:v>
+                </c:pt>
+                <c:pt idx="19">
+                  <c:v>1450</c:v>
+                </c:pt>
+                <c:pt idx="20">
+                  <c:v>1610</c:v>
+                </c:pt>
+                <c:pt idx="21">
+                  <c:v>2380</c:v>
+                </c:pt>
+                <c:pt idx="22">
+                  <c:v>1820</c:v>
+                </c:pt>
+                <c:pt idx="23">
+                  <c:v>1880</c:v>
+                </c:pt>
+                <c:pt idx="24">
+                  <c:v>2040</c:v>
+                </c:pt>
+                <c:pt idx="25">
+                  <c:v>2380</c:v>
+                </c:pt>
+                <c:pt idx="26">
+                  <c:v>1610</c:v>
+                </c:pt>
+                <c:pt idx="27">
+                  <c:v>2380</c:v>
+                </c:pt>
+                <c:pt idx="28">
+                  <c:v>1849</c:v>
+                </c:pt>
+                <c:pt idx="29">
+                  <c:v>1943</c:v>
+                </c:pt>
+                <c:pt idx="30">
+                  <c:v>2400</c:v>
+                </c:pt>
+                <c:pt idx="31">
+                  <c:v>2400</c:v>
+                </c:pt>
+                <c:pt idx="32">
+                  <c:v>2400</c:v>
+                </c:pt>
+                <c:pt idx="33">
+                  <c:v>1650</c:v>
+                </c:pt>
+                <c:pt idx="34">
+                  <c:v>1500</c:v>
+                </c:pt>
+                <c:pt idx="35">
+                  <c:v>1650</c:v>
+                </c:pt>
+                <c:pt idx="36">
+                  <c:v>1900</c:v>
+                </c:pt>
+                <c:pt idx="37">
+                  <c:v>1650</c:v>
+                </c:pt>
+                <c:pt idx="38">
+                  <c:v>1900</c:v>
+                </c:pt>
+                <c:pt idx="39">
+                  <c:v>1650</c:v>
+                </c:pt>
+                <c:pt idx="40">
+                  <c:v>2100</c:v>
+                </c:pt>
+                <c:pt idx="41">
+                  <c:v>1450</c:v>
+                </c:pt>
+                <c:pt idx="42">
+                  <c:v>1485.1851851851852</c:v>
+                </c:pt>
+                <c:pt idx="43">
+                  <c:v>1520.3703703703704</c:v>
+                </c:pt>
+                <c:pt idx="44">
+                  <c:v>1555.5555555555557</c:v>
+                </c:pt>
+                <c:pt idx="45">
+                  <c:v>1590.7407407407406</c:v>
+                </c:pt>
+                <c:pt idx="46">
+                  <c:v>1625.9259259259259</c:v>
+                </c:pt>
+                <c:pt idx="47">
+                  <c:v>1661.111111111111</c:v>
+                </c:pt>
+                <c:pt idx="48">
+                  <c:v>1696.2962962962963</c:v>
+                </c:pt>
+                <c:pt idx="49">
+                  <c:v>1731.4814814814815</c:v>
+                </c:pt>
+                <c:pt idx="50">
+                  <c:v>1766.6666666666667</c:v>
+                </c:pt>
+                <c:pt idx="51">
+                  <c:v>1801.8518518518517</c:v>
+                </c:pt>
+                <c:pt idx="52">
+                  <c:v>1837.037037037037</c:v>
+                </c:pt>
+                <c:pt idx="53">
+                  <c:v>1872.2222222222222</c:v>
+                </c:pt>
+                <c:pt idx="54">
+                  <c:v>1907.4074074074074</c:v>
+                </c:pt>
+                <c:pt idx="55">
+                  <c:v>1942.5925925925926</c:v>
+                </c:pt>
+                <c:pt idx="56">
+                  <c:v>1977.7777777777778</c:v>
+                </c:pt>
+                <c:pt idx="57">
+                  <c:v>2012.962962962963</c:v>
+                </c:pt>
+                <c:pt idx="58">
+                  <c:v>2048.1481481481483</c:v>
+                </c:pt>
+                <c:pt idx="59">
+                  <c:v>2083.3333333333335</c:v>
+                </c:pt>
+                <c:pt idx="60">
+                  <c:v>2118.5185185185182</c:v>
+                </c:pt>
+                <c:pt idx="61">
+                  <c:v>2153.7037037037035</c:v>
+                </c:pt>
+                <c:pt idx="62">
+                  <c:v>2188.8888888888887</c:v>
+                </c:pt>
+                <c:pt idx="63">
+                  <c:v>2224.074074074074</c:v>
+                </c:pt>
+                <c:pt idx="64">
+                  <c:v>2259.259259259259</c:v>
+                </c:pt>
+                <c:pt idx="65">
+                  <c:v>2294.4444444444443</c:v>
+                </c:pt>
+                <c:pt idx="66">
+                  <c:v>2329.6296296296296</c:v>
+                </c:pt>
+                <c:pt idx="67">
+                  <c:v>2364.814814814815</c:v>
+                </c:pt>
+                <c:pt idx="68">
+                  <c:v>2400</c:v>
+                </c:pt>
+                <c:pt idx="69">
                   <c:v>1824</c:v>
                 </c:pt>
-                <c:pt idx="1">
+                <c:pt idx="70">
                   <c:v>1865</c:v>
                 </c:pt>
-                <c:pt idx="2">
+                <c:pt idx="71">
                   <c:v>1871</c:v>
                 </c:pt>
-                <c:pt idx="3">
+                <c:pt idx="72">
                   <c:v>1849</c:v>
                 </c:pt>
-                <c:pt idx="4">
+                <c:pt idx="73">
                   <c:v>1865</c:v>
-                </c:pt>
-                <c:pt idx="5">
-                  <c:v>1790</c:v>
-                </c:pt>
-                <c:pt idx="6">
-                  <c:v>1810</c:v>
-                </c:pt>
-                <c:pt idx="7">
-                  <c:v>1702</c:v>
-                </c:pt>
-                <c:pt idx="8">
-                  <c:v>1880</c:v>
-                </c:pt>
-                <c:pt idx="9">
-                  <c:v>2260</c:v>
-                </c:pt>
-                <c:pt idx="10">
-                  <c:v>1950</c:v>
-                </c:pt>
-                <c:pt idx="11">
-                  <c:v>2380</c:v>
-                </c:pt>
-                <c:pt idx="12">
-                  <c:v>2150</c:v>
-                </c:pt>
-                <c:pt idx="13">
-                  <c:v>2380</c:v>
-                </c:pt>
-                <c:pt idx="14">
-                  <c:v>1740</c:v>
-                </c:pt>
-                <c:pt idx="15">
-                  <c:v>1880</c:v>
-                </c:pt>
-                <c:pt idx="16">
-                  <c:v>1950</c:v>
-                </c:pt>
-                <c:pt idx="17">
-                  <c:v>1740</c:v>
-                </c:pt>
-                <c:pt idx="18">
-                  <c:v>1450</c:v>
-                </c:pt>
-                <c:pt idx="19">
-                  <c:v>2150</c:v>
-                </c:pt>
-                <c:pt idx="20">
-                  <c:v>2380</c:v>
-                </c:pt>
-                <c:pt idx="21">
-                  <c:v>2260</c:v>
-                </c:pt>
-                <c:pt idx="22">
-                  <c:v>2380</c:v>
-                </c:pt>
-                <c:pt idx="23">
-                  <c:v>1740</c:v>
-                </c:pt>
-                <c:pt idx="24">
-                  <c:v>1450</c:v>
-                </c:pt>
-                <c:pt idx="25">
-                  <c:v>1610</c:v>
-                </c:pt>
-                <c:pt idx="26">
-                  <c:v>2380</c:v>
-                </c:pt>
-                <c:pt idx="27">
-                  <c:v>1820</c:v>
-                </c:pt>
-                <c:pt idx="28">
-                  <c:v>1880</c:v>
-                </c:pt>
-                <c:pt idx="29">
-                  <c:v>2040</c:v>
-                </c:pt>
-                <c:pt idx="30">
-                  <c:v>2380</c:v>
-                </c:pt>
-                <c:pt idx="31">
-                  <c:v>1610</c:v>
-                </c:pt>
-                <c:pt idx="32">
-                  <c:v>2380</c:v>
-                </c:pt>
-                <c:pt idx="33">
-                  <c:v>1849</c:v>
-                </c:pt>
-                <c:pt idx="34">
-                  <c:v>1943</c:v>
-                </c:pt>
-                <c:pt idx="35">
-                  <c:v>2400</c:v>
-                </c:pt>
-                <c:pt idx="36">
-                  <c:v>2400</c:v>
-                </c:pt>
-                <c:pt idx="37">
-                  <c:v>2400</c:v>
-                </c:pt>
-                <c:pt idx="38">
-                  <c:v>1650</c:v>
-                </c:pt>
-                <c:pt idx="39">
-                  <c:v>1500</c:v>
-                </c:pt>
-                <c:pt idx="40">
-                  <c:v>1650</c:v>
-                </c:pt>
-                <c:pt idx="41">
-                  <c:v>1900</c:v>
-                </c:pt>
-                <c:pt idx="42">
-                  <c:v>1650</c:v>
-                </c:pt>
-                <c:pt idx="43">
-                  <c:v>1900</c:v>
-                </c:pt>
-                <c:pt idx="44">
-                  <c:v>1650</c:v>
-                </c:pt>
-                <c:pt idx="45">
-                  <c:v>2100</c:v>
-                </c:pt>
-                <c:pt idx="46">
-                  <c:v>1450</c:v>
-                </c:pt>
-                <c:pt idx="47">
-                  <c:v>1485.1851851851852</c:v>
-                </c:pt>
-                <c:pt idx="48">
-                  <c:v>1520.3703703703704</c:v>
-                </c:pt>
-                <c:pt idx="49">
-                  <c:v>1555.5555555555557</c:v>
-                </c:pt>
-                <c:pt idx="50">
-                  <c:v>1590.7407407407406</c:v>
-                </c:pt>
-                <c:pt idx="51">
-                  <c:v>1625.9259259259259</c:v>
-                </c:pt>
-                <c:pt idx="52">
-                  <c:v>1661.111111111111</c:v>
-                </c:pt>
-                <c:pt idx="53">
-                  <c:v>1696.2962962962963</c:v>
-                </c:pt>
-                <c:pt idx="54">
-                  <c:v>1731.4814814814815</c:v>
-                </c:pt>
-                <c:pt idx="55">
-                  <c:v>1766.6666666666667</c:v>
-                </c:pt>
-                <c:pt idx="56">
-                  <c:v>1801.8518518518517</c:v>
-                </c:pt>
-                <c:pt idx="57">
-                  <c:v>1837.037037037037</c:v>
-                </c:pt>
-                <c:pt idx="58">
-                  <c:v>1872.2222222222222</c:v>
-                </c:pt>
-                <c:pt idx="59">
-                  <c:v>1907.4074074074074</c:v>
-                </c:pt>
-                <c:pt idx="60">
-                  <c:v>1942.5925925925926</c:v>
-                </c:pt>
-                <c:pt idx="61">
-                  <c:v>1977.7777777777778</c:v>
-                </c:pt>
-                <c:pt idx="62">
-                  <c:v>2012.962962962963</c:v>
-                </c:pt>
-                <c:pt idx="63">
-                  <c:v>2048.1481481481483</c:v>
-                </c:pt>
-                <c:pt idx="64">
-                  <c:v>2083.3333333333335</c:v>
-                </c:pt>
-                <c:pt idx="65">
-                  <c:v>2118.5185185185182</c:v>
-                </c:pt>
-                <c:pt idx="66">
-                  <c:v>2153.7037037037035</c:v>
-                </c:pt>
-                <c:pt idx="67">
-                  <c:v>2188.8888888888887</c:v>
-                </c:pt>
-                <c:pt idx="68">
-                  <c:v>2224.074074074074</c:v>
-                </c:pt>
-                <c:pt idx="69">
-                  <c:v>2259.259259259259</c:v>
-                </c:pt>
-                <c:pt idx="70">
-                  <c:v>2294.4444444444443</c:v>
-                </c:pt>
-                <c:pt idx="71">
-                  <c:v>2329.6296296296296</c:v>
-                </c:pt>
-                <c:pt idx="72">
-                  <c:v>2364.814814814815</c:v>
-                </c:pt>
-                <c:pt idx="73">
-                  <c:v>2400</c:v>
                 </c:pt>
                 <c:pt idx="74">
                   <c:v>1849</c:v>
@@ -912,108 +403,108 @@
           </c:xVal>
           <c:yVal>
             <c:numRef>
-              <c:f>Sheet1!$C$2:$C$76</c:f>
+              <c:f>Sheet1!$B$2:$B$76</c:f>
               <c:numCache>
                 <c:formatCode>General</c:formatCode>
                 <c:ptCount val="75"/>
                 <c:pt idx="0">
-                  <c:v/>
+                  <c:v>427000</c:v>
                 </c:pt>
                 <c:pt idx="1">
-                  <c:v/>
+                  <c:v>435000</c:v>
                 </c:pt>
                 <c:pt idx="2">
-                  <c:v/>
+                  <c:v>470000</c:v>
                 </c:pt>
                 <c:pt idx="3">
-                  <c:v/>
+                  <c:v>454500</c:v>
                 </c:pt>
                 <c:pt idx="4">
-                  <c:v/>
+                  <c:v>559500</c:v>
                 </c:pt>
                 <c:pt idx="5">
-                  <c:v>427000</c:v>
+                  <c:v>446000</c:v>
                 </c:pt>
                 <c:pt idx="6">
-                  <c:v>435000</c:v>
+                  <c:v>575000</c:v>
                 </c:pt>
                 <c:pt idx="7">
-                  <c:v>470000</c:v>
+                  <c:v>529500</c:v>
                 </c:pt>
                 <c:pt idx="8">
-                  <c:v>454500</c:v>
+                  <c:v>516000</c:v>
                 </c:pt>
                 <c:pt idx="9">
-                  <c:v>559500</c:v>
+                  <c:v>364000</c:v>
                 </c:pt>
                 <c:pt idx="10">
-                  <c:v>446000</c:v>
+                  <c:v>429500</c:v>
                 </c:pt>
                 <c:pt idx="11">
-                  <c:v>575000</c:v>
+                  <c:v>473000</c:v>
                 </c:pt>
                 <c:pt idx="12">
-                  <c:v>529500</c:v>
+                  <c:v>391000</c:v>
                 </c:pt>
                 <c:pt idx="13">
-                  <c:v>516000</c:v>
+                  <c:v>325500</c:v>
                 </c:pt>
                 <c:pt idx="14">
-                  <c:v>364000</c:v>
+                  <c:v>493000</c:v>
                 </c:pt>
                 <c:pt idx="15">
-                  <c:v>429500</c:v>
+                  <c:v>578000</c:v>
                 </c:pt>
                 <c:pt idx="16">
-                  <c:v>473000</c:v>
+                  <c:v>549500</c:v>
                 </c:pt>
                 <c:pt idx="17">
-                  <c:v>391000</c:v>
+                  <c:v>596500</c:v>
                 </c:pt>
                 <c:pt idx="18">
-                  <c:v>325500</c:v>
+                  <c:v>444500</c:v>
                 </c:pt>
                 <c:pt idx="19">
-                  <c:v>493000</c:v>
+                  <c:v>361500</c:v>
                 </c:pt>
                 <c:pt idx="20">
-                  <c:v>578000</c:v>
+                  <c:v>398000</c:v>
                 </c:pt>
                 <c:pt idx="21">
-                  <c:v>549500</c:v>
+                  <c:v>526000</c:v>
                 </c:pt>
                 <c:pt idx="22">
-                  <c:v>596500</c:v>
+                  <c:v>396500</c:v>
                 </c:pt>
                 <c:pt idx="23">
-                  <c:v>444500</c:v>
+                  <c:v>461000</c:v>
                 </c:pt>
                 <c:pt idx="24">
-                  <c:v>361500</c:v>
+                  <c:v>477000</c:v>
                 </c:pt>
                 <c:pt idx="25">
-                  <c:v>398000</c:v>
+                  <c:v>535000</c:v>
                 </c:pt>
                 <c:pt idx="26">
-                  <c:v>526000</c:v>
+                  <c:v>367000</c:v>
                 </c:pt>
                 <c:pt idx="27">
-                  <c:v>396500</c:v>
+                  <c:v>570000</c:v>
                 </c:pt>
                 <c:pt idx="28">
-                  <c:v>461000</c:v>
+                  <c:v/>
                 </c:pt>
                 <c:pt idx="29">
-                  <c:v>477000</c:v>
+                  <c:v/>
                 </c:pt>
                 <c:pt idx="30">
-                  <c:v>535000</c:v>
+                  <c:v/>
                 </c:pt>
                 <c:pt idx="31">
-                  <c:v>367000</c:v>
+                  <c:v/>
                 </c:pt>
                 <c:pt idx="32">
-                  <c:v>570000</c:v>
+                  <c:v/>
                 </c:pt>
                 <c:pt idx="33">
                   <c:v/>
@@ -1147,11 +638,11 @@
           <c:smooth val="0"/>
         </c:ser>
         <c:ser>
-          <c:idx val="2"/>
-          <c:order val="2"/>
+          <c:idx val="1"/>
+          <c:order val="1"/>
           <c:tx>
             <c:strRef>
-              <c:f>Sheet1!$D$1</c:f>
+              <c:f>Sheet1!$C$1</c:f>
               <c:strCache>
                 <c:ptCount val="1"/>
                 <c:pt idx="0">
@@ -1174,7 +665,7 @@
             <c:size val="7"/>
             <c:spPr>
               <a:solidFill>
-                <a:srgbClr val="DADEE2"/>
+                <a:srgbClr val="A3ADB6"/>
               </a:solidFill>
               <a:ln w="15875">
                 <a:solidFill>
@@ -1190,226 +681,226 @@
                 <c:formatCode>General</c:formatCode>
                 <c:ptCount val="75"/>
                 <c:pt idx="0">
+                  <c:v>1790</c:v>
+                </c:pt>
+                <c:pt idx="1">
+                  <c:v>1810</c:v>
+                </c:pt>
+                <c:pt idx="2">
+                  <c:v>1702</c:v>
+                </c:pt>
+                <c:pt idx="3">
+                  <c:v>1880</c:v>
+                </c:pt>
+                <c:pt idx="4">
+                  <c:v>2260</c:v>
+                </c:pt>
+                <c:pt idx="5">
+                  <c:v>1950</c:v>
+                </c:pt>
+                <c:pt idx="6">
+                  <c:v>2380</c:v>
+                </c:pt>
+                <c:pt idx="7">
+                  <c:v>2150</c:v>
+                </c:pt>
+                <c:pt idx="8">
+                  <c:v>2380</c:v>
+                </c:pt>
+                <c:pt idx="9">
+                  <c:v>1740</c:v>
+                </c:pt>
+                <c:pt idx="10">
+                  <c:v>1880</c:v>
+                </c:pt>
+                <c:pt idx="11">
+                  <c:v>1950</c:v>
+                </c:pt>
+                <c:pt idx="12">
+                  <c:v>1740</c:v>
+                </c:pt>
+                <c:pt idx="13">
+                  <c:v>1450</c:v>
+                </c:pt>
+                <c:pt idx="14">
+                  <c:v>2150</c:v>
+                </c:pt>
+                <c:pt idx="15">
+                  <c:v>2380</c:v>
+                </c:pt>
+                <c:pt idx="16">
+                  <c:v>2260</c:v>
+                </c:pt>
+                <c:pt idx="17">
+                  <c:v>2380</c:v>
+                </c:pt>
+                <c:pt idx="18">
+                  <c:v>1740</c:v>
+                </c:pt>
+                <c:pt idx="19">
+                  <c:v>1450</c:v>
+                </c:pt>
+                <c:pt idx="20">
+                  <c:v>1610</c:v>
+                </c:pt>
+                <c:pt idx="21">
+                  <c:v>2380</c:v>
+                </c:pt>
+                <c:pt idx="22">
+                  <c:v>1820</c:v>
+                </c:pt>
+                <c:pt idx="23">
+                  <c:v>1880</c:v>
+                </c:pt>
+                <c:pt idx="24">
+                  <c:v>2040</c:v>
+                </c:pt>
+                <c:pt idx="25">
+                  <c:v>2380</c:v>
+                </c:pt>
+                <c:pt idx="26">
+                  <c:v>1610</c:v>
+                </c:pt>
+                <c:pt idx="27">
+                  <c:v>2380</c:v>
+                </c:pt>
+                <c:pt idx="28">
+                  <c:v>1849</c:v>
+                </c:pt>
+                <c:pt idx="29">
+                  <c:v>1943</c:v>
+                </c:pt>
+                <c:pt idx="30">
+                  <c:v>2400</c:v>
+                </c:pt>
+                <c:pt idx="31">
+                  <c:v>2400</c:v>
+                </c:pt>
+                <c:pt idx="32">
+                  <c:v>2400</c:v>
+                </c:pt>
+                <c:pt idx="33">
+                  <c:v>1650</c:v>
+                </c:pt>
+                <c:pt idx="34">
+                  <c:v>1500</c:v>
+                </c:pt>
+                <c:pt idx="35">
+                  <c:v>1650</c:v>
+                </c:pt>
+                <c:pt idx="36">
+                  <c:v>1900</c:v>
+                </c:pt>
+                <c:pt idx="37">
+                  <c:v>1650</c:v>
+                </c:pt>
+                <c:pt idx="38">
+                  <c:v>1900</c:v>
+                </c:pt>
+                <c:pt idx="39">
+                  <c:v>1650</c:v>
+                </c:pt>
+                <c:pt idx="40">
+                  <c:v>2100</c:v>
+                </c:pt>
+                <c:pt idx="41">
+                  <c:v>1450</c:v>
+                </c:pt>
+                <c:pt idx="42">
+                  <c:v>1485.1851851851852</c:v>
+                </c:pt>
+                <c:pt idx="43">
+                  <c:v>1520.3703703703704</c:v>
+                </c:pt>
+                <c:pt idx="44">
+                  <c:v>1555.5555555555557</c:v>
+                </c:pt>
+                <c:pt idx="45">
+                  <c:v>1590.7407407407406</c:v>
+                </c:pt>
+                <c:pt idx="46">
+                  <c:v>1625.9259259259259</c:v>
+                </c:pt>
+                <c:pt idx="47">
+                  <c:v>1661.111111111111</c:v>
+                </c:pt>
+                <c:pt idx="48">
+                  <c:v>1696.2962962962963</c:v>
+                </c:pt>
+                <c:pt idx="49">
+                  <c:v>1731.4814814814815</c:v>
+                </c:pt>
+                <c:pt idx="50">
+                  <c:v>1766.6666666666667</c:v>
+                </c:pt>
+                <c:pt idx="51">
+                  <c:v>1801.8518518518517</c:v>
+                </c:pt>
+                <c:pt idx="52">
+                  <c:v>1837.037037037037</c:v>
+                </c:pt>
+                <c:pt idx="53">
+                  <c:v>1872.2222222222222</c:v>
+                </c:pt>
+                <c:pt idx="54">
+                  <c:v>1907.4074074074074</c:v>
+                </c:pt>
+                <c:pt idx="55">
+                  <c:v>1942.5925925925926</c:v>
+                </c:pt>
+                <c:pt idx="56">
+                  <c:v>1977.7777777777778</c:v>
+                </c:pt>
+                <c:pt idx="57">
+                  <c:v>2012.962962962963</c:v>
+                </c:pt>
+                <c:pt idx="58">
+                  <c:v>2048.1481481481483</c:v>
+                </c:pt>
+                <c:pt idx="59">
+                  <c:v>2083.3333333333335</c:v>
+                </c:pt>
+                <c:pt idx="60">
+                  <c:v>2118.5185185185182</c:v>
+                </c:pt>
+                <c:pt idx="61">
+                  <c:v>2153.7037037037035</c:v>
+                </c:pt>
+                <c:pt idx="62">
+                  <c:v>2188.8888888888887</c:v>
+                </c:pt>
+                <c:pt idx="63">
+                  <c:v>2224.074074074074</c:v>
+                </c:pt>
+                <c:pt idx="64">
+                  <c:v>2259.259259259259</c:v>
+                </c:pt>
+                <c:pt idx="65">
+                  <c:v>2294.4444444444443</c:v>
+                </c:pt>
+                <c:pt idx="66">
+                  <c:v>2329.6296296296296</c:v>
+                </c:pt>
+                <c:pt idx="67">
+                  <c:v>2364.814814814815</c:v>
+                </c:pt>
+                <c:pt idx="68">
+                  <c:v>2400</c:v>
+                </c:pt>
+                <c:pt idx="69">
                   <c:v>1824</c:v>
                 </c:pt>
-                <c:pt idx="1">
+                <c:pt idx="70">
                   <c:v>1865</c:v>
                 </c:pt>
-                <c:pt idx="2">
+                <c:pt idx="71">
                   <c:v>1871</c:v>
                 </c:pt>
-                <c:pt idx="3">
+                <c:pt idx="72">
                   <c:v>1849</c:v>
                 </c:pt>
-                <c:pt idx="4">
+                <c:pt idx="73">
                   <c:v>1865</c:v>
-                </c:pt>
-                <c:pt idx="5">
-                  <c:v>1790</c:v>
-                </c:pt>
-                <c:pt idx="6">
-                  <c:v>1810</c:v>
-                </c:pt>
-                <c:pt idx="7">
-                  <c:v>1702</c:v>
-                </c:pt>
-                <c:pt idx="8">
-                  <c:v>1880</c:v>
-                </c:pt>
-                <c:pt idx="9">
-                  <c:v>2260</c:v>
-                </c:pt>
-                <c:pt idx="10">
-                  <c:v>1950</c:v>
-                </c:pt>
-                <c:pt idx="11">
-                  <c:v>2380</c:v>
-                </c:pt>
-                <c:pt idx="12">
-                  <c:v>2150</c:v>
-                </c:pt>
-                <c:pt idx="13">
-                  <c:v>2380</c:v>
-                </c:pt>
-                <c:pt idx="14">
-                  <c:v>1740</c:v>
-                </c:pt>
-                <c:pt idx="15">
-                  <c:v>1880</c:v>
-                </c:pt>
-                <c:pt idx="16">
-                  <c:v>1950</c:v>
-                </c:pt>
-                <c:pt idx="17">
-                  <c:v>1740</c:v>
-                </c:pt>
-                <c:pt idx="18">
-                  <c:v>1450</c:v>
-                </c:pt>
-                <c:pt idx="19">
-                  <c:v>2150</c:v>
-                </c:pt>
-                <c:pt idx="20">
-                  <c:v>2380</c:v>
-                </c:pt>
-                <c:pt idx="21">
-                  <c:v>2260</c:v>
-                </c:pt>
-                <c:pt idx="22">
-                  <c:v>2380</c:v>
-                </c:pt>
-                <c:pt idx="23">
-                  <c:v>1740</c:v>
-                </c:pt>
-                <c:pt idx="24">
-                  <c:v>1450</c:v>
-                </c:pt>
-                <c:pt idx="25">
-                  <c:v>1610</c:v>
-                </c:pt>
-                <c:pt idx="26">
-                  <c:v>2380</c:v>
-                </c:pt>
-                <c:pt idx="27">
-                  <c:v>1820</c:v>
-                </c:pt>
-                <c:pt idx="28">
-                  <c:v>1880</c:v>
-                </c:pt>
-                <c:pt idx="29">
-                  <c:v>2040</c:v>
-                </c:pt>
-                <c:pt idx="30">
-                  <c:v>2380</c:v>
-                </c:pt>
-                <c:pt idx="31">
-                  <c:v>1610</c:v>
-                </c:pt>
-                <c:pt idx="32">
-                  <c:v>2380</c:v>
-                </c:pt>
-                <c:pt idx="33">
-                  <c:v>1849</c:v>
-                </c:pt>
-                <c:pt idx="34">
-                  <c:v>1943</c:v>
-                </c:pt>
-                <c:pt idx="35">
-                  <c:v>2400</c:v>
-                </c:pt>
-                <c:pt idx="36">
-                  <c:v>2400</c:v>
-                </c:pt>
-                <c:pt idx="37">
-                  <c:v>2400</c:v>
-                </c:pt>
-                <c:pt idx="38">
-                  <c:v>1650</c:v>
-                </c:pt>
-                <c:pt idx="39">
-                  <c:v>1500</c:v>
-                </c:pt>
-                <c:pt idx="40">
-                  <c:v>1650</c:v>
-                </c:pt>
-                <c:pt idx="41">
-                  <c:v>1900</c:v>
-                </c:pt>
-                <c:pt idx="42">
-                  <c:v>1650</c:v>
-                </c:pt>
-                <c:pt idx="43">
-                  <c:v>1900</c:v>
-                </c:pt>
-                <c:pt idx="44">
-                  <c:v>1650</c:v>
-                </c:pt>
-                <c:pt idx="45">
-                  <c:v>2100</c:v>
-                </c:pt>
-                <c:pt idx="46">
-                  <c:v>1450</c:v>
-                </c:pt>
-                <c:pt idx="47">
-                  <c:v>1485.1851851851852</c:v>
-                </c:pt>
-                <c:pt idx="48">
-                  <c:v>1520.3703703703704</c:v>
-                </c:pt>
-                <c:pt idx="49">
-                  <c:v>1555.5555555555557</c:v>
-                </c:pt>
-                <c:pt idx="50">
-                  <c:v>1590.7407407407406</c:v>
-                </c:pt>
-                <c:pt idx="51">
-                  <c:v>1625.9259259259259</c:v>
-                </c:pt>
-                <c:pt idx="52">
-                  <c:v>1661.111111111111</c:v>
-                </c:pt>
-                <c:pt idx="53">
-                  <c:v>1696.2962962962963</c:v>
-                </c:pt>
-                <c:pt idx="54">
-                  <c:v>1731.4814814814815</c:v>
-                </c:pt>
-                <c:pt idx="55">
-                  <c:v>1766.6666666666667</c:v>
-                </c:pt>
-                <c:pt idx="56">
-                  <c:v>1801.8518518518517</c:v>
-                </c:pt>
-                <c:pt idx="57">
-                  <c:v>1837.037037037037</c:v>
-                </c:pt>
-                <c:pt idx="58">
-                  <c:v>1872.2222222222222</c:v>
-                </c:pt>
-                <c:pt idx="59">
-                  <c:v>1907.4074074074074</c:v>
-                </c:pt>
-                <c:pt idx="60">
-                  <c:v>1942.5925925925926</c:v>
-                </c:pt>
-                <c:pt idx="61">
-                  <c:v>1977.7777777777778</c:v>
-                </c:pt>
-                <c:pt idx="62">
-                  <c:v>2012.962962962963</c:v>
-                </c:pt>
-                <c:pt idx="63">
-                  <c:v>2048.1481481481483</c:v>
-                </c:pt>
-                <c:pt idx="64">
-                  <c:v>2083.3333333333335</c:v>
-                </c:pt>
-                <c:pt idx="65">
-                  <c:v>2118.5185185185182</c:v>
-                </c:pt>
-                <c:pt idx="66">
-                  <c:v>2153.7037037037035</c:v>
-                </c:pt>
-                <c:pt idx="67">
-                  <c:v>2188.8888888888887</c:v>
-                </c:pt>
-                <c:pt idx="68">
-                  <c:v>2224.074074074074</c:v>
-                </c:pt>
-                <c:pt idx="69">
-                  <c:v>2259.259259259259</c:v>
-                </c:pt>
-                <c:pt idx="70">
-                  <c:v>2294.4444444444443</c:v>
-                </c:pt>
-                <c:pt idx="71">
-                  <c:v>2329.6296296296296</c:v>
-                </c:pt>
-                <c:pt idx="72">
-                  <c:v>2364.814814814815</c:v>
-                </c:pt>
-                <c:pt idx="73">
-                  <c:v>2400</c:v>
                 </c:pt>
                 <c:pt idx="74">
                   <c:v>1849</c:v>
@@ -1419,7 +910,7 @@
           </c:xVal>
           <c:yVal>
             <c:numRef>
-              <c:f>Sheet1!$D$2:$D$76</c:f>
+              <c:f>Sheet1!$C$2:$C$76</c:f>
               <c:numCache>
                 <c:formatCode>General</c:formatCode>
                 <c:ptCount val="75"/>
@@ -1508,58 +999,58 @@
                   <c:v/>
                 </c:pt>
                 <c:pt idx="28">
-                  <c:v/>
+                  <c:v>400000</c:v>
                 </c:pt>
                 <c:pt idx="29">
-                  <c:v/>
+                  <c:v>565000</c:v>
                 </c:pt>
                 <c:pt idx="30">
-                  <c:v/>
+                  <c:v>470000</c:v>
                 </c:pt>
                 <c:pt idx="31">
-                  <c:v/>
+                  <c:v>449000</c:v>
                 </c:pt>
                 <c:pt idx="32">
-                  <c:v/>
+                  <c:v>490000</c:v>
                 </c:pt>
                 <c:pt idx="33">
-                  <c:v>400000</c:v>
+                  <c:v>391900</c:v>
                 </c:pt>
                 <c:pt idx="34">
-                  <c:v>565000</c:v>
+                  <c:v>368900</c:v>
                 </c:pt>
                 <c:pt idx="35">
-                  <c:v>470000</c:v>
+                  <c:v>390900</c:v>
                 </c:pt>
                 <c:pt idx="36">
-                  <c:v>449000</c:v>
+                  <c:v>486900</c:v>
                 </c:pt>
                 <c:pt idx="37">
-                  <c:v>490000</c:v>
+                  <c:v>388900</c:v>
                 </c:pt>
                 <c:pt idx="38">
-                  <c:v>391900</c:v>
+                  <c:v>464900</c:v>
                 </c:pt>
                 <c:pt idx="39">
-                  <c:v>368900</c:v>
+                  <c:v>425900</c:v>
                 </c:pt>
                 <c:pt idx="40">
-                  <c:v>390900</c:v>
+                  <c:v>530900</c:v>
                 </c:pt>
                 <c:pt idx="41">
-                  <c:v>486900</c:v>
+                  <c:v/>
                 </c:pt>
                 <c:pt idx="42">
-                  <c:v>388900</c:v>
+                  <c:v/>
                 </c:pt>
                 <c:pt idx="43">
-                  <c:v>464900</c:v>
+                  <c:v/>
                 </c:pt>
                 <c:pt idx="44">
-                  <c:v>425900</c:v>
+                  <c:v/>
                 </c:pt>
                 <c:pt idx="45">
-                  <c:v>530900</c:v>
+                  <c:v/>
                 </c:pt>
                 <c:pt idx="46">
                   <c:v/>
@@ -1654,11 +1145,11 @@
           <c:smooth val="0"/>
         </c:ser>
         <c:ser>
-          <c:idx val="3"/>
-          <c:order val="3"/>
+          <c:idx val="2"/>
+          <c:order val="2"/>
           <c:tx>
             <c:strRef>
-              <c:f>Sheet1!$E$1</c:f>
+              <c:f>Sheet1!$D$1</c:f>
               <c:strCache>
                 <c:ptCount val="1"/>
                 <c:pt idx="0">
@@ -1689,226 +1180,733 @@
                 <c:formatCode>General</c:formatCode>
                 <c:ptCount val="75"/>
                 <c:pt idx="0">
+                  <c:v>1790</c:v>
+                </c:pt>
+                <c:pt idx="1">
+                  <c:v>1810</c:v>
+                </c:pt>
+                <c:pt idx="2">
+                  <c:v>1702</c:v>
+                </c:pt>
+                <c:pt idx="3">
+                  <c:v>1880</c:v>
+                </c:pt>
+                <c:pt idx="4">
+                  <c:v>2260</c:v>
+                </c:pt>
+                <c:pt idx="5">
+                  <c:v>1950</c:v>
+                </c:pt>
+                <c:pt idx="6">
+                  <c:v>2380</c:v>
+                </c:pt>
+                <c:pt idx="7">
+                  <c:v>2150</c:v>
+                </c:pt>
+                <c:pt idx="8">
+                  <c:v>2380</c:v>
+                </c:pt>
+                <c:pt idx="9">
+                  <c:v>1740</c:v>
+                </c:pt>
+                <c:pt idx="10">
+                  <c:v>1880</c:v>
+                </c:pt>
+                <c:pt idx="11">
+                  <c:v>1950</c:v>
+                </c:pt>
+                <c:pt idx="12">
+                  <c:v>1740</c:v>
+                </c:pt>
+                <c:pt idx="13">
+                  <c:v>1450</c:v>
+                </c:pt>
+                <c:pt idx="14">
+                  <c:v>2150</c:v>
+                </c:pt>
+                <c:pt idx="15">
+                  <c:v>2380</c:v>
+                </c:pt>
+                <c:pt idx="16">
+                  <c:v>2260</c:v>
+                </c:pt>
+                <c:pt idx="17">
+                  <c:v>2380</c:v>
+                </c:pt>
+                <c:pt idx="18">
+                  <c:v>1740</c:v>
+                </c:pt>
+                <c:pt idx="19">
+                  <c:v>1450</c:v>
+                </c:pt>
+                <c:pt idx="20">
+                  <c:v>1610</c:v>
+                </c:pt>
+                <c:pt idx="21">
+                  <c:v>2380</c:v>
+                </c:pt>
+                <c:pt idx="22">
+                  <c:v>1820</c:v>
+                </c:pt>
+                <c:pt idx="23">
+                  <c:v>1880</c:v>
+                </c:pt>
+                <c:pt idx="24">
+                  <c:v>2040</c:v>
+                </c:pt>
+                <c:pt idx="25">
+                  <c:v>2380</c:v>
+                </c:pt>
+                <c:pt idx="26">
+                  <c:v>1610</c:v>
+                </c:pt>
+                <c:pt idx="27">
+                  <c:v>2380</c:v>
+                </c:pt>
+                <c:pt idx="28">
+                  <c:v>1849</c:v>
+                </c:pt>
+                <c:pt idx="29">
+                  <c:v>1943</c:v>
+                </c:pt>
+                <c:pt idx="30">
+                  <c:v>2400</c:v>
+                </c:pt>
+                <c:pt idx="31">
+                  <c:v>2400</c:v>
+                </c:pt>
+                <c:pt idx="32">
+                  <c:v>2400</c:v>
+                </c:pt>
+                <c:pt idx="33">
+                  <c:v>1650</c:v>
+                </c:pt>
+                <c:pt idx="34">
+                  <c:v>1500</c:v>
+                </c:pt>
+                <c:pt idx="35">
+                  <c:v>1650</c:v>
+                </c:pt>
+                <c:pt idx="36">
+                  <c:v>1900</c:v>
+                </c:pt>
+                <c:pt idx="37">
+                  <c:v>1650</c:v>
+                </c:pt>
+                <c:pt idx="38">
+                  <c:v>1900</c:v>
+                </c:pt>
+                <c:pt idx="39">
+                  <c:v>1650</c:v>
+                </c:pt>
+                <c:pt idx="40">
+                  <c:v>2100</c:v>
+                </c:pt>
+                <c:pt idx="41">
+                  <c:v>1450</c:v>
+                </c:pt>
+                <c:pt idx="42">
+                  <c:v>1485.1851851851852</c:v>
+                </c:pt>
+                <c:pt idx="43">
+                  <c:v>1520.3703703703704</c:v>
+                </c:pt>
+                <c:pt idx="44">
+                  <c:v>1555.5555555555557</c:v>
+                </c:pt>
+                <c:pt idx="45">
+                  <c:v>1590.7407407407406</c:v>
+                </c:pt>
+                <c:pt idx="46">
+                  <c:v>1625.9259259259259</c:v>
+                </c:pt>
+                <c:pt idx="47">
+                  <c:v>1661.111111111111</c:v>
+                </c:pt>
+                <c:pt idx="48">
+                  <c:v>1696.2962962962963</c:v>
+                </c:pt>
+                <c:pt idx="49">
+                  <c:v>1731.4814814814815</c:v>
+                </c:pt>
+                <c:pt idx="50">
+                  <c:v>1766.6666666666667</c:v>
+                </c:pt>
+                <c:pt idx="51">
+                  <c:v>1801.8518518518517</c:v>
+                </c:pt>
+                <c:pt idx="52">
+                  <c:v>1837.037037037037</c:v>
+                </c:pt>
+                <c:pt idx="53">
+                  <c:v>1872.2222222222222</c:v>
+                </c:pt>
+                <c:pt idx="54">
+                  <c:v>1907.4074074074074</c:v>
+                </c:pt>
+                <c:pt idx="55">
+                  <c:v>1942.5925925925926</c:v>
+                </c:pt>
+                <c:pt idx="56">
+                  <c:v>1977.7777777777778</c:v>
+                </c:pt>
+                <c:pt idx="57">
+                  <c:v>2012.962962962963</c:v>
+                </c:pt>
+                <c:pt idx="58">
+                  <c:v>2048.1481481481483</c:v>
+                </c:pt>
+                <c:pt idx="59">
+                  <c:v>2083.3333333333335</c:v>
+                </c:pt>
+                <c:pt idx="60">
+                  <c:v>2118.5185185185182</c:v>
+                </c:pt>
+                <c:pt idx="61">
+                  <c:v>2153.7037037037035</c:v>
+                </c:pt>
+                <c:pt idx="62">
+                  <c:v>2188.8888888888887</c:v>
+                </c:pt>
+                <c:pt idx="63">
+                  <c:v>2224.074074074074</c:v>
+                </c:pt>
+                <c:pt idx="64">
+                  <c:v>2259.259259259259</c:v>
+                </c:pt>
+                <c:pt idx="65">
+                  <c:v>2294.4444444444443</c:v>
+                </c:pt>
+                <c:pt idx="66">
+                  <c:v>2329.6296296296296</c:v>
+                </c:pt>
+                <c:pt idx="67">
+                  <c:v>2364.814814814815</c:v>
+                </c:pt>
+                <c:pt idx="68">
+                  <c:v>2400</c:v>
+                </c:pt>
+                <c:pt idx="69">
                   <c:v>1824</c:v>
                 </c:pt>
+                <c:pt idx="70">
+                  <c:v>1865</c:v>
+                </c:pt>
+                <c:pt idx="71">
+                  <c:v>1871</c:v>
+                </c:pt>
+                <c:pt idx="72">
+                  <c:v>1849</c:v>
+                </c:pt>
+                <c:pt idx="73">
+                  <c:v>1865</c:v>
+                </c:pt>
+                <c:pt idx="74">
+                  <c:v>1849</c:v>
+                </c:pt>
+              </c:numCache>
+            </c:numRef>
+          </c:xVal>
+          <c:yVal>
+            <c:numRef>
+              <c:f>Sheet1!$D$2:$D$76</c:f>
+              <c:numCache>
+                <c:formatCode>General</c:formatCode>
+                <c:ptCount val="75"/>
+                <c:pt idx="0">
+                  <c:v/>
+                </c:pt>
                 <c:pt idx="1">
+                  <c:v/>
+                </c:pt>
+                <c:pt idx="2">
+                  <c:v/>
+                </c:pt>
+                <c:pt idx="3">
+                  <c:v/>
+                </c:pt>
+                <c:pt idx="4">
+                  <c:v/>
+                </c:pt>
+                <c:pt idx="5">
+                  <c:v/>
+                </c:pt>
+                <c:pt idx="6">
+                  <c:v/>
+                </c:pt>
+                <c:pt idx="7">
+                  <c:v/>
+                </c:pt>
+                <c:pt idx="8">
+                  <c:v/>
+                </c:pt>
+                <c:pt idx="9">
+                  <c:v/>
+                </c:pt>
+                <c:pt idx="10">
+                  <c:v/>
+                </c:pt>
+                <c:pt idx="11">
+                  <c:v/>
+                </c:pt>
+                <c:pt idx="12">
+                  <c:v/>
+                </c:pt>
+                <c:pt idx="13">
+                  <c:v/>
+                </c:pt>
+                <c:pt idx="14">
+                  <c:v/>
+                </c:pt>
+                <c:pt idx="15">
+                  <c:v/>
+                </c:pt>
+                <c:pt idx="16">
+                  <c:v/>
+                </c:pt>
+                <c:pt idx="17">
+                  <c:v/>
+                </c:pt>
+                <c:pt idx="18">
+                  <c:v/>
+                </c:pt>
+                <c:pt idx="19">
+                  <c:v/>
+                </c:pt>
+                <c:pt idx="20">
+                  <c:v/>
+                </c:pt>
+                <c:pt idx="21">
+                  <c:v/>
+                </c:pt>
+                <c:pt idx="22">
+                  <c:v/>
+                </c:pt>
+                <c:pt idx="23">
+                  <c:v/>
+                </c:pt>
+                <c:pt idx="24">
+                  <c:v/>
+                </c:pt>
+                <c:pt idx="25">
+                  <c:v/>
+                </c:pt>
+                <c:pt idx="26">
+                  <c:v/>
+                </c:pt>
+                <c:pt idx="27">
+                  <c:v/>
+                </c:pt>
+                <c:pt idx="28">
+                  <c:v/>
+                </c:pt>
+                <c:pt idx="29">
+                  <c:v/>
+                </c:pt>
+                <c:pt idx="30">
+                  <c:v/>
+                </c:pt>
+                <c:pt idx="31">
+                  <c:v/>
+                </c:pt>
+                <c:pt idx="32">
+                  <c:v/>
+                </c:pt>
+                <c:pt idx="33">
+                  <c:v/>
+                </c:pt>
+                <c:pt idx="34">
+                  <c:v/>
+                </c:pt>
+                <c:pt idx="35">
+                  <c:v/>
+                </c:pt>
+                <c:pt idx="36">
+                  <c:v/>
+                </c:pt>
+                <c:pt idx="37">
+                  <c:v/>
+                </c:pt>
+                <c:pt idx="38">
+                  <c:v/>
+                </c:pt>
+                <c:pt idx="39">
+                  <c:v/>
+                </c:pt>
+                <c:pt idx="40">
+                  <c:v/>
+                </c:pt>
+                <c:pt idx="41">
+                  <c:v>353370.74537409266</c:v>
+                </c:pt>
+                <c:pt idx="42">
+                  <c:v>361279.9692978465</c:v>
+                </c:pt>
+                <c:pt idx="43">
+                  <c:v>369189.1932216004</c:v>
+                </c:pt>
+                <c:pt idx="44">
+                  <c:v>377098.41714535427</c:v>
+                </c:pt>
+                <c:pt idx="45">
+                  <c:v>385007.6410691081</c:v>
+                </c:pt>
+                <c:pt idx="46">
+                  <c:v>392916.864992862</c:v>
+                </c:pt>
+                <c:pt idx="47">
+                  <c:v>400826.0889166159</c:v>
+                </c:pt>
+                <c:pt idx="48">
+                  <c:v>408735.31284036976</c:v>
+                </c:pt>
+                <c:pt idx="49">
+                  <c:v>416644.53676412365</c:v>
+                </c:pt>
+                <c:pt idx="50">
+                  <c:v>424553.7606878775</c:v>
+                </c:pt>
+                <c:pt idx="51">
+                  <c:v>432462.9846116313</c:v>
+                </c:pt>
+                <c:pt idx="52">
+                  <c:v>440372.2085353852</c:v>
+                </c:pt>
+                <c:pt idx="53">
+                  <c:v>448281.4324591391</c:v>
+                </c:pt>
+                <c:pt idx="54">
+                  <c:v>456190.656382893</c:v>
+                </c:pt>
+                <c:pt idx="55">
+                  <c:v>464099.88030664687</c:v>
+                </c:pt>
+                <c:pt idx="56">
+                  <c:v>472009.10423040076</c:v>
+                </c:pt>
+                <c:pt idx="57">
+                  <c:v>479918.32815415465</c:v>
+                </c:pt>
+                <c:pt idx="58">
+                  <c:v>487827.5520779085</c:v>
+                </c:pt>
+                <c:pt idx="59">
+                  <c:v>495736.77600166237</c:v>
+                </c:pt>
+                <c:pt idx="60">
+                  <c:v>503645.99992541614</c:v>
+                </c:pt>
+                <c:pt idx="61">
+                  <c:v>511555.22384917</c:v>
+                </c:pt>
+                <c:pt idx="62">
+                  <c:v>519464.4477729239</c:v>
+                </c:pt>
+                <c:pt idx="63">
+                  <c:v>527373.6716966778</c:v>
+                </c:pt>
+                <c:pt idx="64">
+                  <c:v>535282.8956204318</c:v>
+                </c:pt>
+                <c:pt idx="65">
+                  <c:v>543192.1195441856</c:v>
+                </c:pt>
+                <c:pt idx="66">
+                  <c:v>551101.3434679394</c:v>
+                </c:pt>
+                <c:pt idx="67">
+                  <c:v>559010.5673916934</c:v>
+                </c:pt>
+                <c:pt idx="68">
+                  <c:v>566919.7913154473</c:v>
+                </c:pt>
+                <c:pt idx="69">
+                  <c:v/>
+                </c:pt>
+                <c:pt idx="70">
+                  <c:v/>
+                </c:pt>
+                <c:pt idx="71">
+                  <c:v/>
+                </c:pt>
+                <c:pt idx="72">
+                  <c:v/>
+                </c:pt>
+                <c:pt idx="73">
+                  <c:v/>
+                </c:pt>
+                <c:pt idx="74">
+                  <c:v/>
+                </c:pt>
+              </c:numCache>
+            </c:numRef>
+          </c:yVal>
+          <c:smooth val="0"/>
+        </c:ser>
+        <c:ser>
+          <c:idx val="3"/>
+          <c:order val="3"/>
+          <c:tx>
+            <c:strRef>
+              <c:f>Sheet1!$E$1</c:f>
+              <c:strCache>
+                <c:ptCount val="1"/>
+                <c:pt idx="0">
+                  <c:v>Comparable Sales</c:v>
+                </c:pt>
+              </c:strCache>
+            </c:strRef>
+          </c:tx>
+          <c:spPr>
+            <a:solidFill>
+              <a:srgbClr val="C2410C"/>
+            </a:solidFill>
+            <a:ln>
+              <a:noFill/>
+            </a:ln>
+            <a:effectLst/>
+          </c:spPr>
+          <c:marker>
+            <c:symbol val="circle"/>
+            <c:size val="8"/>
+            <c:spPr>
+              <a:solidFill>
+                <a:srgbClr val="C2410C"/>
+              </a:solidFill>
+              <a:ln w="9525">
+                <a:solidFill>
+                  <a:srgbClr val="C2410C"/>
+                </a:solidFill>
+              </a:ln>
+            </c:spPr>
+          </c:marker>
+          <c:xVal>
+            <c:numRef>
+              <c:f>Sheet1!$A$2:$A$76</c:f>
+              <c:numCache>
+                <c:formatCode>General</c:formatCode>
+                <c:ptCount val="75"/>
+                <c:pt idx="0">
+                  <c:v>1790</c:v>
+                </c:pt>
+                <c:pt idx="1">
+                  <c:v>1810</c:v>
+                </c:pt>
+                <c:pt idx="2">
+                  <c:v>1702</c:v>
+                </c:pt>
+                <c:pt idx="3">
+                  <c:v>1880</c:v>
+                </c:pt>
+                <c:pt idx="4">
+                  <c:v>2260</c:v>
+                </c:pt>
+                <c:pt idx="5">
+                  <c:v>1950</c:v>
+                </c:pt>
+                <c:pt idx="6">
+                  <c:v>2380</c:v>
+                </c:pt>
+                <c:pt idx="7">
+                  <c:v>2150</c:v>
+                </c:pt>
+                <c:pt idx="8">
+                  <c:v>2380</c:v>
+                </c:pt>
+                <c:pt idx="9">
+                  <c:v>1740</c:v>
+                </c:pt>
+                <c:pt idx="10">
+                  <c:v>1880</c:v>
+                </c:pt>
+                <c:pt idx="11">
+                  <c:v>1950</c:v>
+                </c:pt>
+                <c:pt idx="12">
+                  <c:v>1740</c:v>
+                </c:pt>
+                <c:pt idx="13">
+                  <c:v>1450</c:v>
+                </c:pt>
+                <c:pt idx="14">
+                  <c:v>2150</c:v>
+                </c:pt>
+                <c:pt idx="15">
+                  <c:v>2380</c:v>
+                </c:pt>
+                <c:pt idx="16">
+                  <c:v>2260</c:v>
+                </c:pt>
+                <c:pt idx="17">
+                  <c:v>2380</c:v>
+                </c:pt>
+                <c:pt idx="18">
+                  <c:v>1740</c:v>
+                </c:pt>
+                <c:pt idx="19">
+                  <c:v>1450</c:v>
+                </c:pt>
+                <c:pt idx="20">
+                  <c:v>1610</c:v>
+                </c:pt>
+                <c:pt idx="21">
+                  <c:v>2380</c:v>
+                </c:pt>
+                <c:pt idx="22">
+                  <c:v>1820</c:v>
+                </c:pt>
+                <c:pt idx="23">
+                  <c:v>1880</c:v>
+                </c:pt>
+                <c:pt idx="24">
+                  <c:v>2040</c:v>
+                </c:pt>
+                <c:pt idx="25">
+                  <c:v>2380</c:v>
+                </c:pt>
+                <c:pt idx="26">
+                  <c:v>1610</c:v>
+                </c:pt>
+                <c:pt idx="27">
+                  <c:v>2380</c:v>
+                </c:pt>
+                <c:pt idx="28">
+                  <c:v>1849</c:v>
+                </c:pt>
+                <c:pt idx="29">
+                  <c:v>1943</c:v>
+                </c:pt>
+                <c:pt idx="30">
+                  <c:v>2400</c:v>
+                </c:pt>
+                <c:pt idx="31">
+                  <c:v>2400</c:v>
+                </c:pt>
+                <c:pt idx="32">
+                  <c:v>2400</c:v>
+                </c:pt>
+                <c:pt idx="33">
+                  <c:v>1650</c:v>
+                </c:pt>
+                <c:pt idx="34">
+                  <c:v>1500</c:v>
+                </c:pt>
+                <c:pt idx="35">
+                  <c:v>1650</c:v>
+                </c:pt>
+                <c:pt idx="36">
+                  <c:v>1900</c:v>
+                </c:pt>
+                <c:pt idx="37">
+                  <c:v>1650</c:v>
+                </c:pt>
+                <c:pt idx="38">
+                  <c:v>1900</c:v>
+                </c:pt>
+                <c:pt idx="39">
+                  <c:v>1650</c:v>
+                </c:pt>
+                <c:pt idx="40">
+                  <c:v>2100</c:v>
+                </c:pt>
+                <c:pt idx="41">
+                  <c:v>1450</c:v>
+                </c:pt>
+                <c:pt idx="42">
+                  <c:v>1485.1851851851852</c:v>
+                </c:pt>
+                <c:pt idx="43">
+                  <c:v>1520.3703703703704</c:v>
+                </c:pt>
+                <c:pt idx="44">
+                  <c:v>1555.5555555555557</c:v>
+                </c:pt>
+                <c:pt idx="45">
+                  <c:v>1590.7407407407406</c:v>
+                </c:pt>
+                <c:pt idx="46">
+                  <c:v>1625.9259259259259</c:v>
+                </c:pt>
+                <c:pt idx="47">
+                  <c:v>1661.111111111111</c:v>
+                </c:pt>
+                <c:pt idx="48">
+                  <c:v>1696.2962962962963</c:v>
+                </c:pt>
+                <c:pt idx="49">
+                  <c:v>1731.4814814814815</c:v>
+                </c:pt>
+                <c:pt idx="50">
+                  <c:v>1766.6666666666667</c:v>
+                </c:pt>
+                <c:pt idx="51">
+                  <c:v>1801.8518518518517</c:v>
+                </c:pt>
+                <c:pt idx="52">
+                  <c:v>1837.037037037037</c:v>
+                </c:pt>
+                <c:pt idx="53">
+                  <c:v>1872.2222222222222</c:v>
+                </c:pt>
+                <c:pt idx="54">
+                  <c:v>1907.4074074074074</c:v>
+                </c:pt>
+                <c:pt idx="55">
+                  <c:v>1942.5925925925926</c:v>
+                </c:pt>
+                <c:pt idx="56">
+                  <c:v>1977.7777777777778</c:v>
+                </c:pt>
+                <c:pt idx="57">
+                  <c:v>2012.962962962963</c:v>
+                </c:pt>
+                <c:pt idx="58">
+                  <c:v>2048.1481481481483</c:v>
+                </c:pt>
+                <c:pt idx="59">
+                  <c:v>2083.3333333333335</c:v>
+                </c:pt>
+                <c:pt idx="60">
+                  <c:v>2118.5185185185182</c:v>
+                </c:pt>
+                <c:pt idx="61">
+                  <c:v>2153.7037037037035</c:v>
+                </c:pt>
+                <c:pt idx="62">
+                  <c:v>2188.8888888888887</c:v>
+                </c:pt>
+                <c:pt idx="63">
+                  <c:v>2224.074074074074</c:v>
+                </c:pt>
+                <c:pt idx="64">
+                  <c:v>2259.259259259259</c:v>
+                </c:pt>
+                <c:pt idx="65">
+                  <c:v>2294.4444444444443</c:v>
+                </c:pt>
+                <c:pt idx="66">
+                  <c:v>2329.6296296296296</c:v>
+                </c:pt>
+                <c:pt idx="67">
+                  <c:v>2364.814814814815</c:v>
+                </c:pt>
+                <c:pt idx="68">
+                  <c:v>2400</c:v>
+                </c:pt>
+                <c:pt idx="69">
+                  <c:v>1824</c:v>
+                </c:pt>
+                <c:pt idx="70">
                   <c:v>1865</c:v>
                 </c:pt>
-                <c:pt idx="2">
+                <c:pt idx="71">
                   <c:v>1871</c:v>
                 </c:pt>
-                <c:pt idx="3">
+                <c:pt idx="72">
                   <c:v>1849</c:v>
                 </c:pt>
-                <c:pt idx="4">
+                <c:pt idx="73">
                   <c:v>1865</c:v>
-                </c:pt>
-                <c:pt idx="5">
-                  <c:v>1790</c:v>
-                </c:pt>
-                <c:pt idx="6">
-                  <c:v>1810</c:v>
-                </c:pt>
-                <c:pt idx="7">
-                  <c:v>1702</c:v>
-                </c:pt>
-                <c:pt idx="8">
-                  <c:v>1880</c:v>
-                </c:pt>
-                <c:pt idx="9">
-                  <c:v>2260</c:v>
-                </c:pt>
-                <c:pt idx="10">
-                  <c:v>1950</c:v>
-                </c:pt>
-                <c:pt idx="11">
-                  <c:v>2380</c:v>
-                </c:pt>
-                <c:pt idx="12">
-                  <c:v>2150</c:v>
-                </c:pt>
-                <c:pt idx="13">
-                  <c:v>2380</c:v>
-                </c:pt>
-                <c:pt idx="14">
-                  <c:v>1740</c:v>
-                </c:pt>
-                <c:pt idx="15">
-                  <c:v>1880</c:v>
-                </c:pt>
-                <c:pt idx="16">
-                  <c:v>1950</c:v>
-                </c:pt>
-                <c:pt idx="17">
-                  <c:v>1740</c:v>
-                </c:pt>
-                <c:pt idx="18">
-                  <c:v>1450</c:v>
-                </c:pt>
-                <c:pt idx="19">
-                  <c:v>2150</c:v>
-                </c:pt>
-                <c:pt idx="20">
-                  <c:v>2380</c:v>
-                </c:pt>
-                <c:pt idx="21">
-                  <c:v>2260</c:v>
-                </c:pt>
-                <c:pt idx="22">
-                  <c:v>2380</c:v>
-                </c:pt>
-                <c:pt idx="23">
-                  <c:v>1740</c:v>
-                </c:pt>
-                <c:pt idx="24">
-                  <c:v>1450</c:v>
-                </c:pt>
-                <c:pt idx="25">
-                  <c:v>1610</c:v>
-                </c:pt>
-                <c:pt idx="26">
-                  <c:v>2380</c:v>
-                </c:pt>
-                <c:pt idx="27">
-                  <c:v>1820</c:v>
-                </c:pt>
-                <c:pt idx="28">
-                  <c:v>1880</c:v>
-                </c:pt>
-                <c:pt idx="29">
-                  <c:v>2040</c:v>
-                </c:pt>
-                <c:pt idx="30">
-                  <c:v>2380</c:v>
-                </c:pt>
-                <c:pt idx="31">
-                  <c:v>1610</c:v>
-                </c:pt>
-                <c:pt idx="32">
-                  <c:v>2380</c:v>
-                </c:pt>
-                <c:pt idx="33">
-                  <c:v>1849</c:v>
-                </c:pt>
-                <c:pt idx="34">
-                  <c:v>1943</c:v>
-                </c:pt>
-                <c:pt idx="35">
-                  <c:v>2400</c:v>
-                </c:pt>
-                <c:pt idx="36">
-                  <c:v>2400</c:v>
-                </c:pt>
-                <c:pt idx="37">
-                  <c:v>2400</c:v>
-                </c:pt>
-                <c:pt idx="38">
-                  <c:v>1650</c:v>
-                </c:pt>
-                <c:pt idx="39">
-                  <c:v>1500</c:v>
-                </c:pt>
-                <c:pt idx="40">
-                  <c:v>1650</c:v>
-                </c:pt>
-                <c:pt idx="41">
-                  <c:v>1900</c:v>
-                </c:pt>
-                <c:pt idx="42">
-                  <c:v>1650</c:v>
-                </c:pt>
-                <c:pt idx="43">
-                  <c:v>1900</c:v>
-                </c:pt>
-                <c:pt idx="44">
-                  <c:v>1650</c:v>
-                </c:pt>
-                <c:pt idx="45">
-                  <c:v>2100</c:v>
-                </c:pt>
-                <c:pt idx="46">
-                  <c:v>1450</c:v>
-                </c:pt>
-                <c:pt idx="47">
-                  <c:v>1485.1851851851852</c:v>
-                </c:pt>
-                <c:pt idx="48">
-                  <c:v>1520.3703703703704</c:v>
-                </c:pt>
-                <c:pt idx="49">
-                  <c:v>1555.5555555555557</c:v>
-                </c:pt>
-                <c:pt idx="50">
-                  <c:v>1590.7407407407406</c:v>
-                </c:pt>
-                <c:pt idx="51">
-                  <c:v>1625.9259259259259</c:v>
-                </c:pt>
-                <c:pt idx="52">
-                  <c:v>1661.111111111111</c:v>
-                </c:pt>
-                <c:pt idx="53">
-                  <c:v>1696.2962962962963</c:v>
-                </c:pt>
-                <c:pt idx="54">
-                  <c:v>1731.4814814814815</c:v>
-                </c:pt>
-                <c:pt idx="55">
-                  <c:v>1766.6666666666667</c:v>
-                </c:pt>
-                <c:pt idx="56">
-                  <c:v>1801.8518518518517</c:v>
-                </c:pt>
-                <c:pt idx="57">
-                  <c:v>1837.037037037037</c:v>
-                </c:pt>
-                <c:pt idx="58">
-                  <c:v>1872.2222222222222</c:v>
-                </c:pt>
-                <c:pt idx="59">
-                  <c:v>1907.4074074074074</c:v>
-                </c:pt>
-                <c:pt idx="60">
-                  <c:v>1942.5925925925926</c:v>
-                </c:pt>
-                <c:pt idx="61">
-                  <c:v>1977.7777777777778</c:v>
-                </c:pt>
-                <c:pt idx="62">
-                  <c:v>2012.962962962963</c:v>
-                </c:pt>
-                <c:pt idx="63">
-                  <c:v>2048.1481481481483</c:v>
-                </c:pt>
-                <c:pt idx="64">
-                  <c:v>2083.3333333333335</c:v>
-                </c:pt>
-                <c:pt idx="65">
-                  <c:v>2118.5185185185182</c:v>
-                </c:pt>
-                <c:pt idx="66">
-                  <c:v>2153.7037037037035</c:v>
-                </c:pt>
-                <c:pt idx="67">
-                  <c:v>2188.8888888888887</c:v>
-                </c:pt>
-                <c:pt idx="68">
-                  <c:v>2224.074074074074</c:v>
-                </c:pt>
-                <c:pt idx="69">
-                  <c:v>2259.259259259259</c:v>
-                </c:pt>
-                <c:pt idx="70">
-                  <c:v>2294.4444444444443</c:v>
-                </c:pt>
-                <c:pt idx="71">
-                  <c:v>2329.6296296296296</c:v>
-                </c:pt>
-                <c:pt idx="72">
-                  <c:v>2364.814814814815</c:v>
-                </c:pt>
-                <c:pt idx="73">
-                  <c:v>2400</c:v>
                 </c:pt>
                 <c:pt idx="74">
                   <c:v>1849</c:v>
@@ -2061,88 +2059,88 @@
                   <c:v/>
                 </c:pt>
                 <c:pt idx="46">
-                  <c:v>353370.74537409266</c:v>
+                  <c:v/>
                 </c:pt>
                 <c:pt idx="47">
-                  <c:v>361279.9692978465</c:v>
+                  <c:v/>
                 </c:pt>
                 <c:pt idx="48">
-                  <c:v>369189.1932216004</c:v>
+                  <c:v/>
                 </c:pt>
                 <c:pt idx="49">
-                  <c:v>377098.41714535427</c:v>
+                  <c:v/>
                 </c:pt>
                 <c:pt idx="50">
-                  <c:v>385007.6410691081</c:v>
+                  <c:v/>
                 </c:pt>
                 <c:pt idx="51">
-                  <c:v>392916.864992862</c:v>
+                  <c:v/>
                 </c:pt>
                 <c:pt idx="52">
-                  <c:v>400826.0889166159</c:v>
+                  <c:v/>
                 </c:pt>
                 <c:pt idx="53">
-                  <c:v>408735.31284036976</c:v>
+                  <c:v/>
                 </c:pt>
                 <c:pt idx="54">
-                  <c:v>416644.53676412365</c:v>
+                  <c:v/>
                 </c:pt>
                 <c:pt idx="55">
-                  <c:v>424553.7606878775</c:v>
+                  <c:v/>
                 </c:pt>
                 <c:pt idx="56">
-                  <c:v>432462.9846116313</c:v>
+                  <c:v/>
                 </c:pt>
                 <c:pt idx="57">
-                  <c:v>440372.2085353852</c:v>
+                  <c:v/>
                 </c:pt>
                 <c:pt idx="58">
-                  <c:v>448281.4324591391</c:v>
+                  <c:v/>
                 </c:pt>
                 <c:pt idx="59">
-                  <c:v>456190.656382893</c:v>
+                  <c:v/>
                 </c:pt>
                 <c:pt idx="60">
-                  <c:v>464099.88030664687</c:v>
+                  <c:v/>
                 </c:pt>
                 <c:pt idx="61">
-                  <c:v>472009.10423040076</c:v>
+                  <c:v/>
                 </c:pt>
                 <c:pt idx="62">
-                  <c:v>479918.32815415465</c:v>
+                  <c:v/>
                 </c:pt>
                 <c:pt idx="63">
-                  <c:v>487827.5520779085</c:v>
+                  <c:v/>
                 </c:pt>
                 <c:pt idx="64">
-                  <c:v>495736.77600166237</c:v>
+                  <c:v/>
                 </c:pt>
                 <c:pt idx="65">
-                  <c:v>503645.99992541614</c:v>
+                  <c:v/>
                 </c:pt>
                 <c:pt idx="66">
-                  <c:v>511555.22384917</c:v>
+                  <c:v/>
                 </c:pt>
                 <c:pt idx="67">
-                  <c:v>519464.4477729239</c:v>
+                  <c:v/>
                 </c:pt>
                 <c:pt idx="68">
-                  <c:v>527373.6716966778</c:v>
+                  <c:v/>
                 </c:pt>
                 <c:pt idx="69">
-                  <c:v>535282.8956204318</c:v>
+                  <c:v>505500</c:v>
                 </c:pt>
                 <c:pt idx="70">
-                  <c:v>543192.1195441856</c:v>
+                  <c:v>495000</c:v>
                 </c:pt>
                 <c:pt idx="71">
-                  <c:v>551101.3434679394</c:v>
+                  <c:v>427000</c:v>
                 </c:pt>
                 <c:pt idx="72">
-                  <c:v>559010.5673916934</c:v>
+                  <c:v>429000</c:v>
                 </c:pt>
                 <c:pt idx="73">
-                  <c:v>566919.7913154473</c:v>
+                  <c:v>465000</c:v>
                 </c:pt>
                 <c:pt idx="74">
                   <c:v/>
@@ -2196,226 +2194,226 @@
                 <c:formatCode>General</c:formatCode>
                 <c:ptCount val="75"/>
                 <c:pt idx="0">
+                  <c:v>1790</c:v>
+                </c:pt>
+                <c:pt idx="1">
+                  <c:v>1810</c:v>
+                </c:pt>
+                <c:pt idx="2">
+                  <c:v>1702</c:v>
+                </c:pt>
+                <c:pt idx="3">
+                  <c:v>1880</c:v>
+                </c:pt>
+                <c:pt idx="4">
+                  <c:v>2260</c:v>
+                </c:pt>
+                <c:pt idx="5">
+                  <c:v>1950</c:v>
+                </c:pt>
+                <c:pt idx="6">
+                  <c:v>2380</c:v>
+                </c:pt>
+                <c:pt idx="7">
+                  <c:v>2150</c:v>
+                </c:pt>
+                <c:pt idx="8">
+                  <c:v>2380</c:v>
+                </c:pt>
+                <c:pt idx="9">
+                  <c:v>1740</c:v>
+                </c:pt>
+                <c:pt idx="10">
+                  <c:v>1880</c:v>
+                </c:pt>
+                <c:pt idx="11">
+                  <c:v>1950</c:v>
+                </c:pt>
+                <c:pt idx="12">
+                  <c:v>1740</c:v>
+                </c:pt>
+                <c:pt idx="13">
+                  <c:v>1450</c:v>
+                </c:pt>
+                <c:pt idx="14">
+                  <c:v>2150</c:v>
+                </c:pt>
+                <c:pt idx="15">
+                  <c:v>2380</c:v>
+                </c:pt>
+                <c:pt idx="16">
+                  <c:v>2260</c:v>
+                </c:pt>
+                <c:pt idx="17">
+                  <c:v>2380</c:v>
+                </c:pt>
+                <c:pt idx="18">
+                  <c:v>1740</c:v>
+                </c:pt>
+                <c:pt idx="19">
+                  <c:v>1450</c:v>
+                </c:pt>
+                <c:pt idx="20">
+                  <c:v>1610</c:v>
+                </c:pt>
+                <c:pt idx="21">
+                  <c:v>2380</c:v>
+                </c:pt>
+                <c:pt idx="22">
+                  <c:v>1820</c:v>
+                </c:pt>
+                <c:pt idx="23">
+                  <c:v>1880</c:v>
+                </c:pt>
+                <c:pt idx="24">
+                  <c:v>2040</c:v>
+                </c:pt>
+                <c:pt idx="25">
+                  <c:v>2380</c:v>
+                </c:pt>
+                <c:pt idx="26">
+                  <c:v>1610</c:v>
+                </c:pt>
+                <c:pt idx="27">
+                  <c:v>2380</c:v>
+                </c:pt>
+                <c:pt idx="28">
+                  <c:v>1849</c:v>
+                </c:pt>
+                <c:pt idx="29">
+                  <c:v>1943</c:v>
+                </c:pt>
+                <c:pt idx="30">
+                  <c:v>2400</c:v>
+                </c:pt>
+                <c:pt idx="31">
+                  <c:v>2400</c:v>
+                </c:pt>
+                <c:pt idx="32">
+                  <c:v>2400</c:v>
+                </c:pt>
+                <c:pt idx="33">
+                  <c:v>1650</c:v>
+                </c:pt>
+                <c:pt idx="34">
+                  <c:v>1500</c:v>
+                </c:pt>
+                <c:pt idx="35">
+                  <c:v>1650</c:v>
+                </c:pt>
+                <c:pt idx="36">
+                  <c:v>1900</c:v>
+                </c:pt>
+                <c:pt idx="37">
+                  <c:v>1650</c:v>
+                </c:pt>
+                <c:pt idx="38">
+                  <c:v>1900</c:v>
+                </c:pt>
+                <c:pt idx="39">
+                  <c:v>1650</c:v>
+                </c:pt>
+                <c:pt idx="40">
+                  <c:v>2100</c:v>
+                </c:pt>
+                <c:pt idx="41">
+                  <c:v>1450</c:v>
+                </c:pt>
+                <c:pt idx="42">
+                  <c:v>1485.1851851851852</c:v>
+                </c:pt>
+                <c:pt idx="43">
+                  <c:v>1520.3703703703704</c:v>
+                </c:pt>
+                <c:pt idx="44">
+                  <c:v>1555.5555555555557</c:v>
+                </c:pt>
+                <c:pt idx="45">
+                  <c:v>1590.7407407407406</c:v>
+                </c:pt>
+                <c:pt idx="46">
+                  <c:v>1625.9259259259259</c:v>
+                </c:pt>
+                <c:pt idx="47">
+                  <c:v>1661.111111111111</c:v>
+                </c:pt>
+                <c:pt idx="48">
+                  <c:v>1696.2962962962963</c:v>
+                </c:pt>
+                <c:pt idx="49">
+                  <c:v>1731.4814814814815</c:v>
+                </c:pt>
+                <c:pt idx="50">
+                  <c:v>1766.6666666666667</c:v>
+                </c:pt>
+                <c:pt idx="51">
+                  <c:v>1801.8518518518517</c:v>
+                </c:pt>
+                <c:pt idx="52">
+                  <c:v>1837.037037037037</c:v>
+                </c:pt>
+                <c:pt idx="53">
+                  <c:v>1872.2222222222222</c:v>
+                </c:pt>
+                <c:pt idx="54">
+                  <c:v>1907.4074074074074</c:v>
+                </c:pt>
+                <c:pt idx="55">
+                  <c:v>1942.5925925925926</c:v>
+                </c:pt>
+                <c:pt idx="56">
+                  <c:v>1977.7777777777778</c:v>
+                </c:pt>
+                <c:pt idx="57">
+                  <c:v>2012.962962962963</c:v>
+                </c:pt>
+                <c:pt idx="58">
+                  <c:v>2048.1481481481483</c:v>
+                </c:pt>
+                <c:pt idx="59">
+                  <c:v>2083.3333333333335</c:v>
+                </c:pt>
+                <c:pt idx="60">
+                  <c:v>2118.5185185185182</c:v>
+                </c:pt>
+                <c:pt idx="61">
+                  <c:v>2153.7037037037035</c:v>
+                </c:pt>
+                <c:pt idx="62">
+                  <c:v>2188.8888888888887</c:v>
+                </c:pt>
+                <c:pt idx="63">
+                  <c:v>2224.074074074074</c:v>
+                </c:pt>
+                <c:pt idx="64">
+                  <c:v>2259.259259259259</c:v>
+                </c:pt>
+                <c:pt idx="65">
+                  <c:v>2294.4444444444443</c:v>
+                </c:pt>
+                <c:pt idx="66">
+                  <c:v>2329.6296296296296</c:v>
+                </c:pt>
+                <c:pt idx="67">
+                  <c:v>2364.814814814815</c:v>
+                </c:pt>
+                <c:pt idx="68">
+                  <c:v>2400</c:v>
+                </c:pt>
+                <c:pt idx="69">
                   <c:v>1824</c:v>
                 </c:pt>
-                <c:pt idx="1">
+                <c:pt idx="70">
                   <c:v>1865</c:v>
                 </c:pt>
-                <c:pt idx="2">
+                <c:pt idx="71">
                   <c:v>1871</c:v>
                 </c:pt>
-                <c:pt idx="3">
+                <c:pt idx="72">
                   <c:v>1849</c:v>
                 </c:pt>
-                <c:pt idx="4">
+                <c:pt idx="73">
                   <c:v>1865</c:v>
-                </c:pt>
-                <c:pt idx="5">
-                  <c:v>1790</c:v>
-                </c:pt>
-                <c:pt idx="6">
-                  <c:v>1810</c:v>
-                </c:pt>
-                <c:pt idx="7">
-                  <c:v>1702</c:v>
-                </c:pt>
-                <c:pt idx="8">
-                  <c:v>1880</c:v>
-                </c:pt>
-                <c:pt idx="9">
-                  <c:v>2260</c:v>
-                </c:pt>
-                <c:pt idx="10">
-                  <c:v>1950</c:v>
-                </c:pt>
-                <c:pt idx="11">
-                  <c:v>2380</c:v>
-                </c:pt>
-                <c:pt idx="12">
-                  <c:v>2150</c:v>
-                </c:pt>
-                <c:pt idx="13">
-                  <c:v>2380</c:v>
-                </c:pt>
-                <c:pt idx="14">
-                  <c:v>1740</c:v>
-                </c:pt>
-                <c:pt idx="15">
-                  <c:v>1880</c:v>
-                </c:pt>
-                <c:pt idx="16">
-                  <c:v>1950</c:v>
-                </c:pt>
-                <c:pt idx="17">
-                  <c:v>1740</c:v>
-                </c:pt>
-                <c:pt idx="18">
-                  <c:v>1450</c:v>
-                </c:pt>
-                <c:pt idx="19">
-                  <c:v>2150</c:v>
-                </c:pt>
-                <c:pt idx="20">
-                  <c:v>2380</c:v>
-                </c:pt>
-                <c:pt idx="21">
-                  <c:v>2260</c:v>
-                </c:pt>
-                <c:pt idx="22">
-                  <c:v>2380</c:v>
-                </c:pt>
-                <c:pt idx="23">
-                  <c:v>1740</c:v>
-                </c:pt>
-                <c:pt idx="24">
-                  <c:v>1450</c:v>
-                </c:pt>
-                <c:pt idx="25">
-                  <c:v>1610</c:v>
-                </c:pt>
-                <c:pt idx="26">
-                  <c:v>2380</c:v>
-                </c:pt>
-                <c:pt idx="27">
-                  <c:v>1820</c:v>
-                </c:pt>
-                <c:pt idx="28">
-                  <c:v>1880</c:v>
-                </c:pt>
-                <c:pt idx="29">
-                  <c:v>2040</c:v>
-                </c:pt>
-                <c:pt idx="30">
-                  <c:v>2380</c:v>
-                </c:pt>
-                <c:pt idx="31">
-                  <c:v>1610</c:v>
-                </c:pt>
-                <c:pt idx="32">
-                  <c:v>2380</c:v>
-                </c:pt>
-                <c:pt idx="33">
-                  <c:v>1849</c:v>
-                </c:pt>
-                <c:pt idx="34">
-                  <c:v>1943</c:v>
-                </c:pt>
-                <c:pt idx="35">
-                  <c:v>2400</c:v>
-                </c:pt>
-                <c:pt idx="36">
-                  <c:v>2400</c:v>
-                </c:pt>
-                <c:pt idx="37">
-                  <c:v>2400</c:v>
-                </c:pt>
-                <c:pt idx="38">
-                  <c:v>1650</c:v>
-                </c:pt>
-                <c:pt idx="39">
-                  <c:v>1500</c:v>
-                </c:pt>
-                <c:pt idx="40">
-                  <c:v>1650</c:v>
-                </c:pt>
-                <c:pt idx="41">
-                  <c:v>1900</c:v>
-                </c:pt>
-                <c:pt idx="42">
-                  <c:v>1650</c:v>
-                </c:pt>
-                <c:pt idx="43">
-                  <c:v>1900</c:v>
-                </c:pt>
-                <c:pt idx="44">
-                  <c:v>1650</c:v>
-                </c:pt>
-                <c:pt idx="45">
-                  <c:v>2100</c:v>
-                </c:pt>
-                <c:pt idx="46">
-                  <c:v>1450</c:v>
-                </c:pt>
-                <c:pt idx="47">
-                  <c:v>1485.1851851851852</c:v>
-                </c:pt>
-                <c:pt idx="48">
-                  <c:v>1520.3703703703704</c:v>
-                </c:pt>
-                <c:pt idx="49">
-                  <c:v>1555.5555555555557</c:v>
-                </c:pt>
-                <c:pt idx="50">
-                  <c:v>1590.7407407407406</c:v>
-                </c:pt>
-                <c:pt idx="51">
-                  <c:v>1625.9259259259259</c:v>
-                </c:pt>
-                <c:pt idx="52">
-                  <c:v>1661.111111111111</c:v>
-                </c:pt>
-                <c:pt idx="53">
-                  <c:v>1696.2962962962963</c:v>
-                </c:pt>
-                <c:pt idx="54">
-                  <c:v>1731.4814814814815</c:v>
-                </c:pt>
-                <c:pt idx="55">
-                  <c:v>1766.6666666666667</c:v>
-                </c:pt>
-                <c:pt idx="56">
-                  <c:v>1801.8518518518517</c:v>
-                </c:pt>
-                <c:pt idx="57">
-                  <c:v>1837.037037037037</c:v>
-                </c:pt>
-                <c:pt idx="58">
-                  <c:v>1872.2222222222222</c:v>
-                </c:pt>
-                <c:pt idx="59">
-                  <c:v>1907.4074074074074</c:v>
-                </c:pt>
-                <c:pt idx="60">
-                  <c:v>1942.5925925925926</c:v>
-                </c:pt>
-                <c:pt idx="61">
-                  <c:v>1977.7777777777778</c:v>
-                </c:pt>
-                <c:pt idx="62">
-                  <c:v>2012.962962962963</c:v>
-                </c:pt>
-                <c:pt idx="63">
-                  <c:v>2048.1481481481483</c:v>
-                </c:pt>
-                <c:pt idx="64">
-                  <c:v>2083.3333333333335</c:v>
-                </c:pt>
-                <c:pt idx="65">
-                  <c:v>2118.5185185185182</c:v>
-                </c:pt>
-                <c:pt idx="66">
-                  <c:v>2153.7037037037035</c:v>
-                </c:pt>
-                <c:pt idx="67">
-                  <c:v>2188.8888888888887</c:v>
-                </c:pt>
-                <c:pt idx="68">
-                  <c:v>2224.074074074074</c:v>
-                </c:pt>
-                <c:pt idx="69">
-                  <c:v>2259.259259259259</c:v>
-                </c:pt>
-                <c:pt idx="70">
-                  <c:v>2294.4444444444443</c:v>
-                </c:pt>
-                <c:pt idx="71">
-                  <c:v>2329.6296296296296</c:v>
-                </c:pt>
-                <c:pt idx="72">
-                  <c:v>2364.814814814815</c:v>
-                </c:pt>
-                <c:pt idx="73">
-                  <c:v>2400</c:v>
                 </c:pt>
                 <c:pt idx="74">
                   <c:v>1849</c:v>

</xml_diff>

<commit_message>
Samples in a real city: Casselberry instead of the made-up Harrow Springs
Streets, names, brokerages and MLS numbers stay made up; the city tax rate is Casselberry's real 2025 millage
from the market file. The dev/samples rule now says real cities and counties are fine. samples/ regenerated.

Co-Authored-By: Claude Opus 5.5 <noreply@anthropic.com>
</commit_message>
<xml_diff>
--- a/samples/seller-cma/517-Larkwood-Ave-Listing-Presentation.pptx
+++ b/samples/seller-cma/517-Larkwood-Ave-Listing-Presentation.pptx
@@ -5252,7 +5252,7 @@
                 <a:ea typeface="Arial" pitchFamily="34" charset="-122"/>
                 <a:cs typeface="Arial" pitchFamily="34" charset="-120"/>
               </a:rPr>
-              <a:t>Listing Presentation · Harrow Springs, Fernwood Park</a:t>
+              <a:t>Listing Presentation · Casselberry, Fernwood Park</a:t>
             </a:r>
             <a:endParaRPr lang="en-US" sz="1600" dirty="0"/>
           </a:p>
@@ -5917,7 +5917,7 @@
                 <a:ea typeface="Arial" pitchFamily="34" charset="-122"/>
                 <a:cs typeface="Arial" pitchFamily="34" charset="-120"/>
               </a:rPr>
-              <a:t>$4,228/mo</a:t>
+              <a:t>$4,169/mo</a:t>
             </a:r>
             <a:endParaRPr lang="en-US" sz="2800" dirty="0"/>
           </a:p>
@@ -6061,7 +6061,7 @@
                 <a:ea typeface="Arial" pitchFamily="34" charset="-122"/>
                 <a:cs typeface="Arial" pitchFamily="34" charset="-120"/>
               </a:rPr>
-              <a:t>$4,146/mo</a:t>
+              <a:t>$4,087/mo</a:t>
             </a:r>
             <a:endParaRPr lang="en-US" sz="2800" dirty="0"/>
           </a:p>
@@ -6205,7 +6205,7 @@
                 <a:ea typeface="Arial" pitchFamily="34" charset="-122"/>
                 <a:cs typeface="Arial" pitchFamily="34" charset="-120"/>
               </a:rPr>
-              <a:t>$4,064/mo</a:t>
+              <a:t>$4,005/mo</a:t>
             </a:r>
             <a:endParaRPr lang="en-US" sz="2800" dirty="0"/>
           </a:p>

</xml_diff>

<commit_message>
Samples: regenerated after the second fix pass
Co-Authored-By: Claude Opus 5.5 <noreply@anthropic.com>
</commit_message>
<xml_diff>
--- a/samples/seller-cma/517-Larkwood-Ave-Listing-Presentation.pptx
+++ b/samples/seller-cma/517-Larkwood-Ave-Listing-Presentation.pptx
@@ -3966,7 +3966,7 @@
           <a:p>
             <a:r>
               <a:rPr lang="en-US" dirty="0"/>
-              <a:t>Holding costs: about $530 a month (loan interest, HOA, insurance and utilities; property tax is in the proration) for each option's time to contract plus 1 month to close. Commissions are negotiable and not set by law. Not included: this year's property tax proration. Taxes here are paid in arrears, so the seller credits the buyer from Jan 1; add the tax bill and the expected closing date to include it. Title company fees are typical local charges (settlement fee $700, title search $250, municipal lien search $125, recording $70); the title company's quote replaces them. Estimates only. Not included: mortgage payoff, tax proration and repairs; the closing agent provides exact figures.</a:t>
+              <a:t>Holding costs: about $530 a month (HOA, insurance and utilities; no loan interest, since no mortgage payoff was given; property tax is not included) for each option's time to contract plus 1 month to close. Commissions are negotiable and not set by law. Not included: this year's property tax proration. Taxes here are paid in arrears, so the seller credits the buyer from Jan 1; add the tax bill and the expected closing date to include it. Title company fees are typical local charges (settlement fee $700, title search $250, municipal lien search $125, recording $70); the title company's quote replaces them. Estimates only. Not included: mortgage payoff, tax proration and repairs; the closing agent provides exact figures.</a:t>
             </a:r>
             <a:endParaRPr lang="en-US" dirty="0"/>
           </a:p>
@@ -17008,7 +17008,7 @@
           <a:bodyPr wrap="square" lIns="0" tIns="0" rIns="0" bIns="0" rtlCol="0" anchor="ctr"/>
           <a:lstStyle/>
           <a:p>
-            <a:pPr indent="0" marL="0">
+            <a:pPr algn="l" indent="0" marL="0">
               <a:buNone/>
             </a:pPr>
             <a:r>
@@ -17150,7 +17150,7 @@
           <a:bodyPr wrap="square" lIns="0" tIns="0" rIns="0" bIns="0" rtlCol="0" anchor="ctr"/>
           <a:lstStyle/>
           <a:p>
-            <a:pPr indent="0" marL="0">
+            <a:pPr algn="l" indent="0" marL="0">
               <a:buNone/>
             </a:pPr>
             <a:r>
@@ -17292,7 +17292,7 @@
           <a:bodyPr wrap="square" lIns="0" tIns="0" rIns="0" bIns="0" rtlCol="0" anchor="ctr"/>
           <a:lstStyle/>
           <a:p>
-            <a:pPr indent="0" marL="0">
+            <a:pPr algn="l" indent="0" marL="0">
               <a:buNone/>
             </a:pPr>
             <a:r>
@@ -17434,7 +17434,7 @@
           <a:bodyPr wrap="square" lIns="0" tIns="0" rIns="0" bIns="0" rtlCol="0" anchor="ctr"/>
           <a:lstStyle/>
           <a:p>
-            <a:pPr indent="0" marL="0">
+            <a:pPr algn="l" indent="0" marL="0">
               <a:buNone/>
             </a:pPr>
             <a:r>
@@ -17576,7 +17576,7 @@
           <a:bodyPr wrap="square" lIns="0" tIns="0" rIns="0" bIns="0" rtlCol="0" anchor="ctr"/>
           <a:lstStyle/>
           <a:p>
-            <a:pPr indent="0" marL="0">
+            <a:pPr algn="l" indent="0" marL="0">
               <a:buNone/>
             </a:pPr>
             <a:r>

</xml_diff>

<commit_message>
Samples: regenerated after the eval iteration 4 fixes
Co-Authored-By: Claude Opus 5.5 <noreply@anthropic.com>
</commit_message>
<xml_diff>
--- a/samples/seller-cma/517-Larkwood-Ave-Listing-Presentation.pptx
+++ b/samples/seller-cma/517-Larkwood-Ave-Listing-Presentation.pptx
@@ -2973,13 +2973,13 @@
                 <c:formatCode>General</c:formatCode>
                 <c:ptCount val="3"/>
                 <c:pt idx="0">
-                  <c:v>423074</c:v>
+                  <c:v>421368</c:v>
                 </c:pt>
                 <c:pt idx="1">
-                  <c:v>422136</c:v>
+                  <c:v>421060</c:v>
                 </c:pt>
                 <c:pt idx="2">
-                  <c:v>425260</c:v>
+                  <c:v>424486</c:v>
                 </c:pt>
               </c:numCache>
             </c:numRef>
@@ -3966,7 +3966,7 @@
           <a:p>
             <a:r>
               <a:rPr lang="en-US" dirty="0"/>
-              <a:t>Holding costs: about $530 a month (HOA, insurance and utilities; no loan interest, since no mortgage payoff was given; property tax is not included) for each option's time to contract plus 1 month to close. Commissions are negotiable and not set by law. Not included: this year's property tax proration. Taxes here are paid in arrears, so the seller credits the buyer from Jan 1; add the tax bill and the expected closing date to include it. Title company fees are typical local charges (settlement fee $700, title search $250, municipal lien search $125, recording $70); the title company's quote replaces them. Estimates only. Not included: mortgage payoff, tax proration and repairs; the closing agent provides exact figures.</a:t>
+              <a:t>Holding costs: about $530 a month (insurance and utilities; no loan interest, since no mortgage payoff was given; property tax is not included) for each option's time to contract plus 1 month to close. Commissions are negotiable and not set by law. Not included: this year's property tax proration. Taxes here are paid in arrears, so the seller credits the buyer from Jan 1; add the tax bill and the expected closing date to include it. Title company fees are typical local charges (settlement fee $700, title search $250, municipal lien search $125, recording $70); the title company's quote replaces them. Estimates only. Not included: mortgage payoff, tax proration and repairs; the closing agent provides exact figures.</a:t>
             </a:r>
             <a:endParaRPr lang="en-US" dirty="0"/>
           </a:p>
@@ -5464,7 +5464,7 @@
                 <a:ea typeface="Arial" pitchFamily="34" charset="-122"/>
                 <a:cs typeface="Arial" pitchFamily="34" charset="-120"/>
               </a:rPr>
-              <a:t>Estimated net before mortgage payoff</a:t>
+              <a:t>Estimated net before mortgage payoff, after holding costs</a:t>
             </a:r>
             <a:endParaRPr lang="en-US" sz="1300" dirty="0"/>
           </a:p>

</xml_diff>

<commit_message>
Samples: regenerated after eval iteration 5 fixes; seller sample's closing section fits page 8
Co-Authored-By: Claude Opus 5.5 <noreply@anthropic.com>
</commit_message>
<xml_diff>
--- a/samples/seller-cma/517-Larkwood-Ave-Listing-Presentation.pptx
+++ b/samples/seller-cma/517-Larkwood-Ave-Listing-Presentation.pptx
@@ -2973,7 +2973,7 @@
                 <c:formatCode>General</c:formatCode>
                 <c:ptCount val="3"/>
                 <c:pt idx="0">
-                  <c:v>421368</c:v>
+                  <c:v>420954</c:v>
                 </c:pt>
                 <c:pt idx="1">
                   <c:v>421060</c:v>
@@ -5546,7 +5546,7 @@
                 <a:ea typeface="Arial" pitchFamily="34" charset="-122"/>
                 <a:cs typeface="Arial" pitchFamily="34" charset="-120"/>
               </a:rPr>
-              <a:t>$3,426</a:t>
+              <a:t>$3,532</a:t>
             </a:r>
             <a:endParaRPr lang="en-US" sz="3200" dirty="0"/>
           </a:p>
@@ -11062,7 +11062,7 @@
                           <a:ea typeface="Arial" pitchFamily="34" charset="-122"/>
                           <a:cs typeface="Arial" pitchFamily="34" charset="-120"/>
                         </a:rPr>
-                        <a:t>−$1,706</a:t>
+                        <a:t>−$2,120</a:t>
                       </a:r>
                       <a:endParaRPr lang="en-US" sz="1100" dirty="0">
                         <a:latin typeface="Arial" charset="0"/>
@@ -11336,7 +11336,7 @@
                           <a:ea typeface="Arial" pitchFamily="34" charset="-122"/>
                           <a:cs typeface="Arial" pitchFamily="34" charset="-120"/>
                         </a:rPr>
-                        <a:t>$421,368</a:t>
+                        <a:t>$420,954</a:t>
                       </a:r>
                       <a:endParaRPr lang="en-US" sz="1100" dirty="0">
                         <a:latin typeface="Arial" charset="0"/>
@@ -15657,7 +15657,7 @@
                 <a:ea typeface="Arial" pitchFamily="34" charset="-122"/>
                 <a:cs typeface="Arial" pitchFamily="34" charset="-120"/>
               </a:rPr>
-              <a:t>Worth about $25,000 against similar homes without one.</a:t>
+              <a:t>Every one of the closest sales had one, so it keeps your home in that group.</a:t>
             </a:r>
             <a:endParaRPr lang="en-US" sz="1200" dirty="0"/>
           </a:p>
@@ -15911,7 +15911,7 @@
                 <a:ea typeface="Arial" pitchFamily="34" charset="-122"/>
                 <a:cs typeface="Arial" pitchFamily="34" charset="-120"/>
               </a:rPr>
-              <a:t>Outside the high-risk flood zone, so lenders don't require flood insurance.</a:t>
+              <a:t>Outside the high-risk flood zones; buyers still get their own flood insurance quote.</a:t>
             </a:r>
             <a:endParaRPr lang="en-US" sz="1200" dirty="0"/>
           </a:p>
@@ -20247,7 +20247,7 @@
         <p:spPr>
           <a:xfrm>
             <a:off x="658368" y="2075688"/>
-            <a:ext cx="1113584" cy="347472"/>
+            <a:ext cx="1075809" cy="347472"/>
           </a:xfrm>
           <a:prstGeom prst="rect">
             <a:avLst/>
@@ -20285,8 +20285,8 @@
         </p:nvSpPr>
         <p:spPr>
           <a:xfrm>
-            <a:off x="1863392" y="2075688"/>
-            <a:ext cx="952960" cy="347472"/>
+            <a:off x="1825617" y="2075688"/>
+            <a:ext cx="990735" cy="347472"/>
           </a:xfrm>
           <a:prstGeom prst="rect">
             <a:avLst/>
@@ -20310,7 +20310,7 @@
                 <a:ea typeface="Arial" pitchFamily="34" charset="-122"/>
                 <a:cs typeface="Arial" pitchFamily="34" charset="-120"/>
               </a:rPr>
-              <a:t>45–90 days</a:t>
+              <a:t>2–4 months</a:t>
             </a:r>
             <a:endParaRPr lang="en-US" sz="1300" dirty="0"/>
           </a:p>

</xml_diff>

<commit_message>
Samples: regenerated after the manual smoke test fixes
Co-Authored-By: Claude Opus 5.5 <noreply@anthropic.com>
</commit_message>
<xml_diff>
--- a/samples/seller-cma/517-Larkwood-Ave-Listing-Presentation.pptx
+++ b/samples/seller-cma/517-Larkwood-Ave-Listing-Presentation.pptx
@@ -4054,7 +4054,7 @@
           <a:p>
             <a:r>
               <a:rPr lang="en-US" dirty="0"/>
-              <a:t>Adjustments: about $75 per sq ft of size difference; $30,000–$45,000 for renovation level; $5,000–$10,000 for larger or better lots; 1–2% for market change since the sale; seller-paid costs subtracted. A broker's opinion of value from comparable sales, not an appraisal, and not for lending. Sales data: Stellar MLS as of 2026-09-22. Deemed reliable but not guaranteed. This comparative market analysis is an opinion of price, not an appraisal, and isn't for lending purposes. Payment, tax and cost figures are estimates only, not lending or tax advice. Equal Housing Opportunity.</a:t>
+              <a:t>Adjustments: about $75 per sq ft of size difference; $30,000–$45,000 for renovation level; $5,000–$10,000 for larger or better lots; 1–2% for market change since the sale; seller-paid costs subtracted. A broker's opinion of value from comparable sales, not an appraisal, and not for lending. Sales data: Stellar MLS as of September 22, 2026. Deemed reliable but not guaranteed. This comparative market analysis is an opinion of price, not an appraisal, and isn't for lending purposes. Payment, tax and cost figures are estimates only, not lending or tax advice. Equal Housing Opportunity.</a:t>
             </a:r>
             <a:endParaRPr lang="en-US" dirty="0"/>
           </a:p>
@@ -5464,7 +5464,7 @@
                 <a:ea typeface="Arial" pitchFamily="34" charset="-122"/>
                 <a:cs typeface="Arial" pitchFamily="34" charset="-120"/>
               </a:rPr>
-              <a:t>Estimated net before mortgage payoff, after holding costs</a:t>
+              <a:t>Net after holding costs, before mortgage payoff</a:t>
             </a:r>
             <a:endParaRPr lang="en-US" sz="1300" dirty="0"/>
           </a:p>
@@ -13699,7 +13699,7 @@
                 <a:ea typeface="Arial" pitchFamily="34" charset="-122"/>
                 <a:cs typeface="Arial" pitchFamily="34" charset="-120"/>
               </a:rPr>
-              <a:t>A broker's opinion of value from comparable sales, not an appraisal, and not for lending. Sales data: Stellar MLS as of 2026-09-22. Deemed reliable but not guaranteed. Equal Housing Opportunity.</a:t>
+              <a:t>A broker's opinion of value from comparable sales, not an appraisal, and not for lending. Sales data: Stellar MLS as of September 22, 2026. Deemed reliable but not guaranteed. Equal Housing Opportunity.</a:t>
             </a:r>
             <a:endParaRPr lang="en-US" sz="1000" dirty="0"/>
           </a:p>

</xml_diff>

<commit_message>
status and samples after the iteration 12 fixes
Co-Authored-By: Claude Opus 5.5 <noreply@anthropic.com>
</commit_message>
<xml_diff>
--- a/samples/seller-cma/517-Larkwood-Ave-Listing-Presentation.pptx
+++ b/samples/seller-cma/517-Larkwood-Ave-Listing-Presentation.pptx
@@ -2966,13 +2966,13 @@
                 <c:formatCode>General</c:formatCode>
                 <c:ptCount val="3"/>
                 <c:pt idx="0">
-                  <c:v>409698</c:v>
+                  <c:v>423768</c:v>
                 </c:pt>
                 <c:pt idx="1">
-                  <c:v>410742</c:v>
+                  <c:v>424812</c:v>
                 </c:pt>
                 <c:pt idx="2">
-                  <c:v>402442</c:v>
+                  <c:v>419796</c:v>
                 </c:pt>
               </c:numCache>
             </c:numRef>
@@ -3607,7 +3607,7 @@
           <a:p>
             <a:r>
               <a:rPr lang="en-US" dirty="0"/>
-              <a:t>Before mortgage payoff. Brokerage is a 2.5% + 2.5% placeholder until we finalize the listing agreement.</a:t>
+              <a:t>Before mortgage payoff. Brokerage is assumed at 2.5% + 2.5% until we finalize the listing agreement.</a:t>
             </a:r>
             <a:endParaRPr lang="en-US" dirty="0"/>
           </a:p>
@@ -5539,7 +5539,7 @@
                 <a:ea typeface="Arial" pitchFamily="34" charset="-122"/>
                 <a:cs typeface="Arial" pitchFamily="34" charset="-120"/>
               </a:rPr>
-              <a:t>$8,300</a:t>
+              <a:t>$5,016</a:t>
             </a:r>
             <a:endParaRPr lang="en-US" sz="3200" dirty="0"/>
           </a:p>
@@ -7090,7 +7090,7 @@
                 <a:ea typeface="Arial" pitchFamily="34" charset="-122"/>
                 <a:cs typeface="Arial" pitchFamily="34" charset="-120"/>
               </a:rPr>
-              <a:t>Seller-Credit Budget</a:t>
+              <a:t>Decide on a Seller-Credit Budget</a:t>
             </a:r>
             <a:endParaRPr lang="en-US" sz="1300" dirty="0"/>
           </a:p>
@@ -7244,7 +7244,7 @@
                 <a:ea typeface="Arial" pitchFamily="34" charset="-122"/>
                 <a:cs typeface="Arial" pitchFamily="34" charset="-120"/>
               </a:rPr>
-              <a:t>3-Week Review</a:t>
+              <a:t>Agree on a Review Point</a:t>
             </a:r>
             <a:endParaRPr lang="en-US" sz="1300" dirty="0"/>
           </a:p>
@@ -8619,7 +8619,7 @@
                           <a:ea typeface="Arial" pitchFamily="34" charset="-122"/>
                           <a:cs typeface="Arial" pitchFamily="34" charset="-120"/>
                         </a:rPr>
-                        <a:t>$451,000</a:t>
+                        <a:t>$466,000</a:t>
                       </a:r>
                       <a:endParaRPr lang="en-US" sz="1100" dirty="0">
                         <a:latin typeface="Arial" charset="0"/>
@@ -8669,7 +8669,7 @@
                           <a:ea typeface="Arial" pitchFamily="34" charset="-122"/>
                           <a:cs typeface="Arial" pitchFamily="34" charset="-120"/>
                         </a:rPr>
-                        <a:t>$451,000</a:t>
+                        <a:t>$466,000</a:t>
                       </a:r>
                       <a:endParaRPr lang="en-US" sz="1100" dirty="0">
                         <a:latin typeface="Arial" charset="0"/>
@@ -8719,7 +8719,7 @@
                           <a:ea typeface="Arial" pitchFamily="34" charset="-122"/>
                           <a:cs typeface="Arial" pitchFamily="34" charset="-120"/>
                         </a:rPr>
-                        <a:t>$436,500</a:t>
+                        <a:t>$455,000</a:t>
                       </a:r>
                       <a:endParaRPr lang="en-US" sz="1100" dirty="0">
                         <a:latin typeface="Arial" charset="0"/>
@@ -8821,7 +8821,7 @@
                           <a:ea typeface="Arial" pitchFamily="34" charset="-122"/>
                           <a:cs typeface="Arial" pitchFamily="34" charset="-120"/>
                         </a:rPr>
-                        <a:t>−$11,275</a:t>
+                        <a:t>−$11,650</a:t>
                       </a:r>
                       <a:endParaRPr lang="en-US" sz="1100" dirty="0">
                         <a:latin typeface="Arial" charset="0"/>
@@ -8871,7 +8871,7 @@
                           <a:ea typeface="Arial" pitchFamily="34" charset="-122"/>
                           <a:cs typeface="Arial" pitchFamily="34" charset="-120"/>
                         </a:rPr>
-                        <a:t>−$11,275</a:t>
+                        <a:t>−$11,650</a:t>
                       </a:r>
                       <a:endParaRPr lang="en-US" sz="1100" dirty="0">
                         <a:latin typeface="Arial" charset="0"/>
@@ -8921,7 +8921,7 @@
                           <a:ea typeface="Arial" pitchFamily="34" charset="-122"/>
                           <a:cs typeface="Arial" pitchFamily="34" charset="-120"/>
                         </a:rPr>
-                        <a:t>−$10,912</a:t>
+                        <a:t>−$11,375</a:t>
                       </a:r>
                       <a:endParaRPr lang="en-US" sz="1100" dirty="0">
                         <a:latin typeface="Arial" charset="0"/>
@@ -9023,7 +9023,7 @@
                           <a:ea typeface="Arial" pitchFamily="34" charset="-122"/>
                           <a:cs typeface="Arial" pitchFamily="34" charset="-120"/>
                         </a:rPr>
-                        <a:t>−$11,275</a:t>
+                        <a:t>−$11,650</a:t>
                       </a:r>
                       <a:endParaRPr lang="en-US" sz="1100" dirty="0">
                         <a:latin typeface="Arial" charset="0"/>
@@ -9073,7 +9073,7 @@
                           <a:ea typeface="Arial" pitchFamily="34" charset="-122"/>
                           <a:cs typeface="Arial" pitchFamily="34" charset="-120"/>
                         </a:rPr>
-                        <a:t>−$11,275</a:t>
+                        <a:t>−$11,650</a:t>
                       </a:r>
                       <a:endParaRPr lang="en-US" sz="1100" dirty="0">
                         <a:latin typeface="Arial" charset="0"/>
@@ -9123,7 +9123,7 @@
                           <a:ea typeface="Arial" pitchFamily="34" charset="-122"/>
                           <a:cs typeface="Arial" pitchFamily="34" charset="-120"/>
                         </a:rPr>
-                        <a:t>−$10,912</a:t>
+                        <a:t>−$11,375</a:t>
                       </a:r>
                       <a:endParaRPr lang="en-US" sz="1100" dirty="0">
                         <a:latin typeface="Arial" charset="0"/>
@@ -9225,7 +9225,7 @@
                           <a:ea typeface="Arial" pitchFamily="34" charset="-122"/>
                           <a:cs typeface="Arial" pitchFamily="34" charset="-120"/>
                         </a:rPr>
-                        <a:t>−$3,157</a:t>
+                        <a:t>−$3,262</a:t>
                       </a:r>
                       <a:endParaRPr lang="en-US" sz="1100" dirty="0">
                         <a:latin typeface="Arial" charset="0"/>
@@ -9275,7 +9275,7 @@
                           <a:ea typeface="Arial" pitchFamily="34" charset="-122"/>
                           <a:cs typeface="Arial" pitchFamily="34" charset="-120"/>
                         </a:rPr>
-                        <a:t>−$3,157</a:t>
+                        <a:t>−$3,262</a:t>
                       </a:r>
                       <a:endParaRPr lang="en-US" sz="1100" dirty="0">
                         <a:latin typeface="Arial" charset="0"/>
@@ -9325,7 +9325,7 @@
                           <a:ea typeface="Arial" pitchFamily="34" charset="-122"/>
                           <a:cs typeface="Arial" pitchFamily="34" charset="-120"/>
                         </a:rPr>
-                        <a:t>−$3,056</a:t>
+                        <a:t>−$3,185</a:t>
                       </a:r>
                       <a:endParaRPr lang="en-US" sz="1100" dirty="0">
                         <a:latin typeface="Arial" charset="0"/>
@@ -9427,7 +9427,7 @@
                           <a:ea typeface="Arial" pitchFamily="34" charset="-122"/>
                           <a:cs typeface="Arial" pitchFamily="34" charset="-120"/>
                         </a:rPr>
-                        <a:t>−$2,330</a:t>
+                        <a:t>−$2,405</a:t>
                       </a:r>
                       <a:endParaRPr lang="en-US" sz="1100" dirty="0">
                         <a:latin typeface="Arial" charset="0"/>
@@ -9477,7 +9477,7 @@
                           <a:ea typeface="Arial" pitchFamily="34" charset="-122"/>
                           <a:cs typeface="Arial" pitchFamily="34" charset="-120"/>
                         </a:rPr>
-                        <a:t>−$2,330</a:t>
+                        <a:t>−$2,405</a:t>
                       </a:r>
                       <a:endParaRPr lang="en-US" sz="1100" dirty="0">
                         <a:latin typeface="Arial" charset="0"/>
@@ -9527,7 +9527,7 @@
                           <a:ea typeface="Arial" pitchFamily="34" charset="-122"/>
                           <a:cs typeface="Arial" pitchFamily="34" charset="-120"/>
                         </a:rPr>
-                        <a:t>−$2,258</a:t>
+                        <a:t>−$2,350</a:t>
                       </a:r>
                       <a:endParaRPr lang="en-US" sz="1100" dirty="0">
                         <a:latin typeface="Arial" charset="0"/>
@@ -10039,7 +10039,7 @@
                           <a:ea typeface="Arial" pitchFamily="34" charset="-122"/>
                           <a:cs typeface="Arial" pitchFamily="34" charset="-120"/>
                         </a:rPr>
-                        <a:t>$411,818</a:t>
+                        <a:t>$425,888</a:t>
                       </a:r>
                       <a:endParaRPr lang="en-US" sz="1100" dirty="0">
                         <a:latin typeface="Arial" charset="0"/>
@@ -10095,7 +10095,7 @@
                           <a:ea typeface="Arial" pitchFamily="34" charset="-122"/>
                           <a:cs typeface="Arial" pitchFamily="34" charset="-120"/>
                         </a:rPr>
-                        <a:t>$411,818</a:t>
+                        <a:t>$425,888</a:t>
                       </a:r>
                       <a:endParaRPr lang="en-US" sz="1100" dirty="0">
                         <a:latin typeface="Arial" charset="0"/>
@@ -10151,7 +10151,7 @@
                           <a:ea typeface="Arial" pitchFamily="34" charset="-122"/>
                           <a:cs typeface="Arial" pitchFamily="34" charset="-120"/>
                         </a:rPr>
-                        <a:t>$403,216</a:t>
+                        <a:t>$420,570</a:t>
                       </a:r>
                       <a:endParaRPr lang="en-US" sz="1100" dirty="0">
                         <a:latin typeface="Arial" charset="0"/>
@@ -10467,7 +10467,7 @@
                           <a:ea typeface="Arial" pitchFamily="34" charset="-122"/>
                           <a:cs typeface="Arial" pitchFamily="34" charset="-120"/>
                         </a:rPr>
-                        <a:t>$409,698</a:t>
+                        <a:t>$423,768</a:t>
                       </a:r>
                       <a:endParaRPr lang="en-US" sz="1100" dirty="0">
                         <a:latin typeface="Arial" charset="0"/>
@@ -10523,7 +10523,7 @@
                           <a:ea typeface="Arial" pitchFamily="34" charset="-122"/>
                           <a:cs typeface="Arial" pitchFamily="34" charset="-120"/>
                         </a:rPr>
-                        <a:t>$410,742</a:t>
+                        <a:t>$424,812</a:t>
                       </a:r>
                       <a:endParaRPr lang="en-US" sz="1100" dirty="0">
                         <a:latin typeface="Arial" charset="0"/>
@@ -10579,7 +10579,7 @@
                           <a:ea typeface="Arial" pitchFamily="34" charset="-122"/>
                           <a:cs typeface="Arial" pitchFamily="34" charset="-120"/>
                         </a:rPr>
-                        <a:t>$402,442</a:t>
+                        <a:t>$419,796</a:t>
                       </a:r>
                       <a:endParaRPr lang="en-US" sz="1100" dirty="0">
                         <a:latin typeface="Arial" charset="0"/>
@@ -12829,7 +12829,7 @@
                 <a:ea typeface="Arial" pitchFamily="34" charset="-122"/>
                 <a:cs typeface="Arial" pitchFamily="34" charset="-120"/>
               </a:rPr>
-              <a:t>About $451,000</a:t>
+              <a:t>About $466,000</a:t>
             </a:r>
             <a:endParaRPr lang="en-US" sz="2400" dirty="0"/>
           </a:p>
@@ -19385,7 +19385,7 @@
                 <a:ea typeface="Arial" pitchFamily="34" charset="-122"/>
                 <a:cs typeface="Arial" pitchFamily="34" charset="-120"/>
               </a:rPr>
-              <a:t>$451,000</a:t>
+              <a:t>$466,000</a:t>
             </a:r>
             <a:endParaRPr lang="en-US" sz="1300" dirty="0"/>
           </a:p>
@@ -19763,7 +19763,7 @@
                 <a:ea typeface="Arial" pitchFamily="34" charset="-122"/>
                 <a:cs typeface="Arial" pitchFamily="34" charset="-120"/>
               </a:rPr>
-              <a:t>$451,000</a:t>
+              <a:t>$466,000</a:t>
             </a:r>
             <a:endParaRPr lang="en-US" sz="1300" dirty="0"/>
           </a:p>
@@ -20102,7 +20102,7 @@
                 <a:ea typeface="Arial" pitchFamily="34" charset="-122"/>
                 <a:cs typeface="Arial" pitchFamily="34" charset="-120"/>
               </a:rPr>
-              <a:t>$436,500</a:t>
+              <a:t>$455,000</a:t>
             </a:r>
             <a:endParaRPr lang="en-US" sz="1300" dirty="0"/>
           </a:p>

</xml_diff>

<commit_message>
status and samples after the fifth manual run fixes
Co-Authored-By: Claude Opus 5.5 <noreply@anthropic.com>
</commit_message>
<xml_diff>
--- a/samples/seller-cma/517-Larkwood-Ave-Listing-Presentation.pptx
+++ b/samples/seller-cma/517-Larkwood-Ave-Listing-Presentation.pptx
@@ -663,7 +663,7 @@
           </c:tx>
           <c:spPr>
             <a:solidFill>
-              <a:srgbClr val="A6A6A6"/>
+              <a:srgbClr val="5E5E5E"/>
             </a:solidFill>
             <a:ln>
               <a:noFill/>
@@ -675,11 +675,11 @@
             <c:size val="7"/>
             <c:spPr>
               <a:solidFill>
-                <a:srgbClr val="A6A6A6"/>
+                <a:srgbClr val="FFFFFF"/>
               </a:solidFill>
               <a:ln w="15875">
                 <a:solidFill>
-                  <a:srgbClr val="A6A6A6"/>
+                  <a:srgbClr val="5E5E5E"/>
                 </a:solidFill>
               </a:ln>
             </c:spPr>
@@ -2185,12 +2185,12 @@
           </c:spPr>
           <c:marker>
             <c:symbol val="diamond"/>
-            <c:size val="14"/>
+            <c:size val="11"/>
             <c:spPr>
               <a:solidFill>
                 <a:srgbClr val="1A1A1A"/>
               </a:solidFill>
-              <a:ln w="12700">
+              <a:ln w="19050">
                 <a:solidFill>
                   <a:srgbClr val="FFFFFF"/>
                 </a:solidFill>
@@ -8024,7 +8024,7 @@
                 <a:ea typeface="Arial" pitchFamily="34" charset="-122"/>
                 <a:cs typeface="Arial" pitchFamily="34" charset="-120"/>
               </a:rPr>
-              <a:t>Week 3</a:t>
+              <a:t>Early October</a:t>
             </a:r>
             <a:endParaRPr lang="en-US" sz="1200" dirty="0"/>
           </a:p>
@@ -11209,7 +11209,7 @@
                           <a:ea typeface="Arial" pitchFamily="34" charset="-122"/>
                           <a:cs typeface="Arial" pitchFamily="34" charset="-120"/>
                         </a:rPr>
-                        <a:t>$492,300</a:t>
+                        <a:t>$493,900</a:t>
                       </a:r>
                       <a:endParaRPr lang="en-US" sz="1100" dirty="0">
                         <a:latin typeface="Arial" charset="0"/>
@@ -11411,7 +11411,7 @@
                           <a:ea typeface="Arial" pitchFamily="34" charset="-122"/>
                           <a:cs typeface="Arial" pitchFamily="34" charset="-120"/>
                         </a:rPr>
-                        <a:t>$483,800</a:t>
+                        <a:t>$484,000</a:t>
                       </a:r>
                       <a:endParaRPr lang="en-US" sz="1100" dirty="0">
                         <a:latin typeface="Arial" charset="0"/>
@@ -11815,7 +11815,7 @@
                           <a:ea typeface="Arial" pitchFamily="34" charset="-122"/>
                           <a:cs typeface="Arial" pitchFamily="34" charset="-120"/>
                         </a:rPr>
-                        <a:t>$438,400</a:t>
+                        <a:t>$440,200</a:t>
                       </a:r>
                       <a:endParaRPr lang="en-US" sz="1100" dirty="0">
                         <a:latin typeface="Arial" charset="0"/>
@@ -12017,7 +12017,7 @@
                           <a:ea typeface="Arial" pitchFamily="34" charset="-122"/>
                           <a:cs typeface="Arial" pitchFamily="34" charset="-120"/>
                         </a:rPr>
-                        <a:t>$436,200</a:t>
+                        <a:t>$435,900</a:t>
                       </a:r>
                       <a:endParaRPr lang="en-US" sz="1100" dirty="0">
                         <a:latin typeface="Arial" charset="0"/>
@@ -13466,7 +13466,7 @@
                 <a:ea typeface="Arial" pitchFamily="34" charset="-122"/>
                 <a:cs typeface="Arial" pitchFamily="34" charset="-120"/>
               </a:rPr>
-              <a:t>$436K–$492K</a:t>
+              <a:t>$436K–$494K</a:t>
             </a:r>
             <a:endParaRPr lang="en-US" sz="2200" dirty="0"/>
           </a:p>
@@ -15585,7 +15585,7 @@
         </p:nvSpPr>
         <p:spPr>
           <a:xfrm>
-            <a:off x="7155180" y="1536192"/>
+            <a:off x="7228332" y="1536192"/>
             <a:ext cx="164592" cy="164592"/>
           </a:xfrm>
           <a:prstGeom prst="ellipse">
@@ -15610,7 +15610,7 @@
         </p:nvSpPr>
         <p:spPr>
           <a:xfrm>
-            <a:off x="7347204" y="1490472"/>
+            <a:off x="7420356" y="1490472"/>
             <a:ext cx="640080" cy="237744"/>
           </a:xfrm>
           <a:prstGeom prst="rect">
@@ -15635,7 +15635,7 @@
                 <a:ea typeface="Arial" pitchFamily="34" charset="-122"/>
                 <a:cs typeface="Arial" pitchFamily="34" charset="-120"/>
               </a:rPr>
-              <a:t>$492K</a:t>
+              <a:t>$494K</a:t>
             </a:r>
             <a:endParaRPr lang="en-US" sz="1000" dirty="0"/>
           </a:p>
@@ -15727,7 +15727,7 @@
         </p:nvSpPr>
         <p:spPr>
           <a:xfrm>
-            <a:off x="6766560" y="1993392"/>
+            <a:off x="6775704" y="1993392"/>
             <a:ext cx="164592" cy="164592"/>
           </a:xfrm>
           <a:prstGeom prst="ellipse">
@@ -15752,7 +15752,7 @@
         </p:nvSpPr>
         <p:spPr>
           <a:xfrm>
-            <a:off x="6958584" y="1947672"/>
+            <a:off x="6967728" y="1947672"/>
             <a:ext cx="640080" cy="237744"/>
           </a:xfrm>
           <a:prstGeom prst="rect">
@@ -15855,7 +15855,7 @@
                 <a:ea typeface="Arial" pitchFamily="34" charset="-122"/>
                 <a:cs typeface="Arial" pitchFamily="34" charset="-120"/>
               </a:rPr>
-              <a:t>Most recent pool sale; not renovated</a:t>
+              <a:t>Strongest match · Most recent pool sale; not renovated</a:t>
             </a:r>
             <a:endParaRPr lang="en-US" sz="950" dirty="0"/>
           </a:p>
@@ -16011,7 +16011,7 @@
         </p:nvSpPr>
         <p:spPr>
           <a:xfrm>
-            <a:off x="4690872" y="2907792"/>
+            <a:off x="4773168" y="2907792"/>
             <a:ext cx="164592" cy="164592"/>
           </a:xfrm>
           <a:prstGeom prst="ellipse">
@@ -16036,7 +16036,7 @@
         </p:nvSpPr>
         <p:spPr>
           <a:xfrm>
-            <a:off x="4882896" y="2862072"/>
+            <a:off x="4965192" y="2862072"/>
             <a:ext cx="640080" cy="237744"/>
           </a:xfrm>
           <a:prstGeom prst="rect">
@@ -16061,7 +16061,7 @@
                 <a:ea typeface="Arial" pitchFamily="34" charset="-122"/>
                 <a:cs typeface="Arial" pitchFamily="34" charset="-120"/>
               </a:rPr>
-              <a:t>$438K</a:t>
+              <a:t>$440K</a:t>
             </a:r>
             <a:endParaRPr lang="en-US" sz="1000" dirty="0"/>
           </a:p>
@@ -16153,7 +16153,7 @@
         </p:nvSpPr>
         <p:spPr>
           <a:xfrm>
-            <a:off x="4590288" y="3364992"/>
+            <a:off x="4576572" y="3364992"/>
             <a:ext cx="164592" cy="164592"/>
           </a:xfrm>
           <a:prstGeom prst="ellipse">
@@ -16178,7 +16178,7 @@
         </p:nvSpPr>
         <p:spPr>
           <a:xfrm>
-            <a:off x="4782312" y="3319272"/>
+            <a:off x="4768596" y="3319272"/>
             <a:ext cx="640080" cy="237744"/>
           </a:xfrm>
           <a:prstGeom prst="rect">
@@ -16436,48 +16436,9 @@
           </a:ln>
         </p:spPr>
       </p:sp>
-      <p:sp>
-        <p:nvSpPr>
-          <p:cNvPr id="4" name="Text 2"/>
-          <p:cNvSpPr txBox="1"/>
-          <p:nvPr/>
-        </p:nvSpPr>
-        <p:spPr>
-          <a:xfrm>
-            <a:off x="1223467" y="2331393"/>
-            <a:ext cx="2743200" cy="201168"/>
-          </a:xfrm>
-          <a:prstGeom prst="rect">
-            <a:avLst/>
-          </a:prstGeom>
-          <a:noFill/>
-          <a:ln/>
-        </p:spPr>
-        <p:txBody>
-          <a:bodyPr wrap="square" lIns="0" tIns="0" rIns="0" bIns="0" rtlCol="0" anchor="ctr"/>
-          <a:lstStyle/>
-          <a:p>
-            <a:pPr indent="0" marL="0">
-              <a:buNone/>
-            </a:pPr>
-            <a:r>
-              <a:rPr lang="en-US" sz="900" b="1" dirty="0">
-                <a:solidFill>
-                  <a:srgbClr val="A23200"/>
-                </a:solidFill>
-                <a:latin typeface="Arial" pitchFamily="34" charset="0"/>
-                <a:ea typeface="Arial" pitchFamily="34" charset="-122"/>
-                <a:cs typeface="Arial" pitchFamily="34" charset="-120"/>
-              </a:rPr>
-              <a:t>Supported Range $455K–$480K</a:t>
-            </a:r>
-            <a:endParaRPr lang="en-US" sz="900" dirty="0"/>
-          </a:p>
-        </p:txBody>
-      </p:sp>
       <p:graphicFrame>
         <p:nvGraphicFramePr>
-          <p:cNvPr id="5" name="Chart 0" descr=""/>
+          <p:cNvPr id="4" name="Chart 0" descr=""/>
           <p:cNvGraphicFramePr/>
           <p:nvPr/>
         </p:nvGraphicFramePr>
@@ -16493,6 +16454,47 @@
       </p:graphicFrame>
       <p:sp>
         <p:nvSpPr>
+          <p:cNvPr id="5" name="Text 2"/>
+          <p:cNvSpPr txBox="1"/>
+          <p:nvPr/>
+        </p:nvSpPr>
+        <p:spPr>
+          <a:xfrm>
+            <a:off x="1205179" y="2331393"/>
+            <a:ext cx="1899940" cy="182880"/>
+          </a:xfrm>
+          <a:prstGeom prst="rect">
+            <a:avLst/>
+          </a:prstGeom>
+          <a:solidFill>
+            <a:srgbClr val="FBF2EE"/>
+          </a:solidFill>
+          <a:ln/>
+        </p:spPr>
+        <p:txBody>
+          <a:bodyPr wrap="square" lIns="0" tIns="762" rIns="762" bIns="0" rtlCol="0" anchor="ctr"/>
+          <a:lstStyle/>
+          <a:p>
+            <a:pPr indent="0" marL="0">
+              <a:buNone/>
+            </a:pPr>
+            <a:r>
+              <a:rPr lang="en-US" sz="900" b="1" dirty="0">
+                <a:solidFill>
+                  <a:srgbClr val="A23200"/>
+                </a:solidFill>
+                <a:latin typeface="Arial" pitchFamily="34" charset="0"/>
+                <a:ea typeface="Arial" pitchFamily="34" charset="-122"/>
+                <a:cs typeface="Arial" pitchFamily="34" charset="-120"/>
+              </a:rPr>
+              <a:t>Supported Range $455K–$480K</a:t>
+            </a:r>
+            <a:endParaRPr lang="en-US" sz="900" dirty="0"/>
+          </a:p>
+        </p:txBody>
+      </p:sp>
+      <p:sp>
+        <p:nvSpPr>
           <p:cNvPr id="6" name="Shape 3"/>
           <p:cNvSpPr/>
           <p:nvPr/>
@@ -16570,11 +16572,11 @@
             <a:avLst/>
           </a:prstGeom>
           <a:solidFill>
-            <a:srgbClr val="A6A6A6"/>
+            <a:srgbClr val="FFFFFF"/>
           </a:solidFill>
-          <a:ln w="6350">
+          <a:ln w="15875">
             <a:solidFill>
-              <a:srgbClr val="A6A6A6"/>
+              <a:srgbClr val="5E5E5E"/>
             </a:solidFill>
             <a:prstDash val="solid"/>
           </a:ln>

</xml_diff>

<commit_message>
Samples for the strategy categories; buyer CMA tax row reads (City, With Homestead)
Co-Authored-By: Claude Opus 5.5 <noreply@anthropic.com>
</commit_message>
<xml_diff>
--- a/samples/seller-cma/517-Larkwood-Ave-Listing-Presentation.pptx
+++ b/samples/seller-cma/517-Larkwood-Ave-Listing-Presentation.pptx
@@ -2916,13 +2916,13 @@
                 <c:ptCount val="3"/>
                 <c:lvl>
                   <c:pt idx="0">
-                    <c:v>List at $479,900</c:v>
+                    <c:v>Premium at $474,900</c:v>
                   </c:pt>
                   <c:pt idx="1">
-                    <c:v>List at $469,900</c:v>
+                    <c:v>Market Price at $469,900</c:v>
                   </c:pt>
                   <c:pt idx="2">
-                    <c:v>List at $459,900</c:v>
+                    <c:v>Draw Offers at $459,900</c:v>
                   </c:pt>
                 </c:lvl>
               </c:multiLvlStrCache>
@@ -2935,13 +2935,13 @@
                 <c:formatCode>General</c:formatCode>
                 <c:ptCount val="3"/>
                 <c:pt idx="0">
-                  <c:v>423519</c:v>
+                  <c:v>424222</c:v>
                 </c:pt>
                 <c:pt idx="1">
-                  <c:v>424563</c:v>
+                  <c:v>424636</c:v>
                 </c:pt>
                 <c:pt idx="2">
-                  <c:v>419558</c:v>
+                  <c:v>415497</c:v>
                 </c:pt>
               </c:numCache>
             </c:numRef>
@@ -3917,7 +3917,7 @@
           <a:p>
             <a:r>
               <a:rPr lang="en-US" dirty="0"/>
-              <a:t>Expected sales are estimates, not guarantees: each option's list price times an assumed 97.0% of its final asking price after seller-paid costs, plus that option's seller credit, to the nearest $500. None is below the supported range (the comps are already net of seller credits) or above its list price or the top of the range. At $479,900 we expect the recommended option's sale: a price above the range usually sells after a cut, so it costs time rather than adding to the sale. Holding costs: about $530 a month (insurance and utilities; no loan interest, since no mortgage payoff was given) from the report date to each option's closing; property tax is in the proration. Title company fees are typical local charges (settlement fee $700, title search $250, municipal lien search $125, recording $70); the title company's quote replaces them. Buyer payments: Conventional loan, 5% down, 6.95% 30-year fixed, property taxes at 18.1808 mills, with homestead, $3,600 a year insurance, and 0.5% a year mortgage insurance. Commissions are negotiable and not set by law. Not included: your mortgage payoff, this year's property tax proration (the tax bill and the expected closing date add it) and any repairs agreed after inspection. The closing agent provides the exact figures. Flood zone X: a lender may not require flood insurance, but a Citizens policy on a home with a dwelling replacement cost of $400,000 or more must carry flood insurance, and from January 1, 2027 every Citizens policy must (s. 627.351(6)(aa)). Get a quote; the total leaves it out until then.</a:t>
+              <a:t>Expected sales are estimates, not guarantees: each option's list price times an assumed 97.0% of its final asking price after seller-paid costs, plus that option's seller credit, to the nearest $500. At $474,900 we expect the recommended option's sale: a price above the recommended one usually sells after a cut, so it costs time rather than adding to the sale. Times to contract are estimates from the recent median of 22 days on market: longer for a higher price, shorter for a price that draws competing offers. Each option assumes a $11,000 seller credit toward the buyer's costs: how often recent sellers paid buyer costs times the typical amount. Holding costs: about $520 a month (insurance at the recommended $469,900 list price and utilities; no loan interest, since no mortgage payoff was given) from the report date to each option's closing; property tax is in the proration. Title company fees are typical local charges (settlement fee $700, title search $250, municipal lien search $125, recording $70); the title company's quote replaces them. Buyer payments: Conventional loan, 5% down, 6.95% 30-year fixed, property taxes at 18.1808 mills, with homestead, $3,600 a year insurance, and 0.5% a year mortgage insurance. Commissions are negotiable and not set by law. Not included: your mortgage payoff, this year's property tax proration (the tax bill and the expected closing date add it) and any repairs agreed after inspection. The closing agent provides the exact figures. Flood zone X: a lender may not require flood insurance, but a Citizens policy on a home with a dwelling replacement cost of $400,000 or more must carry flood insurance, and from January 1, 2027 every Citizens policy must (s. 627.351(6)(aa)). Get a quote; the total leaves it out until then.</a:t>
             </a:r>
             <a:endParaRPr lang="en-US" dirty="0"/>
           </a:p>
@@ -4005,7 +4005,7 @@
           <a:p>
             <a:r>
               <a:rPr lang="en-US" dirty="0"/>
-              <a:t>Adjusted for size ($1,200 to $1,800), lot ($5,000), market changes since each sale (1% a quarter off sales before July), roof and systems ($5,000), condition and updates ($30,000 to $45,000), view or water ($10,000) and seller credits (taken off each sale price). These are the five closest matches, sold Apr 24, 2026 to Aug 20, 2026 (one since July), all within a mile.</a:t>
+              <a:t>Adjusted for size ($1,200 to $1,800), lot ($5,000), market changes since each sale (1% a quarter off sales before July), roof and systems ($5,000), condition and updates ($30,000 to $45,000, against this home's full renovation), view or water ($10,000) and seller credits (taken off each sale price). These are the five closest matches, sold Apr 24, 2026 to Aug 20, 2026 (one since July), all within a mile.</a:t>
             </a:r>
             <a:endParaRPr lang="en-US" dirty="0"/>
           </a:p>
@@ -4533,7 +4533,7 @@
           <a:p>
             <a:r>
               <a:rPr lang="en-US" dirty="0"/>
-              <a:t>The earlier period is the spring sales; now is the summer sales. The report's market table has every figure.</a:t>
+              <a:t>The earlier period holds the older sales; now holds the recent ones. The report's market table has every figure.</a:t>
             </a:r>
             <a:endParaRPr lang="en-US" dirty="0"/>
           </a:p>
@@ -5497,7 +5497,7 @@
                 <a:ea typeface="Arial" pitchFamily="34" charset="-122"/>
                 <a:cs typeface="Arial" pitchFamily="34" charset="-120"/>
               </a:rPr>
-              <a:t>$5,005</a:t>
+              <a:t>$9,139</a:t>
             </a:r>
             <a:endParaRPr lang="en-US" sz="3200" dirty="0"/>
           </a:p>
@@ -5829,7 +5829,7 @@
                 <a:ea typeface="Arial" pitchFamily="34" charset="-122"/>
                 <a:cs typeface="Arial" pitchFamily="34" charset="-120"/>
               </a:rPr>
-              <a:t>List at $479,900</a:t>
+              <a:t>Premium at $474,900</a:t>
             </a:r>
             <a:endParaRPr lang="en-US" sz="1300" dirty="0"/>
           </a:p>
@@ -5868,7 +5868,7 @@
                 <a:ea typeface="Arial" pitchFamily="34" charset="-122"/>
                 <a:cs typeface="Arial" pitchFamily="34" charset="-120"/>
               </a:rPr>
-              <a:t>$4,169/mo</a:t>
+              <a:t>$4,127/mo</a:t>
             </a:r>
             <a:endParaRPr lang="en-US" sz="2800" dirty="0"/>
           </a:p>
@@ -5907,7 +5907,7 @@
                 <a:ea typeface="Arial" pitchFamily="34" charset="-122"/>
                 <a:cs typeface="Arial" pitchFamily="34" charset="-120"/>
               </a:rPr>
-              <a:t>$23,995 down (5%)</a:t>
+              <a:t>$23,745 down (5%)</a:t>
             </a:r>
             <a:endParaRPr lang="en-US" sz="1100" dirty="0"/>
           </a:p>
@@ -5973,7 +5973,7 @@
                 <a:ea typeface="Arial" pitchFamily="34" charset="-122"/>
                 <a:cs typeface="Arial" pitchFamily="34" charset="-120"/>
               </a:rPr>
-              <a:t>List at $469,900</a:t>
+              <a:t>Market Price at $469,900</a:t>
             </a:r>
             <a:endParaRPr lang="en-US" sz="1300" dirty="0"/>
           </a:p>
@@ -6117,7 +6117,7 @@
                 <a:ea typeface="Arial" pitchFamily="34" charset="-122"/>
                 <a:cs typeface="Arial" pitchFamily="34" charset="-120"/>
               </a:rPr>
-              <a:t>List at $459,900</a:t>
+              <a:t>Draw Offers at $459,900</a:t>
             </a:r>
             <a:endParaRPr lang="en-US" sz="1300" dirty="0"/>
           </a:p>
@@ -8500,7 +8500,7 @@
                 <a:gridCol w="1645920"/>
                 <a:gridCol w="1645920"/>
               </a:tblGrid>
-              <a:tr h="270976">
+              <a:tr h="258064">
                 <a:tc>
                   <a:txBody>
                     <a:bodyPr/>
@@ -8510,7 +8510,7 @@
                         <a:buNone/>
                       </a:pPr>
                       <a:r>
-                        <a:rPr lang="en-US" sz="1100" b="1" dirty="0">
+                        <a:rPr lang="en-US" sz="1000" b="1" dirty="0">
                           <a:solidFill>
                             <a:srgbClr val="A23200"/>
                           </a:solidFill>
@@ -8520,7 +8520,7 @@
                         </a:rPr>
                         <a:t>Estimated at Closing</a:t>
                       </a:r>
-                      <a:endParaRPr lang="en-US" sz="1100" dirty="0">
+                      <a:endParaRPr lang="en-US" sz="1000" dirty="0">
                         <a:latin typeface="Arial" charset="0"/>
                         <a:ea typeface="Arial" charset="0"/>
                         <a:cs typeface="Arial" charset="0"/>
@@ -8560,7 +8560,7 @@
                         <a:buNone/>
                       </a:pPr>
                       <a:r>
-                        <a:rPr lang="en-US" sz="1100" b="1" dirty="0">
+                        <a:rPr lang="en-US" sz="1000" b="1" dirty="0">
                           <a:solidFill>
                             <a:srgbClr val="A23200"/>
                           </a:solidFill>
@@ -8568,9 +8568,9 @@
                           <a:ea typeface="Arial" pitchFamily="34" charset="-122"/>
                           <a:cs typeface="Arial" pitchFamily="34" charset="-120"/>
                         </a:rPr>
-                        <a:t>List at $479,900</a:t>
+                        <a:t>Premium at $474,900</a:t>
                       </a:r>
-                      <a:endParaRPr lang="en-US" sz="1100" dirty="0">
+                      <a:endParaRPr lang="en-US" sz="1000" dirty="0">
                         <a:latin typeface="Arial" charset="0"/>
                         <a:ea typeface="Arial" charset="0"/>
                         <a:cs typeface="Arial" charset="0"/>
@@ -8610,7 +8610,7 @@
                         <a:buNone/>
                       </a:pPr>
                       <a:r>
-                        <a:rPr lang="en-US" sz="1100" b="1" dirty="0">
+                        <a:rPr lang="en-US" sz="1000" b="1" dirty="0">
                           <a:solidFill>
                             <a:srgbClr val="A23200"/>
                           </a:solidFill>
@@ -8618,9 +8618,9 @@
                           <a:ea typeface="Arial" pitchFamily="34" charset="-122"/>
                           <a:cs typeface="Arial" pitchFamily="34" charset="-120"/>
                         </a:rPr>
-                        <a:t>List at $469,900</a:t>
+                        <a:t>Market Price at $469,900</a:t>
                       </a:r>
-                      <a:endParaRPr lang="en-US" sz="1100" dirty="0">
+                      <a:endParaRPr lang="en-US" sz="1000" dirty="0">
                         <a:latin typeface="Arial" charset="0"/>
                         <a:ea typeface="Arial" charset="0"/>
                         <a:cs typeface="Arial" charset="0"/>
@@ -8660,7 +8660,7 @@
                         <a:buNone/>
                       </a:pPr>
                       <a:r>
-                        <a:rPr lang="en-US" sz="1100" b="1" dirty="0">
+                        <a:rPr lang="en-US" sz="1000" b="1" dirty="0">
                           <a:solidFill>
                             <a:srgbClr val="A23200"/>
                           </a:solidFill>
@@ -8668,9 +8668,9 @@
                           <a:ea typeface="Arial" pitchFamily="34" charset="-122"/>
                           <a:cs typeface="Arial" pitchFamily="34" charset="-120"/>
                         </a:rPr>
-                        <a:t>List at $459,900</a:t>
+                        <a:t>Draw Offers at $459,900</a:t>
                       </a:r>
-                      <a:endParaRPr lang="en-US" sz="1100" dirty="0">
+                      <a:endParaRPr lang="en-US" sz="1000" dirty="0">
                         <a:latin typeface="Arial" charset="0"/>
                         <a:ea typeface="Arial" charset="0"/>
                         <a:cs typeface="Arial" charset="0"/>
@@ -8702,7 +8702,7 @@
                   </a:tcPr>
                 </a:tc>
               </a:tr>
-              <a:tr h="270976">
+              <a:tr h="258064">
                 <a:tc>
                   <a:txBody>
                     <a:bodyPr/>
@@ -8712,7 +8712,7 @@
                         <a:buNone/>
                       </a:pPr>
                       <a:r>
-                        <a:rPr lang="en-US" sz="1100" dirty="0">
+                        <a:rPr lang="en-US" sz="1000" dirty="0">
                           <a:solidFill>
                             <a:srgbClr val="1A1A1A"/>
                           </a:solidFill>
@@ -8722,7 +8722,7 @@
                         </a:rPr>
                         <a:t>Expected Sale Price</a:t>
                       </a:r>
-                      <a:endParaRPr lang="en-US" sz="1100" dirty="0">
+                      <a:endParaRPr lang="en-US" sz="1000" dirty="0">
                         <a:latin typeface="Arial" charset="0"/>
                         <a:ea typeface="Arial" charset="0"/>
                         <a:cs typeface="Arial" charset="0"/>
@@ -8762,7 +8762,7 @@
                         <a:buNone/>
                       </a:pPr>
                       <a:r>
-                        <a:rPr lang="en-US" sz="1100" dirty="0">
+                        <a:rPr lang="en-US" sz="1000" dirty="0">
                           <a:solidFill>
                             <a:srgbClr val="1A1A1A"/>
                           </a:solidFill>
@@ -8770,9 +8770,9 @@
                           <a:ea typeface="Arial" pitchFamily="34" charset="-122"/>
                           <a:cs typeface="Arial" pitchFamily="34" charset="-120"/>
                         </a:rPr>
-                        <a:t>$466,000</a:t>
+                        <a:t>$467,000</a:t>
                       </a:r>
-                      <a:endParaRPr lang="en-US" sz="1100" dirty="0">
+                      <a:endParaRPr lang="en-US" sz="1000" dirty="0">
                         <a:latin typeface="Arial" charset="0"/>
                         <a:ea typeface="Arial" charset="0"/>
                         <a:cs typeface="Arial" charset="0"/>
@@ -8812,7 +8812,7 @@
                         <a:buNone/>
                       </a:pPr>
                       <a:r>
-                        <a:rPr lang="en-US" sz="1100" dirty="0">
+                        <a:rPr lang="en-US" sz="1000" dirty="0">
                           <a:solidFill>
                             <a:srgbClr val="1A1A1A"/>
                           </a:solidFill>
@@ -8820,9 +8820,9 @@
                           <a:ea typeface="Arial" pitchFamily="34" charset="-122"/>
                           <a:cs typeface="Arial" pitchFamily="34" charset="-120"/>
                         </a:rPr>
-                        <a:t>$466,000</a:t>
+                        <a:t>$467,000</a:t>
                       </a:r>
-                      <a:endParaRPr lang="en-US" sz="1100" dirty="0">
+                      <a:endParaRPr lang="en-US" sz="1000" dirty="0">
                         <a:latin typeface="Arial" charset="0"/>
                         <a:ea typeface="Arial" charset="0"/>
                         <a:cs typeface="Arial" charset="0"/>
@@ -8862,7 +8862,7 @@
                         <a:buNone/>
                       </a:pPr>
                       <a:r>
-                        <a:rPr lang="en-US" sz="1100" dirty="0">
+                        <a:rPr lang="en-US" sz="1000" dirty="0">
                           <a:solidFill>
                             <a:srgbClr val="1A1A1A"/>
                           </a:solidFill>
@@ -8870,9 +8870,9 @@
                           <a:ea typeface="Arial" pitchFamily="34" charset="-122"/>
                           <a:cs typeface="Arial" pitchFamily="34" charset="-120"/>
                         </a:rPr>
-                        <a:t>$455,000</a:t>
+                        <a:t>$457,000</a:t>
                       </a:r>
-                      <a:endParaRPr lang="en-US" sz="1100" dirty="0">
+                      <a:endParaRPr lang="en-US" sz="1000" dirty="0">
                         <a:latin typeface="Arial" charset="0"/>
                         <a:ea typeface="Arial" charset="0"/>
                         <a:cs typeface="Arial" charset="0"/>
@@ -8904,7 +8904,7 @@
                   </a:tcPr>
                 </a:tc>
               </a:tr>
-              <a:tr h="270976">
+              <a:tr h="258064">
                 <a:tc>
                   <a:txBody>
                     <a:bodyPr/>
@@ -8914,7 +8914,7 @@
                         <a:buNone/>
                       </a:pPr>
                       <a:r>
-                        <a:rPr lang="en-US" sz="1100" dirty="0">
+                        <a:rPr lang="en-US" sz="1000" dirty="0">
                           <a:solidFill>
                             <a:srgbClr val="1A1A1A"/>
                           </a:solidFill>
@@ -8924,7 +8924,7 @@
                         </a:rPr>
                         <a:t>Expected Closing</a:t>
                       </a:r>
-                      <a:endParaRPr lang="en-US" sz="1100" dirty="0">
+                      <a:endParaRPr lang="en-US" sz="1000" dirty="0">
                         <a:latin typeface="Arial" charset="0"/>
                         <a:ea typeface="Arial" charset="0"/>
                         <a:cs typeface="Arial" charset="0"/>
@@ -8964,7 +8964,7 @@
                         <a:buNone/>
                       </a:pPr>
                       <a:r>
-                        <a:rPr lang="en-US" sz="1100" dirty="0">
+                        <a:rPr lang="en-US" sz="1000" dirty="0">
                           <a:solidFill>
                             <a:srgbClr val="1A1A1A"/>
                           </a:solidFill>
@@ -8972,9 +8972,9 @@
                           <a:ea typeface="Arial" pitchFamily="34" charset="-122"/>
                           <a:cs typeface="Arial" pitchFamily="34" charset="-120"/>
                         </a:rPr>
-                        <a:t>Feb 5, 2027</a:t>
+                        <a:t>Dec 24, 2026</a:t>
                       </a:r>
-                      <a:endParaRPr lang="en-US" sz="1100" dirty="0">
+                      <a:endParaRPr lang="en-US" sz="1000" dirty="0">
                         <a:latin typeface="Arial" charset="0"/>
                         <a:ea typeface="Arial" charset="0"/>
                         <a:cs typeface="Arial" charset="0"/>
@@ -9014,7 +9014,7 @@
                         <a:buNone/>
                       </a:pPr>
                       <a:r>
-                        <a:rPr lang="en-US" sz="1100" dirty="0">
+                        <a:rPr lang="en-US" sz="1000" dirty="0">
                           <a:solidFill>
                             <a:srgbClr val="1A1A1A"/>
                           </a:solidFill>
@@ -9022,9 +9022,9 @@
                           <a:ea typeface="Arial" pitchFamily="34" charset="-122"/>
                           <a:cs typeface="Arial" pitchFamily="34" charset="-120"/>
                         </a:rPr>
-                        <a:t>Dec 7, 2026</a:t>
+                        <a:t>Nov 30, 2026</a:t>
                       </a:r>
-                      <a:endParaRPr lang="en-US" sz="1100" dirty="0">
+                      <a:endParaRPr lang="en-US" sz="1000" dirty="0">
                         <a:latin typeface="Arial" charset="0"/>
                         <a:ea typeface="Arial" charset="0"/>
                         <a:cs typeface="Arial" charset="0"/>
@@ -9064,7 +9064,7 @@
                         <a:buNone/>
                       </a:pPr>
                       <a:r>
-                        <a:rPr lang="en-US" sz="1100" dirty="0">
+                        <a:rPr lang="en-US" sz="1000" dirty="0">
                           <a:solidFill>
                             <a:srgbClr val="1A1A1A"/>
                           </a:solidFill>
@@ -9072,9 +9072,9 @@
                           <a:ea typeface="Arial" pitchFamily="34" charset="-122"/>
                           <a:cs typeface="Arial" pitchFamily="34" charset="-120"/>
                         </a:rPr>
-                        <a:t>Nov 19, 2026</a:t>
+                        <a:t>Nov 16, 2026</a:t>
                       </a:r>
-                      <a:endParaRPr lang="en-US" sz="1100" dirty="0">
+                      <a:endParaRPr lang="en-US" sz="1000" dirty="0">
                         <a:latin typeface="Arial" charset="0"/>
                         <a:ea typeface="Arial" charset="0"/>
                         <a:cs typeface="Arial" charset="0"/>
@@ -9106,7 +9106,7 @@
                   </a:tcPr>
                 </a:tc>
               </a:tr>
-              <a:tr h="270976">
+              <a:tr h="258064">
                 <a:tc>
                   <a:txBody>
                     <a:bodyPr/>
@@ -9116,7 +9116,7 @@
                         <a:buNone/>
                       </a:pPr>
                       <a:r>
-                        <a:rPr lang="en-US" sz="1100" dirty="0">
+                        <a:rPr lang="en-US" sz="1000" dirty="0">
                           <a:solidFill>
                             <a:srgbClr val="1A1A1A"/>
                           </a:solidFill>
@@ -9126,7 +9126,7 @@
                         </a:rPr>
                         <a:t>Listing Brokerage (2.5%)</a:t>
                       </a:r>
-                      <a:endParaRPr lang="en-US" sz="1100" dirty="0">
+                      <a:endParaRPr lang="en-US" sz="1000" dirty="0">
                         <a:latin typeface="Arial" charset="0"/>
                         <a:ea typeface="Arial" charset="0"/>
                         <a:cs typeface="Arial" charset="0"/>
@@ -9166,7 +9166,7 @@
                         <a:buNone/>
                       </a:pPr>
                       <a:r>
-                        <a:rPr lang="en-US" sz="1100" dirty="0">
+                        <a:rPr lang="en-US" sz="1000" dirty="0">
                           <a:solidFill>
                             <a:srgbClr val="1A1A1A"/>
                           </a:solidFill>
@@ -9174,9 +9174,9 @@
                           <a:ea typeface="Arial" pitchFamily="34" charset="-122"/>
                           <a:cs typeface="Arial" pitchFamily="34" charset="-120"/>
                         </a:rPr>
-                        <a:t>−$11,650</a:t>
+                        <a:t>−$11,675</a:t>
                       </a:r>
-                      <a:endParaRPr lang="en-US" sz="1100" dirty="0">
+                      <a:endParaRPr lang="en-US" sz="1000" dirty="0">
                         <a:latin typeface="Arial" charset="0"/>
                         <a:ea typeface="Arial" charset="0"/>
                         <a:cs typeface="Arial" charset="0"/>
@@ -9216,7 +9216,7 @@
                         <a:buNone/>
                       </a:pPr>
                       <a:r>
-                        <a:rPr lang="en-US" sz="1100" dirty="0">
+                        <a:rPr lang="en-US" sz="1000" dirty="0">
                           <a:solidFill>
                             <a:srgbClr val="1A1A1A"/>
                           </a:solidFill>
@@ -9224,9 +9224,9 @@
                           <a:ea typeface="Arial" pitchFamily="34" charset="-122"/>
                           <a:cs typeface="Arial" pitchFamily="34" charset="-120"/>
                         </a:rPr>
-                        <a:t>−$11,650</a:t>
+                        <a:t>−$11,675</a:t>
                       </a:r>
-                      <a:endParaRPr lang="en-US" sz="1100" dirty="0">
+                      <a:endParaRPr lang="en-US" sz="1000" dirty="0">
                         <a:latin typeface="Arial" charset="0"/>
                         <a:ea typeface="Arial" charset="0"/>
                         <a:cs typeface="Arial" charset="0"/>
@@ -9266,7 +9266,7 @@
                         <a:buNone/>
                       </a:pPr>
                       <a:r>
-                        <a:rPr lang="en-US" sz="1100" dirty="0">
+                        <a:rPr lang="en-US" sz="1000" dirty="0">
                           <a:solidFill>
                             <a:srgbClr val="1A1A1A"/>
                           </a:solidFill>
@@ -9274,9 +9274,9 @@
                           <a:ea typeface="Arial" pitchFamily="34" charset="-122"/>
                           <a:cs typeface="Arial" pitchFamily="34" charset="-120"/>
                         </a:rPr>
-                        <a:t>−$11,375</a:t>
+                        <a:t>−$11,425</a:t>
                       </a:r>
-                      <a:endParaRPr lang="en-US" sz="1100" dirty="0">
+                      <a:endParaRPr lang="en-US" sz="1000" dirty="0">
                         <a:latin typeface="Arial" charset="0"/>
                         <a:ea typeface="Arial" charset="0"/>
                         <a:cs typeface="Arial" charset="0"/>
@@ -9308,7 +9308,7 @@
                   </a:tcPr>
                 </a:tc>
               </a:tr>
-              <a:tr h="270976">
+              <a:tr h="258064">
                 <a:tc>
                   <a:txBody>
                     <a:bodyPr/>
@@ -9318,7 +9318,7 @@
                         <a:buNone/>
                       </a:pPr>
                       <a:r>
-                        <a:rPr lang="en-US" sz="1100" dirty="0">
+                        <a:rPr lang="en-US" sz="1000" dirty="0">
                           <a:solidFill>
                             <a:srgbClr val="1A1A1A"/>
                           </a:solidFill>
@@ -9328,7 +9328,7 @@
                         </a:rPr>
                         <a:t>Buyer's Agent Compensation (2.5%)</a:t>
                       </a:r>
-                      <a:endParaRPr lang="en-US" sz="1100" dirty="0">
+                      <a:endParaRPr lang="en-US" sz="1000" dirty="0">
                         <a:latin typeface="Arial" charset="0"/>
                         <a:ea typeface="Arial" charset="0"/>
                         <a:cs typeface="Arial" charset="0"/>
@@ -9368,7 +9368,7 @@
                         <a:buNone/>
                       </a:pPr>
                       <a:r>
-                        <a:rPr lang="en-US" sz="1100" dirty="0">
+                        <a:rPr lang="en-US" sz="1000" dirty="0">
                           <a:solidFill>
                             <a:srgbClr val="1A1A1A"/>
                           </a:solidFill>
@@ -9376,9 +9376,9 @@
                           <a:ea typeface="Arial" pitchFamily="34" charset="-122"/>
                           <a:cs typeface="Arial" pitchFamily="34" charset="-120"/>
                         </a:rPr>
-                        <a:t>−$11,650</a:t>
+                        <a:t>−$11,675</a:t>
                       </a:r>
-                      <a:endParaRPr lang="en-US" sz="1100" dirty="0">
+                      <a:endParaRPr lang="en-US" sz="1000" dirty="0">
                         <a:latin typeface="Arial" charset="0"/>
                         <a:ea typeface="Arial" charset="0"/>
                         <a:cs typeface="Arial" charset="0"/>
@@ -9418,7 +9418,7 @@
                         <a:buNone/>
                       </a:pPr>
                       <a:r>
-                        <a:rPr lang="en-US" sz="1100" dirty="0">
+                        <a:rPr lang="en-US" sz="1000" dirty="0">
                           <a:solidFill>
                             <a:srgbClr val="1A1A1A"/>
                           </a:solidFill>
@@ -9426,9 +9426,9 @@
                           <a:ea typeface="Arial" pitchFamily="34" charset="-122"/>
                           <a:cs typeface="Arial" pitchFamily="34" charset="-120"/>
                         </a:rPr>
-                        <a:t>−$11,650</a:t>
+                        <a:t>−$11,675</a:t>
                       </a:r>
-                      <a:endParaRPr lang="en-US" sz="1100" dirty="0">
+                      <a:endParaRPr lang="en-US" sz="1000" dirty="0">
                         <a:latin typeface="Arial" charset="0"/>
                         <a:ea typeface="Arial" charset="0"/>
                         <a:cs typeface="Arial" charset="0"/>
@@ -9468,7 +9468,7 @@
                         <a:buNone/>
                       </a:pPr>
                       <a:r>
-                        <a:rPr lang="en-US" sz="1100" dirty="0">
+                        <a:rPr lang="en-US" sz="1000" dirty="0">
                           <a:solidFill>
                             <a:srgbClr val="1A1A1A"/>
                           </a:solidFill>
@@ -9476,9 +9476,9 @@
                           <a:ea typeface="Arial" pitchFamily="34" charset="-122"/>
                           <a:cs typeface="Arial" pitchFamily="34" charset="-120"/>
                         </a:rPr>
-                        <a:t>−$11,375</a:t>
+                        <a:t>−$11,425</a:t>
                       </a:r>
-                      <a:endParaRPr lang="en-US" sz="1100" dirty="0">
+                      <a:endParaRPr lang="en-US" sz="1000" dirty="0">
                         <a:latin typeface="Arial" charset="0"/>
                         <a:ea typeface="Arial" charset="0"/>
                         <a:cs typeface="Arial" charset="0"/>
@@ -9510,7 +9510,7 @@
                   </a:tcPr>
                 </a:tc>
               </a:tr>
-              <a:tr h="270976">
+              <a:tr h="258064">
                 <a:tc>
                   <a:txBody>
                     <a:bodyPr/>
@@ -9520,7 +9520,7 @@
                         <a:buNone/>
                       </a:pPr>
                       <a:r>
-                        <a:rPr lang="en-US" sz="1100" dirty="0">
+                        <a:rPr lang="en-US" sz="1000" dirty="0">
                           <a:solidFill>
                             <a:srgbClr val="1A1A1A"/>
                           </a:solidFill>
@@ -9530,7 +9530,7 @@
                         </a:rPr>
                         <a:t>Documentary Stamp Tax on the Deed (0.70%)</a:t>
                       </a:r>
-                      <a:endParaRPr lang="en-US" sz="1100" dirty="0">
+                      <a:endParaRPr lang="en-US" sz="1000" dirty="0">
                         <a:latin typeface="Arial" charset="0"/>
                         <a:ea typeface="Arial" charset="0"/>
                         <a:cs typeface="Arial" charset="0"/>
@@ -9570,7 +9570,7 @@
                         <a:buNone/>
                       </a:pPr>
                       <a:r>
-                        <a:rPr lang="en-US" sz="1100" dirty="0">
+                        <a:rPr lang="en-US" sz="1000" dirty="0">
                           <a:solidFill>
                             <a:srgbClr val="1A1A1A"/>
                           </a:solidFill>
@@ -9578,9 +9578,9 @@
                           <a:ea typeface="Arial" pitchFamily="34" charset="-122"/>
                           <a:cs typeface="Arial" pitchFamily="34" charset="-120"/>
                         </a:rPr>
-                        <a:t>−$3,262</a:t>
+                        <a:t>−$3,269</a:t>
                       </a:r>
-                      <a:endParaRPr lang="en-US" sz="1100" dirty="0">
+                      <a:endParaRPr lang="en-US" sz="1000" dirty="0">
                         <a:latin typeface="Arial" charset="0"/>
                         <a:ea typeface="Arial" charset="0"/>
                         <a:cs typeface="Arial" charset="0"/>
@@ -9620,7 +9620,7 @@
                         <a:buNone/>
                       </a:pPr>
                       <a:r>
-                        <a:rPr lang="en-US" sz="1100" dirty="0">
+                        <a:rPr lang="en-US" sz="1000" dirty="0">
                           <a:solidFill>
                             <a:srgbClr val="1A1A1A"/>
                           </a:solidFill>
@@ -9628,9 +9628,9 @@
                           <a:ea typeface="Arial" pitchFamily="34" charset="-122"/>
                           <a:cs typeface="Arial" pitchFamily="34" charset="-120"/>
                         </a:rPr>
-                        <a:t>−$3,262</a:t>
+                        <a:t>−$3,269</a:t>
                       </a:r>
-                      <a:endParaRPr lang="en-US" sz="1100" dirty="0">
+                      <a:endParaRPr lang="en-US" sz="1000" dirty="0">
                         <a:latin typeface="Arial" charset="0"/>
                         <a:ea typeface="Arial" charset="0"/>
                         <a:cs typeface="Arial" charset="0"/>
@@ -9670,7 +9670,7 @@
                         <a:buNone/>
                       </a:pPr>
                       <a:r>
-                        <a:rPr lang="en-US" sz="1100" dirty="0">
+                        <a:rPr lang="en-US" sz="1000" dirty="0">
                           <a:solidFill>
                             <a:srgbClr val="1A1A1A"/>
                           </a:solidFill>
@@ -9678,9 +9678,9 @@
                           <a:ea typeface="Arial" pitchFamily="34" charset="-122"/>
                           <a:cs typeface="Arial" pitchFamily="34" charset="-120"/>
                         </a:rPr>
-                        <a:t>−$3,185</a:t>
+                        <a:t>−$3,199</a:t>
                       </a:r>
-                      <a:endParaRPr lang="en-US" sz="1100" dirty="0">
+                      <a:endParaRPr lang="en-US" sz="1000" dirty="0">
                         <a:latin typeface="Arial" charset="0"/>
                         <a:ea typeface="Arial" charset="0"/>
                         <a:cs typeface="Arial" charset="0"/>
@@ -9712,7 +9712,7 @@
                   </a:tcPr>
                 </a:tc>
               </a:tr>
-              <a:tr h="270976">
+              <a:tr h="258064">
                 <a:tc>
                   <a:txBody>
                     <a:bodyPr/>
@@ -9722,7 +9722,7 @@
                         <a:buNone/>
                       </a:pPr>
                       <a:r>
-                        <a:rPr lang="en-US" sz="1100" dirty="0">
+                        <a:rPr lang="en-US" sz="1000" dirty="0">
                           <a:solidFill>
                             <a:srgbClr val="1A1A1A"/>
                           </a:solidFill>
@@ -9732,7 +9732,7 @@
                         </a:rPr>
                         <a:t>Owner's Title Insurance</a:t>
                       </a:r>
-                      <a:endParaRPr lang="en-US" sz="1100" dirty="0">
+                      <a:endParaRPr lang="en-US" sz="1000" dirty="0">
                         <a:latin typeface="Arial" charset="0"/>
                         <a:ea typeface="Arial" charset="0"/>
                         <a:cs typeface="Arial" charset="0"/>
@@ -9772,7 +9772,7 @@
                         <a:buNone/>
                       </a:pPr>
                       <a:r>
-                        <a:rPr lang="en-US" sz="1100" dirty="0">
+                        <a:rPr lang="en-US" sz="1000" dirty="0">
                           <a:solidFill>
                             <a:srgbClr val="1A1A1A"/>
                           </a:solidFill>
@@ -9780,9 +9780,9 @@
                           <a:ea typeface="Arial" pitchFamily="34" charset="-122"/>
                           <a:cs typeface="Arial" pitchFamily="34" charset="-120"/>
                         </a:rPr>
-                        <a:t>−$2,405</a:t>
+                        <a:t>−$2,410</a:t>
                       </a:r>
-                      <a:endParaRPr lang="en-US" sz="1100" dirty="0">
+                      <a:endParaRPr lang="en-US" sz="1000" dirty="0">
                         <a:latin typeface="Arial" charset="0"/>
                         <a:ea typeface="Arial" charset="0"/>
                         <a:cs typeface="Arial" charset="0"/>
@@ -9822,7 +9822,7 @@
                         <a:buNone/>
                       </a:pPr>
                       <a:r>
-                        <a:rPr lang="en-US" sz="1100" dirty="0">
+                        <a:rPr lang="en-US" sz="1000" dirty="0">
                           <a:solidFill>
                             <a:srgbClr val="1A1A1A"/>
                           </a:solidFill>
@@ -9830,9 +9830,9 @@
                           <a:ea typeface="Arial" pitchFamily="34" charset="-122"/>
                           <a:cs typeface="Arial" pitchFamily="34" charset="-120"/>
                         </a:rPr>
-                        <a:t>−$2,405</a:t>
+                        <a:t>−$2,410</a:t>
                       </a:r>
-                      <a:endParaRPr lang="en-US" sz="1100" dirty="0">
+                      <a:endParaRPr lang="en-US" sz="1000" dirty="0">
                         <a:latin typeface="Arial" charset="0"/>
                         <a:ea typeface="Arial" charset="0"/>
                         <a:cs typeface="Arial" charset="0"/>
@@ -9872,7 +9872,7 @@
                         <a:buNone/>
                       </a:pPr>
                       <a:r>
-                        <a:rPr lang="en-US" sz="1100" dirty="0">
+                        <a:rPr lang="en-US" sz="1000" dirty="0">
                           <a:solidFill>
                             <a:srgbClr val="1A1A1A"/>
                           </a:solidFill>
@@ -9880,9 +9880,9 @@
                           <a:ea typeface="Arial" pitchFamily="34" charset="-122"/>
                           <a:cs typeface="Arial" pitchFamily="34" charset="-120"/>
                         </a:rPr>
-                        <a:t>−$2,350</a:t>
+                        <a:t>−$2,360</a:t>
                       </a:r>
-                      <a:endParaRPr lang="en-US" sz="1100" dirty="0">
+                      <a:endParaRPr lang="en-US" sz="1000" dirty="0">
                         <a:latin typeface="Arial" charset="0"/>
                         <a:ea typeface="Arial" charset="0"/>
                         <a:cs typeface="Arial" charset="0"/>
@@ -9914,7 +9914,7 @@
                   </a:tcPr>
                 </a:tc>
               </a:tr>
-              <a:tr h="270976">
+              <a:tr h="258064">
                 <a:tc>
                   <a:txBody>
                     <a:bodyPr/>
@@ -9924,7 +9924,7 @@
                         <a:buNone/>
                       </a:pPr>
                       <a:r>
-                        <a:rPr lang="en-US" sz="1100" dirty="0">
+                        <a:rPr lang="en-US" sz="1000" dirty="0">
                           <a:solidFill>
                             <a:srgbClr val="1A1A1A"/>
                           </a:solidFill>
@@ -9934,7 +9934,7 @@
                         </a:rPr>
                         <a:t>Title Company Fees</a:t>
                       </a:r>
-                      <a:endParaRPr lang="en-US" sz="1100" dirty="0">
+                      <a:endParaRPr lang="en-US" sz="1000" dirty="0">
                         <a:latin typeface="Arial" charset="0"/>
                         <a:ea typeface="Arial" charset="0"/>
                         <a:cs typeface="Arial" charset="0"/>
@@ -9974,7 +9974,7 @@
                         <a:buNone/>
                       </a:pPr>
                       <a:r>
-                        <a:rPr lang="en-US" sz="1100" dirty="0">
+                        <a:rPr lang="en-US" sz="1000" dirty="0">
                           <a:solidFill>
                             <a:srgbClr val="1A1A1A"/>
                           </a:solidFill>
@@ -9984,7 +9984,7 @@
                         </a:rPr>
                         <a:t>−$1,145</a:t>
                       </a:r>
-                      <a:endParaRPr lang="en-US" sz="1100" dirty="0">
+                      <a:endParaRPr lang="en-US" sz="1000" dirty="0">
                         <a:latin typeface="Arial" charset="0"/>
                         <a:ea typeface="Arial" charset="0"/>
                         <a:cs typeface="Arial" charset="0"/>
@@ -10024,7 +10024,7 @@
                         <a:buNone/>
                       </a:pPr>
                       <a:r>
-                        <a:rPr lang="en-US" sz="1100" dirty="0">
+                        <a:rPr lang="en-US" sz="1000" dirty="0">
                           <a:solidFill>
                             <a:srgbClr val="1A1A1A"/>
                           </a:solidFill>
@@ -10034,7 +10034,7 @@
                         </a:rPr>
                         <a:t>−$1,145</a:t>
                       </a:r>
-                      <a:endParaRPr lang="en-US" sz="1100" dirty="0">
+                      <a:endParaRPr lang="en-US" sz="1000" dirty="0">
                         <a:latin typeface="Arial" charset="0"/>
                         <a:ea typeface="Arial" charset="0"/>
                         <a:cs typeface="Arial" charset="0"/>
@@ -10074,7 +10074,7 @@
                         <a:buNone/>
                       </a:pPr>
                       <a:r>
-                        <a:rPr lang="en-US" sz="1100" dirty="0">
+                        <a:rPr lang="en-US" sz="1000" dirty="0">
                           <a:solidFill>
                             <a:srgbClr val="1A1A1A"/>
                           </a:solidFill>
@@ -10084,7 +10084,7 @@
                         </a:rPr>
                         <a:t>−$1,145</a:t>
                       </a:r>
-                      <a:endParaRPr lang="en-US" sz="1100" dirty="0">
+                      <a:endParaRPr lang="en-US" sz="1000" dirty="0">
                         <a:latin typeface="Arial" charset="0"/>
                         <a:ea typeface="Arial" charset="0"/>
                         <a:cs typeface="Arial" charset="0"/>
@@ -10116,7 +10116,7 @@
                   </a:tcPr>
                 </a:tc>
               </a:tr>
-              <a:tr h="270976">
+              <a:tr h="258064">
                 <a:tc>
                   <a:txBody>
                     <a:bodyPr/>
@@ -10126,7 +10126,7 @@
                         <a:buNone/>
                       </a:pPr>
                       <a:r>
-                        <a:rPr lang="en-US" sz="1100" dirty="0">
+                        <a:rPr lang="en-US" sz="1000" dirty="0">
                           <a:solidFill>
                             <a:srgbClr val="1A1A1A"/>
                           </a:solidFill>
@@ -10136,7 +10136,7 @@
                         </a:rPr>
                         <a:t>Seller-Paid Buyer Costs</a:t>
                       </a:r>
-                      <a:endParaRPr lang="en-US" sz="1100" dirty="0">
+                      <a:endParaRPr lang="en-US" sz="1000" dirty="0">
                         <a:latin typeface="Arial" charset="0"/>
                         <a:ea typeface="Arial" charset="0"/>
                         <a:cs typeface="Arial" charset="0"/>
@@ -10176,7 +10176,7 @@
                         <a:buNone/>
                       </a:pPr>
                       <a:r>
-                        <a:rPr lang="en-US" sz="1100" dirty="0">
+                        <a:rPr lang="en-US" sz="1000" dirty="0">
                           <a:solidFill>
                             <a:srgbClr val="1A1A1A"/>
                           </a:solidFill>
@@ -10184,9 +10184,9 @@
                           <a:ea typeface="Arial" pitchFamily="34" charset="-122"/>
                           <a:cs typeface="Arial" pitchFamily="34" charset="-120"/>
                         </a:rPr>
-                        <a:t>−$10,000</a:t>
+                        <a:t>−$11,000</a:t>
                       </a:r>
-                      <a:endParaRPr lang="en-US" sz="1100" dirty="0">
+                      <a:endParaRPr lang="en-US" sz="1000" dirty="0">
                         <a:latin typeface="Arial" charset="0"/>
                         <a:ea typeface="Arial" charset="0"/>
                         <a:cs typeface="Arial" charset="0"/>
@@ -10226,7 +10226,7 @@
                         <a:buNone/>
                       </a:pPr>
                       <a:r>
-                        <a:rPr lang="en-US" sz="1100" dirty="0">
+                        <a:rPr lang="en-US" sz="1000" dirty="0">
                           <a:solidFill>
                             <a:srgbClr val="1A1A1A"/>
                           </a:solidFill>
@@ -10234,9 +10234,9 @@
                           <a:ea typeface="Arial" pitchFamily="34" charset="-122"/>
                           <a:cs typeface="Arial" pitchFamily="34" charset="-120"/>
                         </a:rPr>
-                        <a:t>−$10,000</a:t>
+                        <a:t>−$11,000</a:t>
                       </a:r>
-                      <a:endParaRPr lang="en-US" sz="1100" dirty="0">
+                      <a:endParaRPr lang="en-US" sz="1000" dirty="0">
                         <a:latin typeface="Arial" charset="0"/>
                         <a:ea typeface="Arial" charset="0"/>
                         <a:cs typeface="Arial" charset="0"/>
@@ -10276,7 +10276,7 @@
                         <a:buNone/>
                       </a:pPr>
                       <a:r>
-                        <a:rPr lang="en-US" sz="1100" dirty="0">
+                        <a:rPr lang="en-US" sz="1000" dirty="0">
                           <a:solidFill>
                             <a:srgbClr val="1A1A1A"/>
                           </a:solidFill>
@@ -10284,9 +10284,9 @@
                           <a:ea typeface="Arial" pitchFamily="34" charset="-122"/>
                           <a:cs typeface="Arial" pitchFamily="34" charset="-120"/>
                         </a:rPr>
-                        <a:t>−$5,000</a:t>
+                        <a:t>−$11,000</a:t>
                       </a:r>
-                      <a:endParaRPr lang="en-US" sz="1100" dirty="0">
+                      <a:endParaRPr lang="en-US" sz="1000" dirty="0">
                         <a:latin typeface="Arial" charset="0"/>
                         <a:ea typeface="Arial" charset="0"/>
                         <a:cs typeface="Arial" charset="0"/>
@@ -10318,7 +10318,7 @@
                   </a:tcPr>
                 </a:tc>
               </a:tr>
-              <a:tr h="270976">
+              <a:tr h="258064">
                 <a:tc>
                   <a:txBody>
                     <a:bodyPr/>
@@ -10328,7 +10328,7 @@
                         <a:buNone/>
                       </a:pPr>
                       <a:r>
-                        <a:rPr lang="en-US" sz="1100" b="1" dirty="0">
+                        <a:rPr lang="en-US" sz="1000" b="1" dirty="0">
                           <a:solidFill>
                             <a:srgbClr val="1A1A1A"/>
                           </a:solidFill>
@@ -10338,7 +10338,7 @@
                         </a:rPr>
                         <a:t>Estimated Net Before Mortgage Payoff</a:t>
                       </a:r>
-                      <a:endParaRPr lang="en-US" sz="1100" dirty="0">
+                      <a:endParaRPr lang="en-US" sz="1000" dirty="0">
                         <a:latin typeface="Arial" charset="0"/>
                         <a:ea typeface="Arial" charset="0"/>
                         <a:cs typeface="Arial" charset="0"/>
@@ -10384,7 +10384,7 @@
                         <a:buNone/>
                       </a:pPr>
                       <a:r>
-                        <a:rPr lang="en-US" sz="1100" b="1" dirty="0">
+                        <a:rPr lang="en-US" sz="1000" b="1" dirty="0">
                           <a:solidFill>
                             <a:srgbClr val="1A1A1A"/>
                           </a:solidFill>
@@ -10392,9 +10392,9 @@
                           <a:ea typeface="Arial" pitchFamily="34" charset="-122"/>
                           <a:cs typeface="Arial" pitchFamily="34" charset="-120"/>
                         </a:rPr>
-                        <a:t>$425,888</a:t>
+                        <a:t>$425,826</a:t>
                       </a:r>
-                      <a:endParaRPr lang="en-US" sz="1100" dirty="0">
+                      <a:endParaRPr lang="en-US" sz="1000" dirty="0">
                         <a:latin typeface="Arial" charset="0"/>
                         <a:ea typeface="Arial" charset="0"/>
                         <a:cs typeface="Arial" charset="0"/>
@@ -10440,7 +10440,7 @@
                         <a:buNone/>
                       </a:pPr>
                       <a:r>
-                        <a:rPr lang="en-US" sz="1100" b="1" dirty="0">
+                        <a:rPr lang="en-US" sz="1000" b="1" dirty="0">
                           <a:solidFill>
                             <a:srgbClr val="1A1A1A"/>
                           </a:solidFill>
@@ -10448,9 +10448,9 @@
                           <a:ea typeface="Arial" pitchFamily="34" charset="-122"/>
                           <a:cs typeface="Arial" pitchFamily="34" charset="-120"/>
                         </a:rPr>
-                        <a:t>$425,888</a:t>
+                        <a:t>$425,826</a:t>
                       </a:r>
-                      <a:endParaRPr lang="en-US" sz="1100" dirty="0">
+                      <a:endParaRPr lang="en-US" sz="1000" dirty="0">
                         <a:latin typeface="Arial" charset="0"/>
                         <a:ea typeface="Arial" charset="0"/>
                         <a:cs typeface="Arial" charset="0"/>
@@ -10496,7 +10496,7 @@
                         <a:buNone/>
                       </a:pPr>
                       <a:r>
-                        <a:rPr lang="en-US" sz="1100" b="1" dirty="0">
+                        <a:rPr lang="en-US" sz="1000" b="1" dirty="0">
                           <a:solidFill>
                             <a:srgbClr val="1A1A1A"/>
                           </a:solidFill>
@@ -10504,9 +10504,9 @@
                           <a:ea typeface="Arial" pitchFamily="34" charset="-122"/>
                           <a:cs typeface="Arial" pitchFamily="34" charset="-120"/>
                         </a:rPr>
-                        <a:t>$420,570</a:t>
+                        <a:t>$416,446</a:t>
                       </a:r>
-                      <a:endParaRPr lang="en-US" sz="1100" dirty="0">
+                      <a:endParaRPr lang="en-US" sz="1000" dirty="0">
                         <a:latin typeface="Arial" charset="0"/>
                         <a:ea typeface="Arial" charset="0"/>
                         <a:cs typeface="Arial" charset="0"/>
@@ -10544,7 +10544,7 @@
                   </a:tcPr>
                 </a:tc>
               </a:tr>
-              <a:tr h="270976">
+              <a:tr h="258064">
                 <a:tc>
                   <a:txBody>
                     <a:bodyPr/>
@@ -10554,7 +10554,7 @@
                         <a:buNone/>
                       </a:pPr>
                       <a:r>
-                        <a:rPr lang="en-US" sz="1100" dirty="0">
+                        <a:rPr lang="en-US" sz="1000" dirty="0">
                           <a:solidFill>
                             <a:srgbClr val="1A1A1A"/>
                           </a:solidFill>
@@ -10564,7 +10564,7 @@
                         </a:rPr>
                         <a:t>Holding Costs Until Closing</a:t>
                       </a:r>
-                      <a:endParaRPr lang="en-US" sz="1100" dirty="0">
+                      <a:endParaRPr lang="en-US" sz="1000" dirty="0">
                         <a:latin typeface="Arial" charset="0"/>
                         <a:ea typeface="Arial" charset="0"/>
                         <a:cs typeface="Arial" charset="0"/>
@@ -10604,7 +10604,7 @@
                         <a:buNone/>
                       </a:pPr>
                       <a:r>
-                        <a:rPr lang="en-US" sz="1100" dirty="0">
+                        <a:rPr lang="en-US" sz="1000" dirty="0">
                           <a:solidFill>
                             <a:srgbClr val="1A1A1A"/>
                           </a:solidFill>
@@ -10612,9 +10612,9 @@
                           <a:ea typeface="Arial" pitchFamily="34" charset="-122"/>
                           <a:cs typeface="Arial" pitchFamily="34" charset="-120"/>
                         </a:rPr>
-                        <a:t>−$2,369</a:t>
+                        <a:t>−$1,604</a:t>
                       </a:r>
-                      <a:endParaRPr lang="en-US" sz="1100" dirty="0">
+                      <a:endParaRPr lang="en-US" sz="1000" dirty="0">
                         <a:latin typeface="Arial" charset="0"/>
                         <a:ea typeface="Arial" charset="0"/>
                         <a:cs typeface="Arial" charset="0"/>
@@ -10654,7 +10654,7 @@
                         <a:buNone/>
                       </a:pPr>
                       <a:r>
-                        <a:rPr lang="en-US" sz="1100" dirty="0">
+                        <a:rPr lang="en-US" sz="1000" dirty="0">
                           <a:solidFill>
                             <a:srgbClr val="1A1A1A"/>
                           </a:solidFill>
@@ -10662,9 +10662,9 @@
                           <a:ea typeface="Arial" pitchFamily="34" charset="-122"/>
                           <a:cs typeface="Arial" pitchFamily="34" charset="-120"/>
                         </a:rPr>
-                        <a:t>−$1,325</a:t>
+                        <a:t>−$1,190</a:t>
                       </a:r>
-                      <a:endParaRPr lang="en-US" sz="1100" dirty="0">
+                      <a:endParaRPr lang="en-US" sz="1000" dirty="0">
                         <a:latin typeface="Arial" charset="0"/>
                         <a:ea typeface="Arial" charset="0"/>
                         <a:cs typeface="Arial" charset="0"/>
@@ -10704,7 +10704,7 @@
                         <a:buNone/>
                       </a:pPr>
                       <a:r>
-                        <a:rPr lang="en-US" sz="1100" dirty="0">
+                        <a:rPr lang="en-US" sz="1000" dirty="0">
                           <a:solidFill>
                             <a:srgbClr val="1A1A1A"/>
                           </a:solidFill>
@@ -10712,9 +10712,9 @@
                           <a:ea typeface="Arial" pitchFamily="34" charset="-122"/>
                           <a:cs typeface="Arial" pitchFamily="34" charset="-120"/>
                         </a:rPr>
-                        <a:t>−$1,012</a:t>
+                        <a:t>−$949</a:t>
                       </a:r>
-                      <a:endParaRPr lang="en-US" sz="1100" dirty="0">
+                      <a:endParaRPr lang="en-US" sz="1000" dirty="0">
                         <a:latin typeface="Arial" charset="0"/>
                         <a:ea typeface="Arial" charset="0"/>
                         <a:cs typeface="Arial" charset="0"/>
@@ -10746,7 +10746,7 @@
                   </a:tcPr>
                 </a:tc>
               </a:tr>
-              <a:tr h="270976">
+              <a:tr h="258064">
                 <a:tc>
                   <a:txBody>
                     <a:bodyPr/>
@@ -10756,7 +10756,7 @@
                         <a:buNone/>
                       </a:pPr>
                       <a:r>
-                        <a:rPr lang="en-US" sz="1100" b="1" dirty="0">
+                        <a:rPr lang="en-US" sz="1000" b="1" dirty="0">
                           <a:solidFill>
                             <a:srgbClr val="1A1A1A"/>
                           </a:solidFill>
@@ -10766,7 +10766,7 @@
                         </a:rPr>
                         <a:t>Net After Holding Costs</a:t>
                       </a:r>
-                      <a:endParaRPr lang="en-US" sz="1100" dirty="0">
+                      <a:endParaRPr lang="en-US" sz="1000" dirty="0">
                         <a:latin typeface="Arial" charset="0"/>
                         <a:ea typeface="Arial" charset="0"/>
                         <a:cs typeface="Arial" charset="0"/>
@@ -10812,7 +10812,7 @@
                         <a:buNone/>
                       </a:pPr>
                       <a:r>
-                        <a:rPr lang="en-US" sz="1100" b="1" dirty="0">
+                        <a:rPr lang="en-US" sz="1000" b="1" dirty="0">
                           <a:solidFill>
                             <a:srgbClr val="1A1A1A"/>
                           </a:solidFill>
@@ -10820,9 +10820,9 @@
                           <a:ea typeface="Arial" pitchFamily="34" charset="-122"/>
                           <a:cs typeface="Arial" pitchFamily="34" charset="-120"/>
                         </a:rPr>
-                        <a:t>$423,519</a:t>
+                        <a:t>$424,222</a:t>
                       </a:r>
-                      <a:endParaRPr lang="en-US" sz="1100" dirty="0">
+                      <a:endParaRPr lang="en-US" sz="1000" dirty="0">
                         <a:latin typeface="Arial" charset="0"/>
                         <a:ea typeface="Arial" charset="0"/>
                         <a:cs typeface="Arial" charset="0"/>
@@ -10868,7 +10868,7 @@
                         <a:buNone/>
                       </a:pPr>
                       <a:r>
-                        <a:rPr lang="en-US" sz="1100" b="1" dirty="0">
+                        <a:rPr lang="en-US" sz="1000" b="1" dirty="0">
                           <a:solidFill>
                             <a:srgbClr val="1A1A1A"/>
                           </a:solidFill>
@@ -10876,9 +10876,9 @@
                           <a:ea typeface="Arial" pitchFamily="34" charset="-122"/>
                           <a:cs typeface="Arial" pitchFamily="34" charset="-120"/>
                         </a:rPr>
-                        <a:t>$424,563</a:t>
+                        <a:t>$424,636</a:t>
                       </a:r>
-                      <a:endParaRPr lang="en-US" sz="1100" dirty="0">
+                      <a:endParaRPr lang="en-US" sz="1000" dirty="0">
                         <a:latin typeface="Arial" charset="0"/>
                         <a:ea typeface="Arial" charset="0"/>
                         <a:cs typeface="Arial" charset="0"/>
@@ -10924,7 +10924,7 @@
                         <a:buNone/>
                       </a:pPr>
                       <a:r>
-                        <a:rPr lang="en-US" sz="1100" b="1" dirty="0">
+                        <a:rPr lang="en-US" sz="1000" b="1" dirty="0">
                           <a:solidFill>
                             <a:srgbClr val="1A1A1A"/>
                           </a:solidFill>
@@ -10932,9 +10932,9 @@
                           <a:ea typeface="Arial" pitchFamily="34" charset="-122"/>
                           <a:cs typeface="Arial" pitchFamily="34" charset="-120"/>
                         </a:rPr>
-                        <a:t>$419,558</a:t>
+                        <a:t>$415,497</a:t>
                       </a:r>
-                      <a:endParaRPr lang="en-US" sz="1100" dirty="0">
+                      <a:endParaRPr lang="en-US" sz="1000" dirty="0">
                         <a:latin typeface="Arial" charset="0"/>
                         <a:ea typeface="Arial" charset="0"/>
                         <a:cs typeface="Arial" charset="0"/>
@@ -10984,8 +10984,8 @@
         </p:nvSpPr>
         <p:spPr>
           <a:xfrm>
-            <a:off x="457200" y="4394708"/>
-            <a:ext cx="8229600" cy="309880"/>
+            <a:off x="457200" y="4346448"/>
+            <a:ext cx="8229600" cy="358140"/>
           </a:xfrm>
           <a:prstGeom prst="rect">
             <a:avLst/>
@@ -13182,7 +13182,7 @@
                 <a:ea typeface="Arial" pitchFamily="34" charset="-122"/>
                 <a:cs typeface="Arial" pitchFamily="34" charset="-120"/>
               </a:rPr>
-              <a:t>About $466,000</a:t>
+              <a:t>About $467,000</a:t>
             </a:r>
             <a:endParaRPr lang="en-US" sz="2400" dirty="0"/>
           </a:p>
@@ -14222,7 +14222,7 @@
                 <a:ea typeface="Arial" pitchFamily="34" charset="-122"/>
                 <a:cs typeface="Arial" pitchFamily="34" charset="-120"/>
               </a:rPr>
-              <a:t>Adjusted for size ($1,200 to $1,800), lot ($5,000), market changes since each sale (1% a quarter off sales before July), roof and systems ($5,000), condition and updates ($30,000 to $45,000), view or water ($10,000) and seller credits (taken off each sale price).</a:t>
+              <a:t>Adjusted for size ($1,200 to $1,800), lot ($5,000), market changes since each sale (1% a quarter off sales before July), roof and systems ($5,000), condition and updates ($30,000 to $45,000, against this home's full renovation), view or water ($10,000) and seller credits (taken off each sale price).</a:t>
             </a:r>
             <a:endParaRPr lang="en-US" sz="1100" dirty="0"/>
           </a:p>
@@ -15924,7 +15924,7 @@
                 <a:ea typeface="Arial" pitchFamily="34" charset="-122"/>
                 <a:cs typeface="Arial" pitchFamily="34" charset="-120"/>
               </a:rPr>
-              <a:t>Renovated pool home; sold in the spring</a:t>
+              <a:t>Renovated pool home; sold earlier in the year</a:t>
             </a:r>
             <a:endParaRPr lang="en-US" sz="950" dirty="0"/>
           </a:p>
@@ -16609,7 +16609,7 @@
                 <a:ea typeface="Arial" pitchFamily="34" charset="-122"/>
                 <a:cs typeface="Arial" pitchFamily="34" charset="-120"/>
               </a:rPr>
-              <a:t>The two highest sold in the spring. The recent sales point to the middle of the range.</a:t>
+              <a:t>The two highest sold earlier in the year. The recent sales point to the middle of the range.</a:t>
             </a:r>
             <a:endParaRPr lang="en-US" sz="1200" dirty="0"/>
           </a:p>
@@ -17761,7 +17761,7 @@
                 <a:ea typeface="Arial" pitchFamily="34" charset="-122"/>
                 <a:cs typeface="Arial" pitchFamily="34" charset="-120"/>
               </a:rPr>
-              <a:t>The Market Shifted Since Spring</a:t>
+              <a:t>The Market Has Shifted</a:t>
             </a:r>
             <a:endParaRPr lang="en-US" sz="2600" dirty="0"/>
           </a:p>
@@ -18923,7 +18923,7 @@
                 <a:ea typeface="Arial" pitchFamily="34" charset="-122"/>
                 <a:cs typeface="Arial" pitchFamily="34" charset="-120"/>
               </a:rPr>
-              <a:t>Buyers are negotiating again. Price for the market we have now, not the one from the spring.</a:t>
+              <a:t>Buyers are negotiating again. Price for the market we have now, not the one from earlier in the year.</a:t>
             </a:r>
             <a:endParaRPr lang="en-US" sz="1400" dirty="0"/>
           </a:p>
@@ -19889,6 +19889,45 @@
         </p:nvSpPr>
         <p:spPr>
           <a:xfrm>
+            <a:off x="658368" y="1188720"/>
+            <a:ext cx="2157984" cy="228600"/>
+          </a:xfrm>
+          <a:prstGeom prst="rect">
+            <a:avLst/>
+          </a:prstGeom>
+          <a:noFill/>
+          <a:ln/>
+        </p:spPr>
+        <p:txBody>
+          <a:bodyPr wrap="square" lIns="0" tIns="0" rIns="0" bIns="0" rtlCol="0" anchor="ctr"/>
+          <a:lstStyle/>
+          <a:p>
+            <a:pPr indent="0" marL="0">
+              <a:buNone/>
+            </a:pPr>
+            <a:r>
+              <a:rPr lang="en-US" sz="1000" b="1" dirty="0">
+                <a:solidFill>
+                  <a:srgbClr val="C2410C"/>
+                </a:solidFill>
+                <a:latin typeface="Arial" pitchFamily="34" charset="0"/>
+                <a:ea typeface="Arial" pitchFamily="34" charset="-122"/>
+                <a:cs typeface="Arial" pitchFamily="34" charset="-120"/>
+              </a:rPr>
+              <a:t>PREMIUM</a:t>
+            </a:r>
+            <a:endParaRPr lang="en-US" sz="1000" dirty="0"/>
+          </a:p>
+        </p:txBody>
+      </p:sp>
+      <p:sp>
+        <p:nvSpPr>
+          <p:cNvPr id="5" name="Text 3"/>
+          <p:cNvSpPr txBox="1"/>
+          <p:nvPr/>
+        </p:nvSpPr>
+        <p:spPr>
+          <a:xfrm>
             <a:off x="658368" y="1435608"/>
             <a:ext cx="2157984" cy="548640"/>
           </a:xfrm>
@@ -19914,7 +19953,7 @@
                 <a:ea typeface="Arial" pitchFamily="34" charset="-122"/>
                 <a:cs typeface="Arial" pitchFamily="34" charset="-120"/>
               </a:rPr>
-              <a:t>$479,900</a:t>
+              <a:t>$474,900</a:t>
             </a:r>
             <a:endParaRPr lang="en-US" sz="3000" dirty="0"/>
           </a:p>
@@ -19922,14 +19961,14 @@
       </p:sp>
       <p:sp>
         <p:nvSpPr>
-          <p:cNvPr id="5" name="Text 3"/>
+          <p:cNvPr id="6" name="Text 4"/>
           <p:cNvSpPr txBox="1"/>
           <p:nvPr/>
         </p:nvSpPr>
         <p:spPr>
           <a:xfrm>
             <a:off x="658368" y="2075688"/>
-            <a:ext cx="1075809" cy="347472"/>
+            <a:ext cx="1180377" cy="347472"/>
           </a:xfrm>
           <a:prstGeom prst="rect">
             <a:avLst/>
@@ -19961,14 +20000,14 @@
       </p:sp>
       <p:sp>
         <p:nvSpPr>
-          <p:cNvPr id="6" name="Text 4"/>
-          <p:cNvSpPr txBox="1"/>
-          <p:nvPr/>
-        </p:nvSpPr>
-        <p:spPr>
-          <a:xfrm>
-            <a:off x="1825617" y="2075688"/>
-            <a:ext cx="990735" cy="347472"/>
+          <p:cNvPr id="7" name="Text 5"/>
+          <p:cNvSpPr txBox="1"/>
+          <p:nvPr/>
+        </p:nvSpPr>
+        <p:spPr>
+          <a:xfrm>
+            <a:off x="1930185" y="2075688"/>
+            <a:ext cx="886167" cy="347472"/>
           </a:xfrm>
           <a:prstGeom prst="rect">
             <a:avLst/>
@@ -19992,7 +20031,7 @@
                 <a:ea typeface="Arial" pitchFamily="34" charset="-122"/>
                 <a:cs typeface="Arial" pitchFamily="34" charset="-120"/>
               </a:rPr>
-              <a:t>2–4 months</a:t>
+              <a:t>5–9 weeks</a:t>
             </a:r>
             <a:endParaRPr lang="en-US" sz="1300" dirty="0"/>
           </a:p>
@@ -20000,7 +20039,7 @@
       </p:sp>
       <p:sp>
         <p:nvSpPr>
-          <p:cNvPr id="7" name="Text 5"/>
+          <p:cNvPr id="8" name="Text 6"/>
           <p:cNvSpPr txBox="1"/>
           <p:nvPr/>
         </p:nvSpPr>
@@ -20039,7 +20078,7 @@
       </p:sp>
       <p:sp>
         <p:nvSpPr>
-          <p:cNvPr id="8" name="Text 6"/>
+          <p:cNvPr id="9" name="Text 7"/>
           <p:cNvSpPr txBox="1"/>
           <p:nvPr/>
         </p:nvSpPr>
@@ -20070,7 +20109,7 @@
                 <a:ea typeface="Arial" pitchFamily="34" charset="-122"/>
                 <a:cs typeface="Arial" pitchFamily="34" charset="-120"/>
               </a:rPr>
-              <a:t>$466,000</a:t>
+              <a:t>$467,000</a:t>
             </a:r>
             <a:endParaRPr lang="en-US" sz="1300" dirty="0"/>
           </a:p>
@@ -20078,7 +20117,7 @@
       </p:sp>
       <p:sp>
         <p:nvSpPr>
-          <p:cNvPr id="9" name="Text 7"/>
+          <p:cNvPr id="10" name="Text 8"/>
           <p:cNvSpPr txBox="1"/>
           <p:nvPr/>
         </p:nvSpPr>
@@ -20117,7 +20156,7 @@
       </p:sp>
       <p:sp>
         <p:nvSpPr>
-          <p:cNvPr id="10" name="Text 8"/>
+          <p:cNvPr id="11" name="Text 9"/>
           <p:cNvSpPr txBox="1"/>
           <p:nvPr/>
         </p:nvSpPr>
@@ -20148,7 +20187,7 @@
                 <a:ea typeface="Arial" pitchFamily="34" charset="-122"/>
                 <a:cs typeface="Arial" pitchFamily="34" charset="-120"/>
               </a:rPr>
-              <a:t>$10,000</a:t>
+              <a:t>$11,000</a:t>
             </a:r>
             <a:endParaRPr lang="en-US" sz="1300" dirty="0"/>
           </a:p>
@@ -20156,7 +20195,7 @@
       </p:sp>
       <p:sp>
         <p:nvSpPr>
-          <p:cNvPr id="11" name="Text 9"/>
+          <p:cNvPr id="12" name="Text 10"/>
           <p:cNvSpPr txBox="1"/>
           <p:nvPr/>
         </p:nvSpPr>
@@ -20187,7 +20226,7 @@
                 <a:ea typeface="Arial" pitchFamily="34" charset="-122"/>
                 <a:cs typeface="Arial" pitchFamily="34" charset="-120"/>
               </a:rPr>
-              <a:t>Tests the top of the range; likely needs a price cut before an offer</a:t>
+              <a:t>Tests the upper part of the range; takes longer and may need a price cut before an offer</a:t>
             </a:r>
             <a:endParaRPr lang="en-US" sz="1100" dirty="0"/>
           </a:p>
@@ -20195,7 +20234,7 @@
       </p:sp>
       <p:sp>
         <p:nvSpPr>
-          <p:cNvPr id="12" name="Shape 10"/>
+          <p:cNvPr id="13" name="Shape 11"/>
           <p:cNvSpPr/>
           <p:nvPr/>
         </p:nvSpPr>
@@ -20222,7 +20261,7 @@
       </p:sp>
       <p:sp>
         <p:nvSpPr>
-          <p:cNvPr id="13" name="Text 11"/>
+          <p:cNvPr id="14" name="Text 12"/>
           <p:cNvSpPr txBox="1"/>
           <p:nvPr/>
         </p:nvSpPr>
@@ -20245,7 +20284,7 @@
               <a:buNone/>
             </a:pPr>
             <a:r>
-              <a:rPr lang="en-US" sz="1000" b="1" spc="200" kern="0" dirty="0">
+              <a:rPr lang="en-US" sz="950" b="1" dirty="0">
                 <a:solidFill>
                   <a:srgbClr val="FFFFFF"/>
                 </a:solidFill>
@@ -20253,15 +20292,15 @@
                 <a:ea typeface="Arial" pitchFamily="34" charset="-122"/>
                 <a:cs typeface="Arial" pitchFamily="34" charset="-120"/>
               </a:rPr>
-              <a:t>RECOMMENDED</a:t>
-            </a:r>
-            <a:endParaRPr lang="en-US" sz="1000" dirty="0"/>
-          </a:p>
-        </p:txBody>
-      </p:sp>
-      <p:sp>
-        <p:nvSpPr>
-          <p:cNvPr id="14" name="Text 12"/>
+              <a:t>MARKET PRICE · RECOMMENDED</a:t>
+            </a:r>
+            <a:endParaRPr lang="en-US" sz="950" dirty="0"/>
+          </a:p>
+        </p:txBody>
+      </p:sp>
+      <p:sp>
+        <p:nvSpPr>
+          <p:cNvPr id="15" name="Text 13"/>
           <p:cNvSpPr txBox="1"/>
           <p:nvPr/>
         </p:nvSpPr>
@@ -20300,7 +20339,7 @@
       </p:sp>
       <p:sp>
         <p:nvSpPr>
-          <p:cNvPr id="15" name="Text 13"/>
+          <p:cNvPr id="16" name="Text 14"/>
           <p:cNvSpPr txBox="1"/>
           <p:nvPr/>
         </p:nvSpPr>
@@ -20339,7 +20378,7 @@
       </p:sp>
       <p:sp>
         <p:nvSpPr>
-          <p:cNvPr id="16" name="Text 14"/>
+          <p:cNvPr id="17" name="Text 15"/>
           <p:cNvSpPr txBox="1"/>
           <p:nvPr/>
         </p:nvSpPr>
@@ -20370,7 +20409,7 @@
                 <a:ea typeface="Arial" pitchFamily="34" charset="-122"/>
                 <a:cs typeface="Arial" pitchFamily="34" charset="-120"/>
               </a:rPr>
-              <a:t>3–6 weeks</a:t>
+              <a:t>2–5 weeks</a:t>
             </a:r>
             <a:endParaRPr lang="en-US" sz="1300" dirty="0"/>
           </a:p>
@@ -20378,7 +20417,7 @@
       </p:sp>
       <p:sp>
         <p:nvSpPr>
-          <p:cNvPr id="17" name="Text 15"/>
+          <p:cNvPr id="18" name="Text 16"/>
           <p:cNvSpPr txBox="1"/>
           <p:nvPr/>
         </p:nvSpPr>
@@ -20417,7 +20456,7 @@
       </p:sp>
       <p:sp>
         <p:nvSpPr>
-          <p:cNvPr id="18" name="Text 16"/>
+          <p:cNvPr id="19" name="Text 17"/>
           <p:cNvSpPr txBox="1"/>
           <p:nvPr/>
         </p:nvSpPr>
@@ -20448,7 +20487,7 @@
                 <a:ea typeface="Arial" pitchFamily="34" charset="-122"/>
                 <a:cs typeface="Arial" pitchFamily="34" charset="-120"/>
               </a:rPr>
-              <a:t>$466,000</a:t>
+              <a:t>$467,000</a:t>
             </a:r>
             <a:endParaRPr lang="en-US" sz="1300" dirty="0"/>
           </a:p>
@@ -20456,7 +20495,7 @@
       </p:sp>
       <p:sp>
         <p:nvSpPr>
-          <p:cNvPr id="19" name="Text 17"/>
+          <p:cNvPr id="20" name="Text 18"/>
           <p:cNvSpPr txBox="1"/>
           <p:nvPr/>
         </p:nvSpPr>
@@ -20495,7 +20534,7 @@
       </p:sp>
       <p:sp>
         <p:nvSpPr>
-          <p:cNvPr id="20" name="Text 18"/>
+          <p:cNvPr id="21" name="Text 19"/>
           <p:cNvSpPr txBox="1"/>
           <p:nvPr/>
         </p:nvSpPr>
@@ -20526,7 +20565,7 @@
                 <a:ea typeface="Arial" pitchFamily="34" charset="-122"/>
                 <a:cs typeface="Arial" pitchFamily="34" charset="-120"/>
               </a:rPr>
-              <a:t>$10,000</a:t>
+              <a:t>$11,000</a:t>
             </a:r>
             <a:endParaRPr lang="en-US" sz="1300" dirty="0"/>
           </a:p>
@@ -20534,7 +20573,7 @@
       </p:sp>
       <p:sp>
         <p:nvSpPr>
-          <p:cNvPr id="21" name="Text 19"/>
+          <p:cNvPr id="22" name="Text 20"/>
           <p:cNvSpPr txBox="1"/>
           <p:nvPr/>
         </p:nvSpPr>
@@ -20565,7 +20604,7 @@
                 <a:ea typeface="Arial" pitchFamily="34" charset="-122"/>
                 <a:cs typeface="Arial" pitchFamily="34" charset="-120"/>
               </a:rPr>
-              <a:t>Priced at the middle of recent adjusted sales; room to negotiate</a:t>
+              <a:t>Priced where recent adjusted sales support; room to negotiate</a:t>
             </a:r>
             <a:endParaRPr lang="en-US" sz="1100" dirty="0"/>
           </a:p>
@@ -20573,7 +20612,7 @@
       </p:sp>
       <p:sp>
         <p:nvSpPr>
-          <p:cNvPr id="22" name="Shape 20"/>
+          <p:cNvPr id="23" name="Shape 21"/>
           <p:cNvSpPr/>
           <p:nvPr/>
         </p:nvSpPr>
@@ -20600,7 +20639,46 @@
       </p:sp>
       <p:sp>
         <p:nvSpPr>
-          <p:cNvPr id="23" name="Text 21"/>
+          <p:cNvPr id="24" name="Text 22"/>
+          <p:cNvSpPr txBox="1"/>
+          <p:nvPr/>
+        </p:nvSpPr>
+        <p:spPr>
+          <a:xfrm>
+            <a:off x="6327648" y="1188720"/>
+            <a:ext cx="2157984" cy="228600"/>
+          </a:xfrm>
+          <a:prstGeom prst="rect">
+            <a:avLst/>
+          </a:prstGeom>
+          <a:noFill/>
+          <a:ln/>
+        </p:spPr>
+        <p:txBody>
+          <a:bodyPr wrap="square" lIns="0" tIns="0" rIns="0" bIns="0" rtlCol="0" anchor="ctr"/>
+          <a:lstStyle/>
+          <a:p>
+            <a:pPr indent="0" marL="0">
+              <a:buNone/>
+            </a:pPr>
+            <a:r>
+              <a:rPr lang="en-US" sz="1000" b="1" dirty="0">
+                <a:solidFill>
+                  <a:srgbClr val="C2410C"/>
+                </a:solidFill>
+                <a:latin typeface="Arial" pitchFamily="34" charset="0"/>
+                <a:ea typeface="Arial" pitchFamily="34" charset="-122"/>
+                <a:cs typeface="Arial" pitchFamily="34" charset="-120"/>
+              </a:rPr>
+              <a:t>DRAW OFFERS</a:t>
+            </a:r>
+            <a:endParaRPr lang="en-US" sz="1000" dirty="0"/>
+          </a:p>
+        </p:txBody>
+      </p:sp>
+      <p:sp>
+        <p:nvSpPr>
+          <p:cNvPr id="25" name="Text 23"/>
           <p:cNvSpPr txBox="1"/>
           <p:nvPr/>
         </p:nvSpPr>
@@ -20639,7 +20717,7 @@
       </p:sp>
       <p:sp>
         <p:nvSpPr>
-          <p:cNvPr id="24" name="Text 22"/>
+          <p:cNvPr id="26" name="Text 24"/>
           <p:cNvSpPr txBox="1"/>
           <p:nvPr/>
         </p:nvSpPr>
@@ -20678,7 +20756,7 @@
       </p:sp>
       <p:sp>
         <p:nvSpPr>
-          <p:cNvPr id="25" name="Text 23"/>
+          <p:cNvPr id="27" name="Text 25"/>
           <p:cNvSpPr txBox="1"/>
           <p:nvPr/>
         </p:nvSpPr>
@@ -20709,7 +20787,7 @@
                 <a:ea typeface="Arial" pitchFamily="34" charset="-122"/>
                 <a:cs typeface="Arial" pitchFamily="34" charset="-120"/>
               </a:rPr>
-              <a:t>1–3 weeks</a:t>
+              <a:t>1–2 weeks</a:t>
             </a:r>
             <a:endParaRPr lang="en-US" sz="1300" dirty="0"/>
           </a:p>
@@ -20717,7 +20795,7 @@
       </p:sp>
       <p:sp>
         <p:nvSpPr>
-          <p:cNvPr id="26" name="Text 24"/>
+          <p:cNvPr id="28" name="Text 26"/>
           <p:cNvSpPr txBox="1"/>
           <p:nvPr/>
         </p:nvSpPr>
@@ -20756,7 +20834,7 @@
       </p:sp>
       <p:sp>
         <p:nvSpPr>
-          <p:cNvPr id="27" name="Text 25"/>
+          <p:cNvPr id="29" name="Text 27"/>
           <p:cNvSpPr txBox="1"/>
           <p:nvPr/>
         </p:nvSpPr>
@@ -20787,7 +20865,7 @@
                 <a:ea typeface="Arial" pitchFamily="34" charset="-122"/>
                 <a:cs typeface="Arial" pitchFamily="34" charset="-120"/>
               </a:rPr>
-              <a:t>$455,000</a:t>
+              <a:t>$457,000</a:t>
             </a:r>
             <a:endParaRPr lang="en-US" sz="1300" dirty="0"/>
           </a:p>
@@ -20795,14 +20873,14 @@
       </p:sp>
       <p:sp>
         <p:nvSpPr>
-          <p:cNvPr id="28" name="Text 26"/>
+          <p:cNvPr id="30" name="Text 28"/>
           <p:cNvSpPr txBox="1"/>
           <p:nvPr/>
         </p:nvSpPr>
         <p:spPr>
           <a:xfrm>
             <a:off x="6327648" y="2843784"/>
-            <a:ext cx="1504897" cy="347472"/>
+            <a:ext cx="1409430" cy="347472"/>
           </a:xfrm>
           <a:prstGeom prst="rect">
             <a:avLst/>
@@ -20834,14 +20912,14 @@
       </p:sp>
       <p:sp>
         <p:nvSpPr>
-          <p:cNvPr id="29" name="Text 27"/>
-          <p:cNvSpPr txBox="1"/>
-          <p:nvPr/>
-        </p:nvSpPr>
-        <p:spPr>
-          <a:xfrm>
-            <a:off x="7923985" y="2843784"/>
-            <a:ext cx="561647" cy="347472"/>
+          <p:cNvPr id="31" name="Text 29"/>
+          <p:cNvSpPr txBox="1"/>
+          <p:nvPr/>
+        </p:nvSpPr>
+        <p:spPr>
+          <a:xfrm>
+            <a:off x="7828518" y="2843784"/>
+            <a:ext cx="657114" cy="347472"/>
           </a:xfrm>
           <a:prstGeom prst="rect">
             <a:avLst/>
@@ -20865,7 +20943,7 @@
                 <a:ea typeface="Arial" pitchFamily="34" charset="-122"/>
                 <a:cs typeface="Arial" pitchFamily="34" charset="-120"/>
               </a:rPr>
-              <a:t>$5,000</a:t>
+              <a:t>$11,000</a:t>
             </a:r>
             <a:endParaRPr lang="en-US" sz="1300" dirty="0"/>
           </a:p>
@@ -20873,7 +20951,7 @@
       </p:sp>
       <p:sp>
         <p:nvSpPr>
-          <p:cNvPr id="30" name="Text 28"/>
+          <p:cNvPr id="32" name="Text 30"/>
           <p:cNvSpPr txBox="1"/>
           <p:nvPr/>
         </p:nvSpPr>
@@ -20904,7 +20982,7 @@
                 <a:ea typeface="Arial" pitchFamily="34" charset="-122"/>
                 <a:cs typeface="Arial" pitchFamily="34" charset="-120"/>
               </a:rPr>
-              <a:t>Aims for competing offers; depends on them materializing</a:t>
+              <a:t>Priced to bring the most buyers in early and draw offers; usually the fastest to contract</a:t>
             </a:r>
             <a:endParaRPr lang="en-US" sz="1100" dirty="0"/>
           </a:p>
@@ -20912,7 +20990,7 @@
       </p:sp>
       <p:sp>
         <p:nvSpPr>
-          <p:cNvPr id="31" name="Text 29"/>
+          <p:cNvPr id="33" name="Text 31"/>
           <p:cNvSpPr txBox="1"/>
           <p:nvPr/>
         </p:nvSpPr>
@@ -20951,7 +21029,7 @@
       </p:sp>
       <p:sp>
         <p:nvSpPr>
-          <p:cNvPr id="32" name="Text 30"/>
+          <p:cNvPr id="34" name="Text 32"/>
           <p:cNvSpPr txBox="1"/>
           <p:nvPr/>
         </p:nvSpPr>
@@ -20990,7 +21068,7 @@
       </p:sp>
       <p:sp>
         <p:nvSpPr>
-          <p:cNvPr id="33" name="Text 31"/>
+          <p:cNvPr id="35" name="Text 33"/>
           <p:cNvSpPr txBox="1"/>
           <p:nvPr/>
         </p:nvSpPr>

</xml_diff>

<commit_message>
Deck: the comps chart starts below the measured subtitle; the builder checks that no two texts on a slide overlap
Co-Authored-By: Claude Opus 5.5 <noreply@anthropic.com>
</commit_message>
<xml_diff>
--- a/samples/seller-cma/517-Larkwood-Ave-Listing-Presentation.pptx
+++ b/samples/seller-cma/517-Larkwood-Ave-Listing-Presentation.pptx
@@ -5391,16 +5391,16 @@
         <p:spPr>
           <a:xfrm>
             <a:off x="457200" y="841248"/>
-            <a:ext cx="8229600" cy="329184"/>
-          </a:xfrm>
-          <a:prstGeom prst="rect">
-            <a:avLst/>
-          </a:prstGeom>
-          <a:noFill/>
-          <a:ln/>
-        </p:spPr>
-        <p:txBody>
-          <a:bodyPr wrap="square" lIns="0" tIns="0" rIns="0" bIns="0" rtlCol="0" anchor="ctr"/>
+            <a:ext cx="8229600" cy="201422"/>
+          </a:xfrm>
+          <a:prstGeom prst="rect">
+            <a:avLst/>
+          </a:prstGeom>
+          <a:noFill/>
+          <a:ln/>
+        </p:spPr>
+        <p:txBody>
+          <a:bodyPr wrap="square" lIns="0" tIns="0" rIns="0" bIns="0" rtlCol="0" anchor="t"/>
           <a:lstStyle/>
           <a:p>
             <a:pPr indent="0" marL="0">
@@ -5739,16 +5739,16 @@
         <p:spPr>
           <a:xfrm>
             <a:off x="457200" y="841248"/>
-            <a:ext cx="8229600" cy="329184"/>
-          </a:xfrm>
-          <a:prstGeom prst="rect">
-            <a:avLst/>
-          </a:prstGeom>
-          <a:noFill/>
-          <a:ln/>
-        </p:spPr>
-        <p:txBody>
-          <a:bodyPr wrap="square" lIns="0" tIns="0" rIns="0" bIns="0" rtlCol="0" anchor="ctr"/>
+            <a:ext cx="8229600" cy="201422"/>
+          </a:xfrm>
+          <a:prstGeom prst="rect">
+            <a:avLst/>
+          </a:prstGeom>
+          <a:noFill/>
+          <a:ln/>
+        </p:spPr>
+        <p:txBody>
+          <a:bodyPr wrap="square" lIns="0" tIns="0" rIns="0" bIns="0" rtlCol="0" anchor="t"/>
           <a:lstStyle/>
           <a:p>
             <a:pPr indent="0" marL="0">
@@ -6486,16 +6486,16 @@
         <p:spPr>
           <a:xfrm>
             <a:off x="457200" y="841248"/>
-            <a:ext cx="8229600" cy="329184"/>
-          </a:xfrm>
-          <a:prstGeom prst="rect">
-            <a:avLst/>
-          </a:prstGeom>
-          <a:noFill/>
-          <a:ln/>
-        </p:spPr>
-        <p:txBody>
-          <a:bodyPr wrap="square" lIns="0" tIns="0" rIns="0" bIns="0" rtlCol="0" anchor="ctr"/>
+            <a:ext cx="8229600" cy="201422"/>
+          </a:xfrm>
+          <a:prstGeom prst="rect">
+            <a:avLst/>
+          </a:prstGeom>
+          <a:noFill/>
+          <a:ln/>
+        </p:spPr>
+        <p:txBody>
+          <a:bodyPr wrap="square" lIns="0" tIns="0" rIns="0" bIns="0" rtlCol="0" anchor="t"/>
           <a:lstStyle/>
           <a:p>
             <a:pPr indent="0" marL="0">
@@ -13385,16 +13385,16 @@
         <p:spPr>
           <a:xfrm>
             <a:off x="457200" y="841248"/>
-            <a:ext cx="8229600" cy="329184"/>
-          </a:xfrm>
-          <a:prstGeom prst="rect">
-            <a:avLst/>
-          </a:prstGeom>
-          <a:noFill/>
-          <a:ln/>
-        </p:spPr>
-        <p:txBody>
-          <a:bodyPr wrap="square" lIns="0" tIns="0" rIns="0" bIns="0" rtlCol="0" anchor="ctr"/>
+            <a:ext cx="8229600" cy="201422"/>
+          </a:xfrm>
+          <a:prstGeom prst="rect">
+            <a:avLst/>
+          </a:prstGeom>
+          <a:noFill/>
+          <a:ln/>
+        </p:spPr>
+        <p:txBody>
+          <a:bodyPr wrap="square" lIns="0" tIns="0" rIns="0" bIns="0" rtlCol="0" anchor="t"/>
           <a:lstStyle/>
           <a:p>
             <a:pPr indent="0" marL="0">
@@ -15363,16 +15363,16 @@
         <p:spPr>
           <a:xfrm>
             <a:off x="457200" y="841248"/>
-            <a:ext cx="8229600" cy="329184"/>
-          </a:xfrm>
-          <a:prstGeom prst="rect">
-            <a:avLst/>
-          </a:prstGeom>
-          <a:noFill/>
-          <a:ln/>
-        </p:spPr>
-        <p:txBody>
-          <a:bodyPr wrap="square" lIns="0" tIns="0" rIns="0" bIns="0" rtlCol="0" anchor="ctr"/>
+            <a:ext cx="8229600" cy="201422"/>
+          </a:xfrm>
+          <a:prstGeom prst="rect">
+            <a:avLst/>
+          </a:prstGeom>
+          <a:noFill/>
+          <a:ln/>
+        </p:spPr>
+        <p:txBody>
+          <a:bodyPr wrap="square" lIns="0" tIns="0" rIns="0" bIns="0" rtlCol="0" anchor="t"/>
           <a:lstStyle/>
           <a:p>
             <a:pPr indent="0" marL="0">
@@ -15401,7 +15401,7 @@
         </p:nvSpPr>
         <p:spPr>
           <a:xfrm>
-            <a:off x="5532120" y="1325880"/>
+            <a:off x="5532120" y="1463294"/>
             <a:ext cx="1143000" cy="2468880"/>
           </a:xfrm>
           <a:prstGeom prst="rect">
@@ -15426,7 +15426,7 @@
         </p:nvSpPr>
         <p:spPr>
           <a:xfrm>
-            <a:off x="3931920" y="1325880"/>
+            <a:off x="3931920" y="1463294"/>
             <a:ext cx="0" cy="2468880"/>
           </a:xfrm>
           <a:prstGeom prst="line">
@@ -15449,7 +15449,7 @@
         </p:nvSpPr>
         <p:spPr>
           <a:xfrm>
-            <a:off x="3520440" y="3840480"/>
+            <a:off x="3520440" y="3977894"/>
             <a:ext cx="822960" cy="228600"/>
           </a:xfrm>
           <a:prstGeom prst="rect">
@@ -15488,7 +15488,7 @@
         </p:nvSpPr>
         <p:spPr>
           <a:xfrm>
-            <a:off x="4846320" y="1325880"/>
+            <a:off x="4846320" y="1463294"/>
             <a:ext cx="0" cy="2468880"/>
           </a:xfrm>
           <a:prstGeom prst="line">
@@ -15511,7 +15511,7 @@
         </p:nvSpPr>
         <p:spPr>
           <a:xfrm>
-            <a:off x="4434840" y="3840480"/>
+            <a:off x="4434840" y="3977894"/>
             <a:ext cx="822960" cy="228600"/>
           </a:xfrm>
           <a:prstGeom prst="rect">
@@ -15550,7 +15550,7 @@
         </p:nvSpPr>
         <p:spPr>
           <a:xfrm>
-            <a:off x="5760720" y="1325880"/>
+            <a:off x="5760720" y="1463294"/>
             <a:ext cx="0" cy="2468880"/>
           </a:xfrm>
           <a:prstGeom prst="line">
@@ -15573,7 +15573,7 @@
         </p:nvSpPr>
         <p:spPr>
           <a:xfrm>
-            <a:off x="5349240" y="3840480"/>
+            <a:off x="5349240" y="3977894"/>
             <a:ext cx="822960" cy="228600"/>
           </a:xfrm>
           <a:prstGeom prst="rect">
@@ -15612,7 +15612,7 @@
         </p:nvSpPr>
         <p:spPr>
           <a:xfrm>
-            <a:off x="6675120" y="1325880"/>
+            <a:off x="6675120" y="1463294"/>
             <a:ext cx="0" cy="2468880"/>
           </a:xfrm>
           <a:prstGeom prst="line">
@@ -15635,7 +15635,7 @@
         </p:nvSpPr>
         <p:spPr>
           <a:xfrm>
-            <a:off x="6263640" y="3840480"/>
+            <a:off x="6263640" y="3977894"/>
             <a:ext cx="822960" cy="228600"/>
           </a:xfrm>
           <a:prstGeom prst="rect">
@@ -15674,7 +15674,7 @@
         </p:nvSpPr>
         <p:spPr>
           <a:xfrm>
-            <a:off x="7589520" y="1325880"/>
+            <a:off x="7589520" y="1463294"/>
             <a:ext cx="0" cy="2468880"/>
           </a:xfrm>
           <a:prstGeom prst="line">
@@ -15697,7 +15697,7 @@
         </p:nvSpPr>
         <p:spPr>
           <a:xfrm>
-            <a:off x="7178040" y="3840480"/>
+            <a:off x="7178040" y="3977894"/>
             <a:ext cx="822960" cy="228600"/>
           </a:xfrm>
           <a:prstGeom prst="rect">
@@ -15736,7 +15736,7 @@
         </p:nvSpPr>
         <p:spPr>
           <a:xfrm>
-            <a:off x="8503920" y="1325880"/>
+            <a:off x="8503920" y="1463294"/>
             <a:ext cx="0" cy="2468880"/>
           </a:xfrm>
           <a:prstGeom prst="line">
@@ -15759,7 +15759,7 @@
         </p:nvSpPr>
         <p:spPr>
           <a:xfrm>
-            <a:off x="8092440" y="3840480"/>
+            <a:off x="8092440" y="3977894"/>
             <a:ext cx="822960" cy="228600"/>
           </a:xfrm>
           <a:prstGeom prst="rect">
@@ -15798,7 +15798,7 @@
         </p:nvSpPr>
         <p:spPr>
           <a:xfrm>
-            <a:off x="6213348" y="1188720"/>
+            <a:off x="6213348" y="1326134"/>
             <a:ext cx="0" cy="2606040"/>
           </a:xfrm>
           <a:prstGeom prst="line">
@@ -15821,7 +15821,7 @@
         </p:nvSpPr>
         <p:spPr>
           <a:xfrm>
-            <a:off x="5207508" y="960120"/>
+            <a:off x="5207508" y="1097534"/>
             <a:ext cx="2011680" cy="228600"/>
           </a:xfrm>
           <a:prstGeom prst="rect">
@@ -15860,7 +15860,7 @@
         </p:nvSpPr>
         <p:spPr>
           <a:xfrm>
-            <a:off x="457200" y="1417320"/>
+            <a:off x="457200" y="1554734"/>
             <a:ext cx="3291840" cy="219456"/>
           </a:xfrm>
           <a:prstGeom prst="rect">
@@ -15899,7 +15899,7 @@
         </p:nvSpPr>
         <p:spPr>
           <a:xfrm>
-            <a:off x="457200" y="1618488"/>
+            <a:off x="457200" y="1755902"/>
             <a:ext cx="3291840" cy="201168"/>
           </a:xfrm>
           <a:prstGeom prst="rect">
@@ -15938,7 +15938,7 @@
         </p:nvSpPr>
         <p:spPr>
           <a:xfrm>
-            <a:off x="7228332" y="1536192"/>
+            <a:off x="7228332" y="1673606"/>
             <a:ext cx="164592" cy="164592"/>
           </a:xfrm>
           <a:prstGeom prst="ellipse">
@@ -15963,7 +15963,7 @@
         </p:nvSpPr>
         <p:spPr>
           <a:xfrm>
-            <a:off x="7420356" y="1490472"/>
+            <a:off x="7420356" y="1627886"/>
             <a:ext cx="640080" cy="237744"/>
           </a:xfrm>
           <a:prstGeom prst="rect">
@@ -16002,7 +16002,7 @@
         </p:nvSpPr>
         <p:spPr>
           <a:xfrm>
-            <a:off x="457200" y="1874520"/>
+            <a:off x="457200" y="2011934"/>
             <a:ext cx="3291840" cy="219456"/>
           </a:xfrm>
           <a:prstGeom prst="rect">
@@ -16041,7 +16041,7 @@
         </p:nvSpPr>
         <p:spPr>
           <a:xfrm>
-            <a:off x="457200" y="2075688"/>
+            <a:off x="457200" y="2213102"/>
             <a:ext cx="3291840" cy="201168"/>
           </a:xfrm>
           <a:prstGeom prst="rect">
@@ -16080,7 +16080,7 @@
         </p:nvSpPr>
         <p:spPr>
           <a:xfrm>
-            <a:off x="6775704" y="1993392"/>
+            <a:off x="6775704" y="2130806"/>
             <a:ext cx="164592" cy="164592"/>
           </a:xfrm>
           <a:prstGeom prst="ellipse">
@@ -16105,7 +16105,7 @@
         </p:nvSpPr>
         <p:spPr>
           <a:xfrm>
-            <a:off x="6967728" y="1947672"/>
+            <a:off x="6967728" y="2085086"/>
             <a:ext cx="640080" cy="237744"/>
           </a:xfrm>
           <a:prstGeom prst="rect">
@@ -16144,7 +16144,7 @@
         </p:nvSpPr>
         <p:spPr>
           <a:xfrm>
-            <a:off x="457200" y="2331720"/>
+            <a:off x="457200" y="2469134"/>
             <a:ext cx="3291840" cy="219456"/>
           </a:xfrm>
           <a:prstGeom prst="rect">
@@ -16183,7 +16183,7 @@
         </p:nvSpPr>
         <p:spPr>
           <a:xfrm>
-            <a:off x="457200" y="2532888"/>
+            <a:off x="457200" y="2670302"/>
             <a:ext cx="3291840" cy="201168"/>
           </a:xfrm>
           <a:prstGeom prst="rect">
@@ -16222,7 +16222,7 @@
         </p:nvSpPr>
         <p:spPr>
           <a:xfrm>
-            <a:off x="6126480" y="2450592"/>
+            <a:off x="6126480" y="2588006"/>
             <a:ext cx="164592" cy="164592"/>
           </a:xfrm>
           <a:prstGeom prst="ellipse">
@@ -16247,7 +16247,7 @@
         </p:nvSpPr>
         <p:spPr>
           <a:xfrm>
-            <a:off x="6318504" y="2404872"/>
+            <a:off x="6318504" y="2542286"/>
             <a:ext cx="640080" cy="237744"/>
           </a:xfrm>
           <a:prstGeom prst="rect">
@@ -16286,7 +16286,7 @@
         </p:nvSpPr>
         <p:spPr>
           <a:xfrm>
-            <a:off x="457200" y="2788920"/>
+            <a:off x="457200" y="2926334"/>
             <a:ext cx="3291840" cy="219456"/>
           </a:xfrm>
           <a:prstGeom prst="rect">
@@ -16325,7 +16325,7 @@
         </p:nvSpPr>
         <p:spPr>
           <a:xfrm>
-            <a:off x="457200" y="2990088"/>
+            <a:off x="457200" y="3127502"/>
             <a:ext cx="3291840" cy="201168"/>
           </a:xfrm>
           <a:prstGeom prst="rect">
@@ -16364,7 +16364,7 @@
         </p:nvSpPr>
         <p:spPr>
           <a:xfrm>
-            <a:off x="4773168" y="2907792"/>
+            <a:off x="4773168" y="3045206"/>
             <a:ext cx="164592" cy="164592"/>
           </a:xfrm>
           <a:prstGeom prst="ellipse">
@@ -16389,7 +16389,7 @@
         </p:nvSpPr>
         <p:spPr>
           <a:xfrm>
-            <a:off x="4965192" y="2862072"/>
+            <a:off x="4965192" y="2999486"/>
             <a:ext cx="640080" cy="237744"/>
           </a:xfrm>
           <a:prstGeom prst="rect">
@@ -16428,7 +16428,7 @@
         </p:nvSpPr>
         <p:spPr>
           <a:xfrm>
-            <a:off x="457200" y="3246120"/>
+            <a:off x="457200" y="3383534"/>
             <a:ext cx="3291840" cy="219456"/>
           </a:xfrm>
           <a:prstGeom prst="rect">
@@ -16467,7 +16467,7 @@
         </p:nvSpPr>
         <p:spPr>
           <a:xfrm>
-            <a:off x="457200" y="3447288"/>
+            <a:off x="457200" y="3584702"/>
             <a:ext cx="3291840" cy="201168"/>
           </a:xfrm>
           <a:prstGeom prst="rect">
@@ -16506,7 +16506,7 @@
         </p:nvSpPr>
         <p:spPr>
           <a:xfrm>
-            <a:off x="4576572" y="3364992"/>
+            <a:off x="4576572" y="3502406"/>
             <a:ext cx="164592" cy="164592"/>
           </a:xfrm>
           <a:prstGeom prst="ellipse">
@@ -16531,7 +16531,7 @@
         </p:nvSpPr>
         <p:spPr>
           <a:xfrm>
-            <a:off x="4768596" y="3319272"/>
+            <a:off x="4768596" y="3456686"/>
             <a:ext cx="640080" cy="237744"/>
           </a:xfrm>
           <a:prstGeom prst="rect">
@@ -16570,8 +16570,8 @@
         </p:nvSpPr>
         <p:spPr>
           <a:xfrm>
-            <a:off x="457200" y="4160520"/>
-            <a:ext cx="8229600" cy="544068"/>
+            <a:off x="457200" y="4297934"/>
+            <a:ext cx="8229600" cy="406654"/>
           </a:xfrm>
           <a:prstGeom prst="rect">
             <a:avLst/>
@@ -17776,16 +17776,16 @@
         <p:spPr>
           <a:xfrm>
             <a:off x="457200" y="841248"/>
-            <a:ext cx="8229600" cy="329184"/>
-          </a:xfrm>
-          <a:prstGeom prst="rect">
-            <a:avLst/>
-          </a:prstGeom>
-          <a:noFill/>
-          <a:ln/>
-        </p:spPr>
-        <p:txBody>
-          <a:bodyPr wrap="square" lIns="0" tIns="0" rIns="0" bIns="0" rtlCol="0" anchor="ctr"/>
+            <a:ext cx="8229600" cy="201422"/>
+          </a:xfrm>
+          <a:prstGeom prst="rect">
+            <a:avLst/>
+          </a:prstGeom>
+          <a:noFill/>
+          <a:ln/>
+        </p:spPr>
+        <p:txBody>
+          <a:bodyPr wrap="square" lIns="0" tIns="0" rIns="0" bIns="0" rtlCol="0" anchor="t"/>
           <a:lstStyle/>
           <a:p>
             <a:pPr indent="0" marL="0">
@@ -19087,16 +19087,16 @@
         <p:spPr>
           <a:xfrm>
             <a:off x="457200" y="841248"/>
-            <a:ext cx="8229600" cy="329184"/>
-          </a:xfrm>
-          <a:prstGeom prst="rect">
-            <a:avLst/>
-          </a:prstGeom>
-          <a:noFill/>
-          <a:ln/>
-        </p:spPr>
-        <p:txBody>
-          <a:bodyPr wrap="square" lIns="0" tIns="0" rIns="0" bIns="0" rtlCol="0" anchor="ctr"/>
+            <a:ext cx="8229600" cy="201422"/>
+          </a:xfrm>
+          <a:prstGeom prst="rect">
+            <a:avLst/>
+          </a:prstGeom>
+          <a:noFill/>
+          <a:ln/>
+        </p:spPr>
+        <p:txBody>
+          <a:bodyPr wrap="square" lIns="0" tIns="0" rIns="0" bIns="0" rtlCol="0" anchor="t"/>
           <a:lstStyle/>
           <a:p>
             <a:pPr indent="0" marL="0">

</xml_diff>

<commit_message>
Samples and release notes for the iteration 14 fixes
Co-Authored-By: Claude Opus 5.5 <noreply@anthropic.com>
</commit_message>
<xml_diff>
--- a/samples/seller-cma/517-Larkwood-Ave-Listing-Presentation.pptx
+++ b/samples/seller-cma/517-Larkwood-Ave-Listing-Presentation.pptx
@@ -2935,7 +2935,7 @@
                 <c:formatCode>General</c:formatCode>
                 <c:ptCount val="3"/>
                 <c:pt idx="0">
-                  <c:v>424222</c:v>
+                  <c:v>428442</c:v>
                 </c:pt>
                 <c:pt idx="1">
                   <c:v>424636</c:v>
@@ -3917,7 +3917,7 @@
           <a:p>
             <a:r>
               <a:rPr lang="en-US" dirty="0"/>
-              <a:t>Expected sales are estimates, not guarantees: each option's list price times an assumed 97.0% of its final asking price after seller-paid costs, plus that option's seller credit, to the nearest $500. At $474,900 we expect the recommended option's sale: a price above the recommended one usually sells after a cut, so it costs time rather than adding to the sale. Times to contract are estimates from the recent median of 22 days on market: longer for a higher price, shorter for a price that draws competing offers. Each option assumes a $11,000 seller credit toward the buyer's costs: how often recent sellers paid buyer costs times the typical amount. Holding costs: about $520 a month (insurance at the recommended $469,900 list price and utilities; no loan interest, since no mortgage payoff was given) from the report date to each option's closing; property tax is in the proration. Title company fees are typical local charges (settlement fee $700, title search $250, municipal lien search $125, recording $70); the title company's quote replaces them. Buyer payments: Conventional loan, 5% down, 6.95% 30-year fixed, property taxes at 18.1808 mills, with homestead, $3,600 a year insurance, and 0.5% a year mortgage insurance. Commissions are negotiable and not set by law. Not included: your mortgage payoff, this year's property tax proration (the tax bill and the expected closing date add it) and any repairs agreed after inspection. The closing agent provides the exact figures. Flood zone X: a lender may not require flood insurance, but a Citizens policy on a home with a dwelling replacement cost of $400,000 or more must carry flood insurance, and from January 1, 2027 every Citizens policy must (s. 627.351(6)(aa)). Get a quote; the total leaves it out until then.</a:t>
+              <a:t>Expected sales are estimates, not guarantees: each option's list price times an assumed 97.0% of its final asking price after seller-paid costs, plus that option's seller credit, to the nearest $500. Times to contract are estimates from the recent median of 22 days on market: longer for a higher price, shorter for a price that draws competing offers. Each option assumes a $11,000 seller credit toward the buyer's costs: how often recent sellers paid buyer costs times the typical amount. Holding costs: about $520 a month (insurance at the recommended $469,900 list price and utilities; no loan interest, since no mortgage payoff was given) from the report date to each option's closing; property tax is in the proration. Title company fees are typical local charges (settlement fee $700, title search $250, municipal lien search $125, recording $70); the title company's quote replaces them. Buyer payments: Conventional loan, 5% down, 6.95% 30-year fixed, property taxes at 18.1808 mills, with homestead, $3,600 a year insurance, and 0.5% a year mortgage insurance. Commissions are negotiable and not set by law. Not included: your mortgage payoff, this year's property tax proration (the tax bill and the expected closing date add it) and any repairs agreed after inspection. The closing agent provides the exact figures. Flood zone X: a lender may not require flood insurance, but a Citizens policy on a home with a dwelling replacement cost of $400,000 or more must carry flood insurance, and from January 1, 2027 every Citizens policy must (s. 627.351(6)(aa)). Get a quote; the total leaves it out until then.</a:t>
             </a:r>
             <a:endParaRPr lang="en-US" dirty="0"/>
           </a:p>
@@ -4005,7 +4005,7 @@
           <a:p>
             <a:r>
               <a:rPr lang="en-US" dirty="0"/>
-              <a:t>Adjusted for size ($1,200 to $1,800), lot ($5,000), market changes since each sale (1% a quarter off sales before July), roof and systems ($5,000), condition and updates ($30,000 to $45,000, against this home's full renovation), view or water ($10,000) and seller credits (taken off each sale price). These are the five closest matches, sold Apr 24, 2026 to Aug 20, 2026 (one since July), all within a mile.</a:t>
+              <a:t>Adjusted for size ($1,200 to $1,800); lot ($5,000); market changes since each sale (1% a quarter off sales before July); roof and systems ($5,000); condition and updates ($30,000 to $45,000, against this home's full renovation); view or water ($10,000); and seller credits (taken off each sale price). These are the five closest matches, sold Apr 24, 2026 to Aug 20, 2026 (one since July), all within a mile.</a:t>
             </a:r>
             <a:endParaRPr lang="en-US" dirty="0"/>
           </a:p>
@@ -5497,7 +5497,7 @@
                 <a:ea typeface="Arial" pitchFamily="34" charset="-122"/>
                 <a:cs typeface="Arial" pitchFamily="34" charset="-120"/>
               </a:rPr>
-              <a:t>$9,139</a:t>
+              <a:t>$12,945</a:t>
             </a:r>
             <a:endParaRPr lang="en-US" sz="3200" dirty="0"/>
           </a:p>
@@ -8770,7 +8770,7 @@
                           <a:ea typeface="Arial" pitchFamily="34" charset="-122"/>
                           <a:cs typeface="Arial" pitchFamily="34" charset="-120"/>
                         </a:rPr>
-                        <a:t>$467,000</a:t>
+                        <a:t>$471,500</a:t>
                       </a:r>
                       <a:endParaRPr lang="en-US" sz="1000" dirty="0">
                         <a:latin typeface="Arial" charset="0"/>
@@ -9174,7 +9174,7 @@
                           <a:ea typeface="Arial" pitchFamily="34" charset="-122"/>
                           <a:cs typeface="Arial" pitchFamily="34" charset="-120"/>
                         </a:rPr>
-                        <a:t>−$11,675</a:t>
+                        <a:t>−$11,788</a:t>
                       </a:r>
                       <a:endParaRPr lang="en-US" sz="1000" dirty="0">
                         <a:latin typeface="Arial" charset="0"/>
@@ -9376,7 +9376,7 @@
                           <a:ea typeface="Arial" pitchFamily="34" charset="-122"/>
                           <a:cs typeface="Arial" pitchFamily="34" charset="-120"/>
                         </a:rPr>
-                        <a:t>−$11,675</a:t>
+                        <a:t>−$11,788</a:t>
                       </a:r>
                       <a:endParaRPr lang="en-US" sz="1000" dirty="0">
                         <a:latin typeface="Arial" charset="0"/>
@@ -9578,7 +9578,7 @@
                           <a:ea typeface="Arial" pitchFamily="34" charset="-122"/>
                           <a:cs typeface="Arial" pitchFamily="34" charset="-120"/>
                         </a:rPr>
-                        <a:t>−$3,269</a:t>
+                        <a:t>−$3,301</a:t>
                       </a:r>
                       <a:endParaRPr lang="en-US" sz="1000" dirty="0">
                         <a:latin typeface="Arial" charset="0"/>
@@ -9780,7 +9780,7 @@
                           <a:ea typeface="Arial" pitchFamily="34" charset="-122"/>
                           <a:cs typeface="Arial" pitchFamily="34" charset="-120"/>
                         </a:rPr>
-                        <a:t>−$2,410</a:t>
+                        <a:t>−$2,432</a:t>
                       </a:r>
                       <a:endParaRPr lang="en-US" sz="1000" dirty="0">
                         <a:latin typeface="Arial" charset="0"/>
@@ -10392,7 +10392,7 @@
                           <a:ea typeface="Arial" pitchFamily="34" charset="-122"/>
                           <a:cs typeface="Arial" pitchFamily="34" charset="-120"/>
                         </a:rPr>
-                        <a:t>$425,826</a:t>
+                        <a:t>$430,046</a:t>
                       </a:r>
                       <a:endParaRPr lang="en-US" sz="1000" dirty="0">
                         <a:latin typeface="Arial" charset="0"/>
@@ -10820,7 +10820,7 @@
                           <a:ea typeface="Arial" pitchFamily="34" charset="-122"/>
                           <a:cs typeface="Arial" pitchFamily="34" charset="-120"/>
                         </a:rPr>
-                        <a:t>$424,222</a:t>
+                        <a:t>$428,442</a:t>
                       </a:r>
                       <a:endParaRPr lang="en-US" sz="1000" dirty="0">
                         <a:latin typeface="Arial" charset="0"/>
@@ -14222,7 +14222,7 @@
                 <a:ea typeface="Arial" pitchFamily="34" charset="-122"/>
                 <a:cs typeface="Arial" pitchFamily="34" charset="-120"/>
               </a:rPr>
-              <a:t>Adjusted for size ($1,200 to $1,800), lot ($5,000), market changes since each sale (1% a quarter off sales before July), roof and systems ($5,000), condition and updates ($30,000 to $45,000, against this home's full renovation), view or water ($10,000) and seller credits (taken off each sale price).</a:t>
+              <a:t>Adjusted for size ($1,200 to $1,800); lot ($5,000); market changes since each sale (1% a quarter off sales before July); roof and systems ($5,000); condition and updates ($30,000 to $45,000, against this home's full renovation); view or water ($10,000); and seller credits (taken off each sale price).</a:t>
             </a:r>
             <a:endParaRPr lang="en-US" sz="1100" dirty="0"/>
           </a:p>
@@ -20109,7 +20109,7 @@
                 <a:ea typeface="Arial" pitchFamily="34" charset="-122"/>
                 <a:cs typeface="Arial" pitchFamily="34" charset="-120"/>
               </a:rPr>
-              <a:t>$467,000</a:t>
+              <a:t>$471,500</a:t>
             </a:r>
             <a:endParaRPr lang="en-US" sz="1300" dirty="0"/>
           </a:p>

</xml_diff>

<commit_message>
Seller CMA: list prices on round search-bracket steps; a relist never lists at the failed price
Portal price filters include their bounds, so $470,000 shows up in both "up to $470,000"
and "$470,000 and up", where $469,900 misses the upper one. bracket_price drops the
$100/$1,000 offset; the relist cap is the step strictly under the failed price.
Version 0.14.0.

Co-Authored-By: Claude Opus 5.5 <noreply@anthropic.com>
</commit_message>
<xml_diff>
--- a/samples/seller-cma/517-Larkwood-Ave-Listing-Presentation.pptx
+++ b/samples/seller-cma/517-Larkwood-Ave-Listing-Presentation.pptx
@@ -2658,7 +2658,7 @@
                   <c:v/>
                 </c:pt>
                 <c:pt idx="74">
-                  <c:v>469900</c:v>
+                  <c:v>470000</c:v>
                 </c:pt>
               </c:numCache>
             </c:numRef>
@@ -2916,13 +2916,13 @@
                 <c:ptCount val="3"/>
                 <c:lvl>
                   <c:pt idx="0">
-                    <c:v>Premium at $474,900</c:v>
+                    <c:v>Premium at $475,000</c:v>
                   </c:pt>
                   <c:pt idx="1">
-                    <c:v>Market Price at $469,900</c:v>
+                    <c:v>Market Price at $470,000</c:v>
                   </c:pt>
                   <c:pt idx="2">
-                    <c:v>Draw Offers at $459,900</c:v>
+                    <c:v>Draw Offers at $460,000</c:v>
                   </c:pt>
                 </c:lvl>
               </c:multiLvlStrCache>
@@ -2935,7 +2935,7 @@
                 <c:formatCode>General</c:formatCode>
                 <c:ptCount val="3"/>
                 <c:pt idx="0">
-                  <c:v>428442</c:v>
+                  <c:v>428912</c:v>
                 </c:pt>
                 <c:pt idx="1">
                   <c:v>424636</c:v>
@@ -3917,7 +3917,7 @@
           <a:p>
             <a:r>
               <a:rPr lang="en-US" dirty="0"/>
-              <a:t>Expected sales are estimates, not guarantees: each option's list price times an assumed 97.0% of its final asking price after seller-paid costs, plus that option's seller credit, to the nearest $500. Times to contract are estimates from the recent median of 22 days on market: longer for a higher price, shorter for a price that draws competing offers. Each option assumes a $11,000 seller credit toward the buyer's costs: how often recent sellers paid buyer costs times the typical amount. Holding costs: about $520 a month (insurance at the recommended $469,900 list price and utilities; no loan interest, since no mortgage payoff was given) from the report date to each option's closing; property tax is in the proration. Title company fees are typical local charges (settlement fee $700, title search $250, municipal lien search $125, recording $70); the title company's quote replaces them. Buyer payments: Conventional loan, 5% down, 6.95% 30-year fixed, property taxes at 18.1808 mills, with homestead, $3,600 a year insurance, and 0.5% a year mortgage insurance. Commissions are negotiable and not set by law. Not included: your mortgage payoff, this year's property tax proration (the tax bill and the expected closing date add it) and any repairs agreed after inspection. The closing agent provides the exact figures. Flood zone X: a lender may not require flood insurance, but a Citizens policy on a home with a dwelling replacement cost of $400,000 or more must carry flood insurance, and from January 1, 2027 every Citizens policy must (s. 627.351(6)(aa)). Get a quote; the total leaves it out until then.</a:t>
+              <a:t>Expected sales are estimates, not guarantees: each option's list price times an assumed 97.0% of its final asking price after seller-paid costs, plus that option's seller credit, to the nearest $500. Times to contract are estimates from the recent median of 22 days on market: longer for a higher price, shorter for a price that draws competing offers. Each option assumes a $11,000 seller credit toward the buyer's costs: how often recent sellers paid buyer costs times the typical amount. Holding costs: about $520 a month (insurance at the recommended $470,000 list price and utilities; no loan interest, since no mortgage payoff was given) from the report date to each option's closing; property tax is in the proration. Title company fees are typical local charges (settlement fee $700, title search $250, municipal lien search $125, recording $70); the title company's quote replaces them. Buyer payments: Conventional loan, 5% down, 6.95% 30-year fixed, property taxes at 18.1808 mills, with homestead, $3,600 a year insurance, and 0.5% a year mortgage insurance. Commissions are negotiable and not set by law. Not included: your mortgage payoff, this year's property tax proration (the tax bill and the expected closing date add it) and any repairs agreed after inspection. The closing agent provides the exact figures. Flood zone X: a lender may not require flood insurance, but a Citizens policy on a home with a dwelling replacement cost of $400,000 or more must carry flood insurance, and from January 1, 2027 every Citizens policy must (s. 627.351(6)(aa)). Get a quote; the total leaves it out until then.</a:t>
             </a:r>
             <a:endParaRPr lang="en-US" dirty="0"/>
           </a:p>
@@ -5497,7 +5497,7 @@
                 <a:ea typeface="Arial" pitchFamily="34" charset="-122"/>
                 <a:cs typeface="Arial" pitchFamily="34" charset="-120"/>
               </a:rPr>
-              <a:t>$12,945</a:t>
+              <a:t>$13,415</a:t>
             </a:r>
             <a:endParaRPr lang="en-US" sz="3200" dirty="0"/>
           </a:p>
@@ -5829,7 +5829,7 @@
                 <a:ea typeface="Arial" pitchFamily="34" charset="-122"/>
                 <a:cs typeface="Arial" pitchFamily="34" charset="-120"/>
               </a:rPr>
-              <a:t>Premium at $474,900</a:t>
+              <a:t>Premium at $475,000</a:t>
             </a:r>
             <a:endParaRPr lang="en-US" sz="1300" dirty="0"/>
           </a:p>
@@ -5868,7 +5868,7 @@
                 <a:ea typeface="Arial" pitchFamily="34" charset="-122"/>
                 <a:cs typeface="Arial" pitchFamily="34" charset="-120"/>
               </a:rPr>
-              <a:t>$4,127/mo</a:t>
+              <a:t>$4,128/mo</a:t>
             </a:r>
             <a:endParaRPr lang="en-US" sz="2800" dirty="0"/>
           </a:p>
@@ -5907,7 +5907,7 @@
                 <a:ea typeface="Arial" pitchFamily="34" charset="-122"/>
                 <a:cs typeface="Arial" pitchFamily="34" charset="-120"/>
               </a:rPr>
-              <a:t>$23,745 down (5%)</a:t>
+              <a:t>$23,750 down (5%)</a:t>
             </a:r>
             <a:endParaRPr lang="en-US" sz="1100" dirty="0"/>
           </a:p>
@@ -5973,7 +5973,7 @@
                 <a:ea typeface="Arial" pitchFamily="34" charset="-122"/>
                 <a:cs typeface="Arial" pitchFamily="34" charset="-120"/>
               </a:rPr>
-              <a:t>Market Price at $469,900</a:t>
+              <a:t>Market Price at $470,000</a:t>
             </a:r>
             <a:endParaRPr lang="en-US" sz="1300" dirty="0"/>
           </a:p>
@@ -6012,7 +6012,7 @@
                 <a:ea typeface="Arial" pitchFamily="34" charset="-122"/>
                 <a:cs typeface="Arial" pitchFamily="34" charset="-120"/>
               </a:rPr>
-              <a:t>$4,087/mo</a:t>
+              <a:t>$4,088/mo</a:t>
             </a:r>
             <a:endParaRPr lang="en-US" sz="2800" dirty="0"/>
           </a:p>
@@ -6051,7 +6051,7 @@
                 <a:ea typeface="Arial" pitchFamily="34" charset="-122"/>
                 <a:cs typeface="Arial" pitchFamily="34" charset="-120"/>
               </a:rPr>
-              <a:t>$23,495 down (5%)</a:t>
+              <a:t>$23,500 down (5%)</a:t>
             </a:r>
             <a:endParaRPr lang="en-US" sz="1100" dirty="0"/>
           </a:p>
@@ -6117,7 +6117,7 @@
                 <a:ea typeface="Arial" pitchFamily="34" charset="-122"/>
                 <a:cs typeface="Arial" pitchFamily="34" charset="-120"/>
               </a:rPr>
-              <a:t>Draw Offers at $459,900</a:t>
+              <a:t>Draw Offers at $460,000</a:t>
             </a:r>
             <a:endParaRPr lang="en-US" sz="1300" dirty="0"/>
           </a:p>
@@ -6156,7 +6156,7 @@
                 <a:ea typeface="Arial" pitchFamily="34" charset="-122"/>
                 <a:cs typeface="Arial" pitchFamily="34" charset="-120"/>
               </a:rPr>
-              <a:t>$4,004/mo</a:t>
+              <a:t>$4,006/mo</a:t>
             </a:r>
             <a:endParaRPr lang="en-US" sz="2800" dirty="0"/>
           </a:p>
@@ -6195,7 +6195,7 @@
                 <a:ea typeface="Arial" pitchFamily="34" charset="-122"/>
                 <a:cs typeface="Arial" pitchFamily="34" charset="-120"/>
               </a:rPr>
-              <a:t>$22,995 down (5%)</a:t>
+              <a:t>$23,000 down (5%)</a:t>
             </a:r>
             <a:endParaRPr lang="en-US" sz="1100" dirty="0"/>
           </a:p>
@@ -6283,7 +6283,7 @@
                 <a:ea typeface="Arial" pitchFamily="34" charset="-122"/>
                 <a:cs typeface="Arial" pitchFamily="34" charset="-120"/>
               </a:rPr>
-              <a:t>Every $10,000 in price is about $83 a month to a buyer.</a:t>
+              <a:t>Every $10,000 in price is about $82 a month to a buyer.</a:t>
             </a:r>
             <a:endParaRPr lang="en-US" sz="1400" dirty="0"/>
           </a:p>
@@ -8214,7 +8214,7 @@
                 <a:ea typeface="Arial" pitchFamily="34" charset="-122"/>
                 <a:cs typeface="Arial" pitchFamily="34" charset="-120"/>
               </a:rPr>
-              <a:t>Go live at $469,900</a:t>
+              <a:t>Go live at $470,000</a:t>
             </a:r>
             <a:endParaRPr lang="en-US" sz="1100" dirty="0"/>
           </a:p>
@@ -8568,7 +8568,7 @@
                           <a:ea typeface="Arial" pitchFamily="34" charset="-122"/>
                           <a:cs typeface="Arial" pitchFamily="34" charset="-120"/>
                         </a:rPr>
-                        <a:t>Premium at $474,900</a:t>
+                        <a:t>Premium at $475,000</a:t>
                       </a:r>
                       <a:endParaRPr lang="en-US" sz="1000" dirty="0">
                         <a:latin typeface="Arial" charset="0"/>
@@ -8618,7 +8618,7 @@
                           <a:ea typeface="Arial" pitchFamily="34" charset="-122"/>
                           <a:cs typeface="Arial" pitchFamily="34" charset="-120"/>
                         </a:rPr>
-                        <a:t>Market Price at $469,900</a:t>
+                        <a:t>Market Price at $470,000</a:t>
                       </a:r>
                       <a:endParaRPr lang="en-US" sz="1000" dirty="0">
                         <a:latin typeface="Arial" charset="0"/>
@@ -8668,7 +8668,7 @@
                           <a:ea typeface="Arial" pitchFamily="34" charset="-122"/>
                           <a:cs typeface="Arial" pitchFamily="34" charset="-120"/>
                         </a:rPr>
-                        <a:t>Draw Offers at $459,900</a:t>
+                        <a:t>Draw Offers at $460,000</a:t>
                       </a:r>
                       <a:endParaRPr lang="en-US" sz="1000" dirty="0">
                         <a:latin typeface="Arial" charset="0"/>
@@ -8770,7 +8770,7 @@
                           <a:ea typeface="Arial" pitchFamily="34" charset="-122"/>
                           <a:cs typeface="Arial" pitchFamily="34" charset="-120"/>
                         </a:rPr>
-                        <a:t>$471,500</a:t>
+                        <a:t>$472,000</a:t>
                       </a:r>
                       <a:endParaRPr lang="en-US" sz="1000" dirty="0">
                         <a:latin typeface="Arial" charset="0"/>
@@ -9174,7 +9174,7 @@
                           <a:ea typeface="Arial" pitchFamily="34" charset="-122"/>
                           <a:cs typeface="Arial" pitchFamily="34" charset="-120"/>
                         </a:rPr>
-                        <a:t>−$11,788</a:t>
+                        <a:t>−$11,800</a:t>
                       </a:r>
                       <a:endParaRPr lang="en-US" sz="1000" dirty="0">
                         <a:latin typeface="Arial" charset="0"/>
@@ -9376,7 +9376,7 @@
                           <a:ea typeface="Arial" pitchFamily="34" charset="-122"/>
                           <a:cs typeface="Arial" pitchFamily="34" charset="-120"/>
                         </a:rPr>
-                        <a:t>−$11,788</a:t>
+                        <a:t>−$11,800</a:t>
                       </a:r>
                       <a:endParaRPr lang="en-US" sz="1000" dirty="0">
                         <a:latin typeface="Arial" charset="0"/>
@@ -9578,7 +9578,7 @@
                           <a:ea typeface="Arial" pitchFamily="34" charset="-122"/>
                           <a:cs typeface="Arial" pitchFamily="34" charset="-120"/>
                         </a:rPr>
-                        <a:t>−$3,301</a:t>
+                        <a:t>−$3,304</a:t>
                       </a:r>
                       <a:endParaRPr lang="en-US" sz="1000" dirty="0">
                         <a:latin typeface="Arial" charset="0"/>
@@ -9780,7 +9780,7 @@
                           <a:ea typeface="Arial" pitchFamily="34" charset="-122"/>
                           <a:cs typeface="Arial" pitchFamily="34" charset="-120"/>
                         </a:rPr>
-                        <a:t>−$2,432</a:t>
+                        <a:t>−$2,435</a:t>
                       </a:r>
                       <a:endParaRPr lang="en-US" sz="1000" dirty="0">
                         <a:latin typeface="Arial" charset="0"/>
@@ -10392,7 +10392,7 @@
                           <a:ea typeface="Arial" pitchFamily="34" charset="-122"/>
                           <a:cs typeface="Arial" pitchFamily="34" charset="-120"/>
                         </a:rPr>
-                        <a:t>$430,046</a:t>
+                        <a:t>$430,516</a:t>
                       </a:r>
                       <a:endParaRPr lang="en-US" sz="1000" dirty="0">
                         <a:latin typeface="Arial" charset="0"/>
@@ -10820,7 +10820,7 @@
                           <a:ea typeface="Arial" pitchFamily="34" charset="-122"/>
                           <a:cs typeface="Arial" pitchFamily="34" charset="-120"/>
                         </a:rPr>
-                        <a:t>$428,442</a:t>
+                        <a:t>$428,912</a:t>
                       </a:r>
                       <a:endParaRPr lang="en-US" sz="1000" dirty="0">
                         <a:latin typeface="Arial" charset="0"/>
@@ -12478,7 +12478,7 @@
                           <a:ea typeface="Arial" pitchFamily="34" charset="-122"/>
                           <a:cs typeface="Arial" pitchFamily="34" charset="-120"/>
                         </a:rPr>
-                        <a:t>$469,900</a:t>
+                        <a:t>$470,000</a:t>
                       </a:r>
                       <a:endParaRPr lang="en-US" sz="1100" dirty="0">
                         <a:latin typeface="Arial" charset="0"/>
@@ -12894,7 +12894,7 @@
                 <a:ea typeface="Arial" pitchFamily="34" charset="-122"/>
                 <a:cs typeface="Arial" pitchFamily="34" charset="-120"/>
               </a:rPr>
-              <a:t>$469,900</a:t>
+              <a:t>$470,000</a:t>
             </a:r>
             <a:endParaRPr lang="en-US" sz="6400" dirty="0"/>
           </a:p>
@@ -14105,7 +14105,7 @@
                 <a:ea typeface="Arial" pitchFamily="34" charset="-122"/>
                 <a:cs typeface="Arial" pitchFamily="34" charset="-120"/>
               </a:rPr>
-              <a:t>$469,900</a:t>
+              <a:t>$470,000</a:t>
             </a:r>
             <a:endParaRPr lang="en-US" sz="4000" dirty="0"/>
           </a:p>
@@ -15798,7 +15798,7 @@
         </p:nvSpPr>
         <p:spPr>
           <a:xfrm>
-            <a:off x="6213348" y="1326134"/>
+            <a:off x="6217920" y="1326134"/>
             <a:ext cx="0" cy="2606040"/>
           </a:xfrm>
           <a:prstGeom prst="line">
@@ -15821,7 +15821,7 @@
         </p:nvSpPr>
         <p:spPr>
           <a:xfrm>
-            <a:off x="5207508" y="1097534"/>
+            <a:off x="5212080" y="1097534"/>
             <a:ext cx="2011680" cy="228600"/>
           </a:xfrm>
           <a:prstGeom prst="rect">
@@ -15846,7 +15846,7 @@
                 <a:ea typeface="Arial" pitchFamily="34" charset="-122"/>
                 <a:cs typeface="Arial" pitchFamily="34" charset="-120"/>
               </a:rPr>
-              <a:t>Recommended $469,900</a:t>
+              <a:t>Recommended $470,000</a:t>
             </a:r>
             <a:endParaRPr lang="en-US" sz="1000" dirty="0"/>
           </a:p>
@@ -19953,7 +19953,7 @@
                 <a:ea typeface="Arial" pitchFamily="34" charset="-122"/>
                 <a:cs typeface="Arial" pitchFamily="34" charset="-120"/>
               </a:rPr>
-              <a:t>$474,900</a:t>
+              <a:t>$475,000</a:t>
             </a:r>
             <a:endParaRPr lang="en-US" sz="3000" dirty="0"/>
           </a:p>
@@ -20109,7 +20109,7 @@
                 <a:ea typeface="Arial" pitchFamily="34" charset="-122"/>
                 <a:cs typeface="Arial" pitchFamily="34" charset="-120"/>
               </a:rPr>
-              <a:t>$471,500</a:t>
+              <a:t>$472,000</a:t>
             </a:r>
             <a:endParaRPr lang="en-US" sz="1300" dirty="0"/>
           </a:p>
@@ -20331,7 +20331,7 @@
                 <a:ea typeface="Arial" pitchFamily="34" charset="-122"/>
                 <a:cs typeface="Arial" pitchFamily="34" charset="-120"/>
               </a:rPr>
-              <a:t>$469,900</a:t>
+              <a:t>$470,000</a:t>
             </a:r>
             <a:endParaRPr lang="en-US" sz="3000" dirty="0"/>
           </a:p>
@@ -20709,7 +20709,7 @@
                 <a:ea typeface="Arial" pitchFamily="34" charset="-122"/>
                 <a:cs typeface="Arial" pitchFamily="34" charset="-120"/>
               </a:rPr>
-              <a:t>$459,900</a:t>
+              <a:t>$460,000</a:t>
             </a:r>
             <a:endParaRPr lang="en-US" sz="3000" dirty="0"/>
           </a:p>

</xml_diff>

<commit_message>
The subject home is the darkest brand shade everywhere: card, table row, chart marker, price line and deck
Co-Authored-By: Claude Opus 5.5 <noreply@anthropic.com>
</commit_message>
<xml_diff>
--- a/samples/seller-cma/517-Larkwood-Ave-Listing-Presentation.pptx
+++ b/samples/seller-cma/517-Larkwood-Ave-Listing-Presentation.pptx
@@ -2174,7 +2174,7 @@
           </c:tx>
           <c:spPr>
             <a:solidFill>
-              <a:srgbClr val="1A1A1A"/>
+              <a:srgbClr val="7B2400"/>
             </a:solidFill>
             <a:ln>
               <a:noFill/>
@@ -2186,7 +2186,7 @@
             <c:size val="11"/>
             <c:spPr>
               <a:solidFill>
-                <a:srgbClr val="1A1A1A"/>
+                <a:srgbClr val="7B2400"/>
               </a:solidFill>
               <a:ln w="19050">
                 <a:solidFill>
@@ -12416,7 +12416,7 @@
                       <a:r>
                         <a:rPr lang="en-US" sz="1100" b="1" dirty="0">
                           <a:solidFill>
-                            <a:srgbClr val="1A1A1A"/>
+                            <a:srgbClr val="7B2400"/>
                           </a:solidFill>
                           <a:latin typeface="Arial" pitchFamily="34" charset="0"/>
                           <a:ea typeface="Arial" pitchFamily="34" charset="-122"/>
@@ -12472,7 +12472,7 @@
                       <a:r>
                         <a:rPr lang="en-US" sz="1100" b="1" dirty="0">
                           <a:solidFill>
-                            <a:srgbClr val="1A1A1A"/>
+                            <a:srgbClr val="7B2400"/>
                           </a:solidFill>
                           <a:latin typeface="Arial" pitchFamily="34" charset="0"/>
                           <a:ea typeface="Arial" pitchFamily="34" charset="-122"/>
@@ -12528,7 +12528,7 @@
                       <a:r>
                         <a:rPr lang="en-US" sz="1100" b="1" dirty="0">
                           <a:solidFill>
-                            <a:srgbClr val="1A1A1A"/>
+                            <a:srgbClr val="7B2400"/>
                           </a:solidFill>
                           <a:latin typeface="Arial" pitchFamily="34" charset="0"/>
                           <a:ea typeface="Arial" pitchFamily="34" charset="-122"/>
@@ -12584,7 +12584,7 @@
                       <a:r>
                         <a:rPr lang="en-US" sz="1100" b="1" dirty="0">
                           <a:solidFill>
-                            <a:srgbClr val="1A1A1A"/>
+                            <a:srgbClr val="7B2400"/>
                           </a:solidFill>
                           <a:latin typeface="Arial" pitchFamily="34" charset="0"/>
                           <a:ea typeface="Arial" pitchFamily="34" charset="-122"/>
@@ -15745,7 +15745,7 @@
           <a:noFill/>
           <a:ln w="25400">
             <a:solidFill>
-              <a:srgbClr val="1A1A1A"/>
+              <a:srgbClr val="7B2400"/>
             </a:solidFill>
             <a:prstDash val="dash"/>
           </a:ln>
@@ -15778,7 +15778,7 @@
             <a:r>
               <a:rPr lang="en-US" sz="1000" b="1" dirty="0">
                 <a:solidFill>
-                  <a:srgbClr val="1A1A1A"/>
+                  <a:srgbClr val="7B2400"/>
                 </a:solidFill>
                 <a:latin typeface="Arial" pitchFamily="34" charset="0"/>
                 <a:ea typeface="Arial" pitchFamily="34" charset="-122"/>
@@ -17404,7 +17404,7 @@
             <a:avLst/>
           </a:prstGeom>
           <a:solidFill>
-            <a:srgbClr val="1A1A1A"/>
+            <a:srgbClr val="7B2400"/>
           </a:solidFill>
           <a:ln w="6350">
             <a:solidFill>

</xml_diff>